<commit_message>
V6 validation slides -> n=5 mean; add auto-preload feature slide
- Slides 148 (journal verdict), 155 (single common offset factor), 156
  (add:north retention) switched from pilot V6a to the n=5 mean
  (UTS 46.2 / sy 45.0 / E 2.60). Fixes the E-retention 84%->91% mismatch
  and drops the bogus "coherent k~1.2 on strength AND stiffness" V6a artifact
  (batch = strength k1.26/80%, stiffness k1.10/91%).
- Regenerated v6a_offset_window.png (E[1.15,2.12]/sy[0.67,1.11]/UTS[0.69,1.30],
  strength window [0.69,1.11]) and v6a_epla_offset.png (k 1.26/1.10/1.43).
- New slide 162: UTM auto-preload feature (recreated UI control + load-scheduled
  speed profile from preload_schedule.py + how-it-works + safety). Deck = 22
  slides (pp.141-162).

Co-Authored-By: Claude Opus 4.8 <noreply@anthropic.com>
</commit_message>
<xml_diff>
--- a/V6a_8_6_20_slides.pptx
+++ b/V6a_8_6_20_slides.pptx
@@ -26,6 +26,7 @@
     <p:sldId id="274" r:id="rId25"/>
     <p:sldId id="275" r:id="rId26"/>
     <p:sldId id="276" r:id="rId27"/>
+    <p:sldId id="277" r:id="rId28"/>
   </p:sldIdLst>
   <p:sldSz cx="12191695" cy="6858000" type="screen4x3"/>
   <p:notesSz cx="6858000" cy="9144000"/>
@@ -7598,7 +7599,7 @@
                 </a:solidFill>
                 <a:latin typeface="Calibri Light"/>
               </a:rPr>
-              <a:t>V6a: A SINGLE COMMON OFFSET FACTOR?</a:t>
+              <a:t>V6 (n = 5): A SINGLE COMMON OFFSET FACTOR?</a:t>
             </a:r>
           </a:p>
         </p:txBody>
@@ -7657,7 +7658,7 @@
                 </a:solidFill>
                 <a:latin typeface="Calibri"/>
               </a:rPr>
-              <a:t>Same interval method as V5</a:t>
+              <a:t>Same interval method as V5 · from n = 5 mean</a:t>
             </a:r>
           </a:p>
         </p:txBody>
@@ -7765,7 +7766,7 @@
                           </a:solidFill>
                           <a:latin typeface="Calibri"/>
                         </a:rPr>
-                        <a:t>[1.24, 2.28]</a:t>
+                        <a:t>[1.15, 2.12]</a:t>
                       </a:r>
                     </a:p>
                   </a:txBody>
@@ -7805,7 +7806,7 @@
                           </a:solidFill>
                           <a:latin typeface="Calibri"/>
                         </a:rPr>
-                        <a:t>[0.63, 1.05]</a:t>
+                        <a:t>[0.67, 1.11]</a:t>
                       </a:r>
                     </a:p>
                   </a:txBody>
@@ -7845,7 +7846,7 @@
                           </a:solidFill>
                           <a:latin typeface="Calibri"/>
                         </a:rPr>
-                        <a:t>[0.67, 1.25]</a:t>
+                        <a:t>[0.69, 1.30]</a:t>
                       </a:r>
                     </a:p>
                   </a:txBody>
@@ -7937,7 +7938,7 @@
                           </a:solidFill>
                           <a:latin typeface="Calibri"/>
                         </a:rPr>
-                        <a:t>[0.67, 1.05]</a:t>
+                        <a:t>[0.69, 1.11]</a:t>
                       </a:r>
                     </a:p>
                   </a:txBody>
@@ -8034,7 +8035,7 @@
                 </a:solidFill>
                 <a:latin typeface="Calibri"/>
               </a:rPr>
-              <a:t>STRENGTH: a single uniform factor works — k ∈ [0.67, 1.05] and k = 1 sits inside it ⇒ apply k = 1.0 (no knock-down) to σ_y and UTS at 100 % infill.</a:t>
+              <a:t>STRENGTH: a single uniform factor works — k ∈ [0.69, 1.11] and k = 1 sits inside it ⇒ apply k = 1.0 (no knock-down) to σ_y and UTS at 100 % infill.</a:t>
             </a:r>
           </a:p>
         </p:txBody>
@@ -8086,7 +8087,7 @@
                 </a:solidFill>
                 <a:latin typeface="Calibri"/>
               </a:rPr>
-              <a:t>No single ALL-property k: E reads low (needs ≥1.24 — rig-compliance-limited) while in-range σ_y caps k ≤ 1.05 → they pull opposite ways. Treat E separately.   (Contrast V5: a common k ≈ 2.4 existed.)</a:t>
+              <a:t>No single ALL-property k: E reads ~13 % low (needs k ≥ 1.15) while in-range σ_y caps k ≤ 1.11 → they pull opposite ways, but only by 0.04. Treat E separately.   (Contrast V5: a common k ≈ 2.4 existed.)</a:t>
             </a:r>
           </a:p>
         </p:txBody>
@@ -8252,7 +8253,7 @@
                 </a:solidFill>
                 <a:latin typeface="Calibri Light"/>
               </a:rPr>
-              <a:t>PHASE 8.6.20 V6a: VALIDATION — add:north PLA REFERENCE</a:t>
+              <a:t>PHASE 8.6.20 V6 (n = 5): VALIDATION — add:north PLA REFERENCE</a:t>
             </a:r>
           </a:p>
         </p:txBody>
@@ -8287,7 +8288,7 @@
                 </a:solidFill>
                 <a:latin typeface="Calibri"/>
               </a:rPr>
-              <a:t>add:north E-PLA datasheet (ISO 527 / 178) vs measured — k = spec / measured</a:t>
+              <a:t>add:north E-PLA datasheet (ISO 527 / 178) vs measured n = 5 mean — k = spec / measured</a:t>
             </a:r>
           </a:p>
         </p:txBody>
@@ -8401,7 +8402,7 @@
                           </a:solidFill>
                           <a:latin typeface="Calibri"/>
                         </a:rPr>
-                        <a:t>V6a 100 %</a:t>
+                        <a:t>V6 (n=5)</a:t>
                       </a:r>
                     </a:p>
                   </a:txBody>
@@ -8541,7 +8542,7 @@
                           </a:solidFill>
                           <a:latin typeface="Calibri"/>
                         </a:rPr>
-                        <a:t>47.8 MPa</a:t>
+                        <a:t>45.0 MPa</a:t>
                       </a:r>
                     </a:p>
                   </a:txBody>
@@ -8564,7 +8565,7 @@
                           </a:solidFill>
                           <a:latin typeface="Calibri"/>
                         </a:rPr>
-                        <a:t>1.21</a:t>
+                        <a:t>1.29</a:t>
                       </a:r>
                     </a:p>
                   </a:txBody>
@@ -8587,7 +8588,7 @@
                           </a:solidFill>
                           <a:latin typeface="Calibri"/>
                         </a:rPr>
-                        <a:t>82 %</a:t>
+                        <a:t>78 %</a:t>
                       </a:r>
                     </a:p>
                   </a:txBody>
@@ -8681,7 +8682,7 @@
                           </a:solidFill>
                           <a:latin typeface="Calibri"/>
                         </a:rPr>
-                        <a:t>47.8 MPa</a:t>
+                        <a:t>46.2 MPa</a:t>
                       </a:r>
                     </a:p>
                   </a:txBody>
@@ -8704,7 +8705,7 @@
                           </a:solidFill>
                           <a:latin typeface="Calibri"/>
                         </a:rPr>
-                        <a:t>1.21</a:t>
+                        <a:t>1.26</a:t>
                       </a:r>
                     </a:p>
                   </a:txBody>
@@ -8727,7 +8728,7 @@
                           </a:solidFill>
                           <a:latin typeface="Calibri"/>
                         </a:rPr>
-                        <a:t>82 %</a:t>
+                        <a:t>80 %</a:t>
                       </a:r>
                     </a:p>
                   </a:txBody>
@@ -8821,7 +8822,7 @@
                           </a:solidFill>
                           <a:latin typeface="Calibri"/>
                         </a:rPr>
-                        <a:t>2.41 GPa</a:t>
+                        <a:t>2.60 GPa</a:t>
                       </a:r>
                     </a:p>
                   </a:txBody>
@@ -8844,7 +8845,7 @@
                           </a:solidFill>
                           <a:latin typeface="Calibri"/>
                         </a:rPr>
-                        <a:t>1.19</a:t>
+                        <a:t>1.10</a:t>
                       </a:r>
                     </a:p>
                   </a:txBody>
@@ -8867,7 +8868,7 @@
                           </a:solidFill>
                           <a:latin typeface="Calibri"/>
                         </a:rPr>
-                        <a:t>84 %</a:t>
+                        <a:t>91 %</a:t>
                       </a:r>
                     </a:p>
                   </a:txBody>
@@ -8961,7 +8962,7 @@
                           </a:solidFill>
                           <a:latin typeface="Calibri"/>
                         </a:rPr>
-                        <a:t>3.0 %</a:t>
+                        <a:t>3–7 %</a:t>
                       </a:r>
                     </a:p>
                   </a:txBody>
@@ -8984,7 +8985,7 @@
                           </a:solidFill>
                           <a:latin typeface="Calibri"/>
                         </a:rPr>
-                        <a:t>2.68</a:t>
+                        <a:t>1.1–2.7</a:t>
                       </a:r>
                     </a:p>
                   </a:txBody>
@@ -9007,7 +9008,7 @@
                           </a:solidFill>
                           <a:latin typeface="Calibri"/>
                         </a:rPr>
-                        <a:t>37 %</a:t>
+                        <a:t>37–93 %</a:t>
                       </a:r>
                     </a:p>
                   </a:txBody>
@@ -9379,8 +9380,8 @@
                 <a:latin typeface="Calibri"/>
               </a:rPr>
               <a:t>Validated against TWO references:
-• Journal (Chacón 2017): V6a σ_y &amp; UTS land INSIDE the range (pass); modulus just below floor.
-• add:north E-PLA datasheet: σ_y, UTS and E share ONE factor k ≈ 1.20 → printed 100 % ≈ 83 % of solid-rated. Coherent and actionable.</a:t>
+• Journal (Chacón 2017): σ_y &amp; UTS land INSIDE the range (pass); modulus just below floor.
+• add:north E-PLA datasheet: strength ≈ 80 % of rated (k ≈ 1.26); stiffness ≈ 91 % (k ≈ 1.10, near spec) — E is CLOSER to spec than strength, so NOT one common factor. Repeatable at CV 2.5 % (n = 5).</a:t>
             </a:r>
           </a:p>
         </p:txBody>
@@ -9432,7 +9433,7 @@
                 </a:solidFill>
                 <a:latin typeface="Calibri"/>
               </a:rPr>
-              <a:t>Closest match = add:north E-PLA datasheet: one coherent FFF knock-down k ≈ 1.2 on strength &amp; stiffness. Predict printed strength ≈ spec ÷ 1.2.</a:t>
+              <a:t>Closest match = add:north E-PLA datasheet: strength k ≈ 1.26 (80 % of rated), stiffness k ≈ 1.10 (91 %, near spec). Predict printed strength ≈ spec ÷ 1.25.</a:t>
             </a:r>
           </a:p>
         </p:txBody>
@@ -9467,7 +9468,7 @@
                 </a:solidFill>
                 <a:latin typeface="Calibri"/>
               </a:rPr>
-              <a:t>Pilot V6a values (batch edge); representative n = 5 offset on p. 160. † E-PLA reports one tensile strength (at break), PLA σ_y ≈ UTS → both vs 58 MPa. E-PLA = closest add:north PLA; ISO 527 moulded vs printed.</a:t>
+              <a:t>† E-PLA reports one tensile strength (at break), PLA σ_y ≈ UTS → both vs 58 MPa. E-PLA = closest add:north PLA (no PLA Economy TDS); ISO 527 moulded vs printed 80 mm² bar; values = n = 5 mean.</a:t>
             </a:r>
           </a:p>
         </p:txBody>
@@ -15384,6 +15385,589 @@
 </p:sld>
 </file>
 
+<file path=ppt/slides/slide22.xml><?xml version="1.0" encoding="utf-8"?>
+<p:sld xmlns:a="http://schemas.openxmlformats.org/drawingml/2006/main" xmlns:p="http://schemas.openxmlformats.org/presentationml/2006/main" xmlns:r="http://schemas.openxmlformats.org/officeDocument/2006/relationships">
+  <p:cSld>
+    <p:spTree>
+      <p:nvGrpSpPr>
+        <p:cNvPr id="1" name=""/>
+        <p:cNvGrpSpPr/>
+        <p:nvPr/>
+      </p:nvGrpSpPr>
+      <p:grpSpPr/>
+      <p:sp>
+        <p:nvSpPr>
+          <p:cNvPr id="2" name="TextBox 1"/>
+          <p:cNvSpPr txBox="1"/>
+          <p:nvPr/>
+        </p:nvSpPr>
+        <p:spPr>
+          <a:xfrm>
+            <a:off x="11155680" y="274320"/>
+            <a:ext cx="914400" cy="274320"/>
+          </a:xfrm>
+          <a:prstGeom prst="rect">
+            <a:avLst/>
+          </a:prstGeom>
+          <a:noFill/>
+        </p:spPr>
+        <p:txBody>
+          <a:bodyPr wrap="square" lIns="45720" rIns="45720" tIns="18288" bIns="18288" anchor="t">
+            <a:spAutoFit/>
+          </a:bodyPr>
+          <a:lstStyle/>
+          <a:p>
+            <a:pPr algn="r"/>
+            <a:r>
+              <a:rPr sz="800" b="1" i="0">
+                <a:solidFill>
+                  <a:srgbClr val="707070"/>
+                </a:solidFill>
+                <a:latin typeface="Calibri"/>
+              </a:rPr>
+              <a:t>JÖNKÖPING UNIVERSITY</a:t>
+            </a:r>
+          </a:p>
+        </p:txBody>
+      </p:sp>
+      <p:sp>
+        <p:nvSpPr>
+          <p:cNvPr id="3" name="Rectangle 2"/>
+          <p:cNvSpPr/>
+          <p:nvPr/>
+        </p:nvSpPr>
+        <p:spPr>
+          <a:xfrm>
+            <a:off x="457200" y="411480"/>
+            <a:ext cx="457200" cy="73152"/>
+          </a:xfrm>
+          <a:prstGeom prst="rect">
+            <a:avLst/>
+          </a:prstGeom>
+          <a:solidFill>
+            <a:srgbClr val="A9D6EF"/>
+          </a:solidFill>
+          <a:ln>
+            <a:noFill/>
+          </a:ln>
+        </p:spPr>
+        <p:style>
+          <a:lnRef idx="1">
+            <a:schemeClr val="accent1"/>
+          </a:lnRef>
+          <a:fillRef idx="3">
+            <a:schemeClr val="accent1"/>
+          </a:fillRef>
+          <a:effectRef idx="2">
+            <a:schemeClr val="accent1"/>
+          </a:effectRef>
+          <a:fontRef idx="minor">
+            <a:schemeClr val="lt1"/>
+          </a:fontRef>
+        </p:style>
+        <p:txBody>
+          <a:bodyPr rtlCol="0" anchor="ctr"/>
+          <a:lstStyle/>
+          <a:p>
+            <a:pPr algn="ctr"/>
+          </a:p>
+        </p:txBody>
+      </p:sp>
+      <p:sp>
+        <p:nvSpPr>
+          <p:cNvPr id="4" name="TextBox 3"/>
+          <p:cNvSpPr txBox="1"/>
+          <p:nvPr/>
+        </p:nvSpPr>
+        <p:spPr>
+          <a:xfrm>
+            <a:off x="457200" y="502920"/>
+            <a:ext cx="11430000" cy="822960"/>
+          </a:xfrm>
+          <a:prstGeom prst="rect">
+            <a:avLst/>
+          </a:prstGeom>
+          <a:noFill/>
+        </p:spPr>
+        <p:txBody>
+          <a:bodyPr wrap="square" lIns="45720" rIns="45720" tIns="18288" bIns="18288" anchor="t">
+            <a:spAutoFit/>
+          </a:bodyPr>
+          <a:lstStyle/>
+          <a:p>
+            <a:pPr algn="l"/>
+            <a:r>
+              <a:rPr sz="3000" b="0" i="0">
+                <a:solidFill>
+                  <a:srgbClr val="000000"/>
+                </a:solidFill>
+                <a:latin typeface="Calibri Light"/>
+              </a:rPr>
+              <a:t>UTM SOFTWARE: AUTOMATIC PRELOAD (‘PRELOAD TENSION’)</a:t>
+            </a:r>
+          </a:p>
+        </p:txBody>
+      </p:sp>
+      <p:sp>
+        <p:nvSpPr>
+          <p:cNvPr id="5" name="TextBox 4"/>
+          <p:cNvSpPr txBox="1"/>
+          <p:nvPr/>
+        </p:nvSpPr>
+        <p:spPr>
+          <a:xfrm>
+            <a:off x="457200" y="1490472"/>
+            <a:ext cx="1097280" cy="320040"/>
+          </a:xfrm>
+          <a:prstGeom prst="rect">
+            <a:avLst/>
+          </a:prstGeom>
+          <a:noFill/>
+        </p:spPr>
+        <p:txBody>
+          <a:bodyPr wrap="square" lIns="45720" rIns="45720" tIns="18288" bIns="18288" anchor="t">
+            <a:spAutoFit/>
+          </a:bodyPr>
+          <a:lstStyle/>
+          <a:p>
+            <a:pPr algn="l"/>
+            <a:r>
+              <a:rPr sz="1400" b="0" i="0">
+                <a:solidFill>
+                  <a:srgbClr val="000000"/>
+                </a:solidFill>
+                <a:latin typeface="Calibri"/>
+              </a:rPr>
+              <a:t>Preload to:</a:t>
+            </a:r>
+          </a:p>
+        </p:txBody>
+      </p:sp>
+      <p:sp>
+        <p:nvSpPr>
+          <p:cNvPr id="6" name="Rounded Rectangle 5"/>
+          <p:cNvSpPr/>
+          <p:nvPr/>
+        </p:nvSpPr>
+        <p:spPr>
+          <a:xfrm>
+            <a:off x="1572768" y="1444752"/>
+            <a:ext cx="960120" cy="384048"/>
+          </a:xfrm>
+          <a:prstGeom prst="roundRect">
+            <a:avLst/>
+          </a:prstGeom>
+          <a:solidFill>
+            <a:srgbClr val="FFFFFF"/>
+          </a:solidFill>
+          <a:ln w="15240">
+            <a:solidFill>
+              <a:srgbClr val="A6A6A6"/>
+            </a:solidFill>
+          </a:ln>
+        </p:spPr>
+        <p:style>
+          <a:lnRef idx="1">
+            <a:schemeClr val="accent1"/>
+          </a:lnRef>
+          <a:fillRef idx="3">
+            <a:schemeClr val="accent1"/>
+          </a:fillRef>
+          <a:effectRef idx="2">
+            <a:schemeClr val="accent1"/>
+          </a:effectRef>
+          <a:fontRef idx="minor">
+            <a:schemeClr val="lt1"/>
+          </a:fontRef>
+        </p:style>
+        <p:txBody>
+          <a:bodyPr rtlCol="0" anchor="ctr" lIns="54864" rIns="54864" tIns="27432" bIns="27432" wrap="square"/>
+          <a:lstStyle/>
+          <a:p>
+            <a:pPr algn="ctr"/>
+            <a:r>
+              <a:rPr sz="1300" b="0">
+                <a:solidFill>
+                  <a:srgbClr val="000000"/>
+                </a:solidFill>
+                <a:latin typeface="Calibri"/>
+              </a:rPr>
+              <a:t>470 N</a:t>
+            </a:r>
+          </a:p>
+        </p:txBody>
+      </p:sp>
+      <p:sp>
+        <p:nvSpPr>
+          <p:cNvPr id="7" name="Rounded Rectangle 6"/>
+          <p:cNvSpPr/>
+          <p:nvPr/>
+        </p:nvSpPr>
+        <p:spPr>
+          <a:xfrm>
+            <a:off x="2551176" y="1444752"/>
+            <a:ext cx="292608" cy="384048"/>
+          </a:xfrm>
+          <a:prstGeom prst="roundRect">
+            <a:avLst/>
+          </a:prstGeom>
+          <a:solidFill>
+            <a:srgbClr val="F2F2F2"/>
+          </a:solidFill>
+          <a:ln w="15240">
+            <a:solidFill>
+              <a:srgbClr val="A6A6A6"/>
+            </a:solidFill>
+          </a:ln>
+        </p:spPr>
+        <p:style>
+          <a:lnRef idx="1">
+            <a:schemeClr val="accent1"/>
+          </a:lnRef>
+          <a:fillRef idx="3">
+            <a:schemeClr val="accent1"/>
+          </a:fillRef>
+          <a:effectRef idx="2">
+            <a:schemeClr val="accent1"/>
+          </a:effectRef>
+          <a:fontRef idx="minor">
+            <a:schemeClr val="lt1"/>
+          </a:fontRef>
+        </p:style>
+        <p:txBody>
+          <a:bodyPr rtlCol="0" anchor="ctr" lIns="54864" rIns="54864" tIns="27432" bIns="27432" wrap="square"/>
+          <a:lstStyle/>
+          <a:p>
+            <a:pPr algn="ctr"/>
+            <a:r>
+              <a:rPr sz="800" b="0">
+                <a:solidFill>
+                  <a:srgbClr val="707070"/>
+                </a:solidFill>
+                <a:latin typeface="Calibri"/>
+              </a:rPr>
+              <a:t>▴
+▾</a:t>
+            </a:r>
+          </a:p>
+        </p:txBody>
+      </p:sp>
+      <p:sp>
+        <p:nvSpPr>
+          <p:cNvPr id="8" name="Rounded Rectangle 7"/>
+          <p:cNvSpPr/>
+          <p:nvPr/>
+        </p:nvSpPr>
+        <p:spPr>
+          <a:xfrm>
+            <a:off x="2990088" y="1444752"/>
+            <a:ext cx="1600200" cy="384048"/>
+          </a:xfrm>
+          <a:prstGeom prst="roundRect">
+            <a:avLst/>
+          </a:prstGeom>
+          <a:solidFill>
+            <a:srgbClr val="ECECEC"/>
+          </a:solidFill>
+          <a:ln w="15240">
+            <a:solidFill>
+              <a:srgbClr val="A6A6A6"/>
+            </a:solidFill>
+          </a:ln>
+        </p:spPr>
+        <p:style>
+          <a:lnRef idx="1">
+            <a:schemeClr val="accent1"/>
+          </a:lnRef>
+          <a:fillRef idx="3">
+            <a:schemeClr val="accent1"/>
+          </a:fillRef>
+          <a:effectRef idx="2">
+            <a:schemeClr val="accent1"/>
+          </a:effectRef>
+          <a:fontRef idx="minor">
+            <a:schemeClr val="lt1"/>
+          </a:fontRef>
+        </p:style>
+        <p:txBody>
+          <a:bodyPr rtlCol="0" anchor="ctr" lIns="54864" rIns="54864" tIns="27432" bIns="27432" wrap="square"/>
+          <a:lstStyle/>
+          <a:p>
+            <a:pPr algn="ctr"/>
+            <a:r>
+              <a:rPr sz="1200" b="0">
+                <a:solidFill>
+                  <a:srgbClr val="555555"/>
+                </a:solidFill>
+                <a:latin typeface="Calibri"/>
+              </a:rPr>
+              <a:t>Preload tension</a:t>
+            </a:r>
+          </a:p>
+        </p:txBody>
+      </p:sp>
+      <p:sp>
+        <p:nvSpPr>
+          <p:cNvPr id="9" name="TextBox 8"/>
+          <p:cNvSpPr txBox="1"/>
+          <p:nvPr/>
+        </p:nvSpPr>
+        <p:spPr>
+          <a:xfrm>
+            <a:off x="457200" y="1938528"/>
+            <a:ext cx="4572000" cy="457200"/>
+          </a:xfrm>
+          <a:prstGeom prst="rect">
+            <a:avLst/>
+          </a:prstGeom>
+          <a:noFill/>
+        </p:spPr>
+        <p:txBody>
+          <a:bodyPr wrap="square" lIns="45720" rIns="45720" tIns="18288" bIns="18288" anchor="t">
+            <a:spAutoFit/>
+          </a:bodyPr>
+          <a:lstStyle/>
+          <a:p>
+            <a:pPr algn="l"/>
+            <a:r>
+              <a:rPr sz="1050" b="0" i="1">
+                <a:solidFill>
+                  <a:srgbClr val="707070"/>
+                </a:solidFill>
+                <a:latin typeface="Calibri"/>
+              </a:rPr>
+              <a:t>The operator control (screen recreation): type a target load, click once — the crosshead auto-tensions to it, hands-off.</a:t>
+            </a:r>
+          </a:p>
+        </p:txBody>
+      </p:sp>
+      <p:sp>
+        <p:nvSpPr>
+          <p:cNvPr id="10" name="TextBox 9"/>
+          <p:cNvSpPr txBox="1"/>
+          <p:nvPr/>
+        </p:nvSpPr>
+        <p:spPr>
+          <a:xfrm>
+            <a:off x="457200" y="2514600"/>
+            <a:ext cx="5486400" cy="365760"/>
+          </a:xfrm>
+          <a:prstGeom prst="rect">
+            <a:avLst/>
+          </a:prstGeom>
+          <a:noFill/>
+        </p:spPr>
+        <p:txBody>
+          <a:bodyPr wrap="square" lIns="45720" rIns="45720" tIns="18288" bIns="18288" anchor="t">
+            <a:spAutoFit/>
+          </a:bodyPr>
+          <a:lstStyle/>
+          <a:p>
+            <a:pPr algn="l"/>
+            <a:r>
+              <a:rPr sz="1600" b="0" i="0">
+                <a:solidFill>
+                  <a:srgbClr val="707070"/>
+                </a:solidFill>
+                <a:latin typeface="Calibri"/>
+              </a:rPr>
+              <a:t>How it works — one click, hands-off</a:t>
+            </a:r>
+          </a:p>
+        </p:txBody>
+      </p:sp>
+      <p:sp>
+        <p:nvSpPr>
+          <p:cNvPr id="11" name="TextBox 10"/>
+          <p:cNvSpPr txBox="1"/>
+          <p:nvPr/>
+        </p:nvSpPr>
+        <p:spPr>
+          <a:xfrm>
+            <a:off x="457200" y="2880360"/>
+            <a:ext cx="5577840" cy="2743200"/>
+          </a:xfrm>
+          <a:prstGeom prst="rect">
+            <a:avLst/>
+          </a:prstGeom>
+          <a:noFill/>
+        </p:spPr>
+        <p:txBody>
+          <a:bodyPr wrap="square" lIns="45720" rIns="45720" tIns="18288" bIns="18288" anchor="t">
+            <a:spAutoFit/>
+          </a:bodyPr>
+          <a:lstStyle/>
+          <a:p>
+            <a:pPr algn="l"/>
+            <a:r>
+              <a:rPr sz="1200" b="0" i="0">
+                <a:solidFill>
+                  <a:srgbClr val="000000"/>
+                </a:solidFill>
+                <a:latin typeface="Calibri"/>
+              </a:rPr>
+              <a:t>1.  Enter the target preload (e.g. 470 N) and press Preload tension.
+2.  The crosshead tensions at a LOAD-scheduled speed: 0.20 mm/s up to ~15 % of target, 0.10 mm/s to 50 %, then ramps to a gentle 0.02 mm/s as it nears the target.
+3.  It stops at 1.03× the target — a deliberate ~3 % overshoot.
+4.  PLA stress-relaxes ~2 % while held → the load settles AT / just above the target.</a:t>
+            </a:r>
+          </a:p>
+        </p:txBody>
+      </p:sp>
+      <p:pic>
+        <p:nvPicPr>
+          <p:cNvPr id="12" name="Picture 11" descr="preload_schedule.png"/>
+          <p:cNvPicPr>
+            <a:picLocks noChangeAspect="1"/>
+          </p:cNvPicPr>
+          <p:nvPr/>
+        </p:nvPicPr>
+        <p:blipFill>
+          <a:blip r:embed="rId2"/>
+          <a:stretch>
+            <a:fillRect/>
+          </a:stretch>
+        </p:blipFill>
+        <p:spPr>
+          <a:xfrm>
+            <a:off x="6172200" y="1508760"/>
+            <a:ext cx="5669280" cy="3556891"/>
+          </a:xfrm>
+          <a:prstGeom prst="rect">
+            <a:avLst/>
+          </a:prstGeom>
+        </p:spPr>
+      </p:pic>
+      <p:sp>
+        <p:nvSpPr>
+          <p:cNvPr id="13" name="Rectangle 12"/>
+          <p:cNvSpPr/>
+          <p:nvPr/>
+        </p:nvSpPr>
+        <p:spPr>
+          <a:xfrm>
+            <a:off x="365760" y="5715000"/>
+            <a:ext cx="11430000" cy="658368"/>
+          </a:xfrm>
+          <a:prstGeom prst="rect">
+            <a:avLst/>
+          </a:prstGeom>
+          <a:solidFill>
+            <a:srgbClr val="E7F1F8"/>
+          </a:solidFill>
+          <a:ln>
+            <a:noFill/>
+          </a:ln>
+        </p:spPr>
+        <p:style>
+          <a:lnRef idx="1">
+            <a:schemeClr val="accent1"/>
+          </a:lnRef>
+          <a:fillRef idx="3">
+            <a:schemeClr val="accent1"/>
+          </a:fillRef>
+          <a:effectRef idx="2">
+            <a:schemeClr val="accent1"/>
+          </a:effectRef>
+          <a:fontRef idx="minor">
+            <a:schemeClr val="lt1"/>
+          </a:fontRef>
+        </p:style>
+        <p:txBody>
+          <a:bodyPr rtlCol="0" anchor="ctr" wrap="square" lIns="109728" rIns="109728"/>
+          <a:lstStyle/>
+          <a:p>
+            <a:pPr algn="ctr"/>
+            <a:r>
+              <a:rPr sz="1150" b="1">
+                <a:solidFill>
+                  <a:srgbClr val="000000"/>
+                </a:solidFill>
+                <a:latin typeface="Calibri"/>
+              </a:rPr>
+              <a:t>Why: manual jogging is slow and overshoots, and PLA relaxes after you stop (you would undershoot). Auto-preload lands consistently at target (+3 % set − ~2 % relaxation ≈ target). Safety: hard cap 1.25× target, 180 s timeout, live speed-only control (no Stop→restart re-latch).</a:t>
+            </a:r>
+          </a:p>
+        </p:txBody>
+      </p:sp>
+      <p:sp>
+        <p:nvSpPr>
+          <p:cNvPr id="14" name="TextBox 13"/>
+          <p:cNvSpPr txBox="1"/>
+          <p:nvPr/>
+        </p:nvSpPr>
+        <p:spPr>
+          <a:xfrm>
+            <a:off x="548640" y="6400800"/>
+            <a:ext cx="11064240" cy="365760"/>
+          </a:xfrm>
+          <a:prstGeom prst="rect">
+            <a:avLst/>
+          </a:prstGeom>
+          <a:noFill/>
+        </p:spPr>
+        <p:txBody>
+          <a:bodyPr wrap="square" lIns="45720" rIns="45720" tIns="18288" bIns="18288" anchor="t">
+            <a:spAutoFit/>
+          </a:bodyPr>
+          <a:lstStyle/>
+          <a:p>
+            <a:pPr algn="l"/>
+            <a:r>
+              <a:rPr sz="1200" b="0" i="1">
+                <a:solidFill>
+                  <a:srgbClr val="707070"/>
+                </a:solidFill>
+                <a:latin typeface="Calibri"/>
+              </a:rPr>
+              <a:t>Feature in Software/UTM_PyQt6/main.py — PRELOAD_SPEED_KNOTS · TARGET_FACTOR 1.03 · OVERSHOOT_CAP 1.25 · TIMEOUT 180 s. Used to set the ~470 N preload before every V5 / V6 pull.</a:t>
+            </a:r>
+          </a:p>
+        </p:txBody>
+      </p:sp>
+      <p:sp>
+        <p:nvSpPr>
+          <p:cNvPr id="15" name="TextBox 14"/>
+          <p:cNvSpPr txBox="1"/>
+          <p:nvPr/>
+        </p:nvSpPr>
+        <p:spPr>
+          <a:xfrm>
+            <a:off x="457200" y="6446520"/>
+            <a:ext cx="640080" cy="274320"/>
+          </a:xfrm>
+          <a:prstGeom prst="rect">
+            <a:avLst/>
+          </a:prstGeom>
+          <a:noFill/>
+        </p:spPr>
+        <p:txBody>
+          <a:bodyPr wrap="square" lIns="45720" rIns="45720" tIns="18288" bIns="18288" anchor="t">
+            <a:spAutoFit/>
+          </a:bodyPr>
+          <a:lstStyle/>
+          <a:p>
+            <a:pPr algn="l"/>
+            <a:r>
+              <a:rPr sz="1000" b="0" i="0">
+                <a:solidFill>
+                  <a:srgbClr val="707070"/>
+                </a:solidFill>
+                <a:latin typeface="Calibri"/>
+              </a:rPr>
+              <a:t>162</a:t>
+            </a:r>
+          </a:p>
+        </p:txBody>
+      </p:sp>
+    </p:spTree>
+  </p:cSld>
+  <p:clrMapOvr>
+    <a:masterClrMapping/>
+  </p:clrMapOvr>
+</p:sld>
+</file>
+
 <file path=ppt/slides/slide3.xml><?xml version="1.0" encoding="utf-8"?>
 <p:sld xmlns:a="http://schemas.openxmlformats.org/drawingml/2006/main" xmlns:p="http://schemas.openxmlformats.org/presentationml/2006/main" xmlns:r="http://schemas.openxmlformats.org/officeDocument/2006/relationships">
   <p:cSld>
@@ -16627,7 +17211,7 @@
                 </a:solidFill>
                 <a:latin typeface="Calibri Light"/>
               </a:rPr>
-              <a:t>PHASE 8.6.20 V6a: VALIDATION — JOURNAL REFERENCE</a:t>
+              <a:t>PHASE 8.6.20 V6 (n = 5): VALIDATION — JOURNAL REFERENCE</a:t>
             </a:r>
           </a:p>
         </p:txBody>
@@ -16662,7 +17246,7 @@
                 </a:solidFill>
                 <a:latin typeface="Calibri"/>
               </a:rPr>
-              <a:t>Chacón (2017) journal — measured vs range, offset k = Chacón_min / measured</a:t>
+              <a:t>Chacón (2017) journal — n = 5 mean vs range, offset k = Chacón_min / measured</a:t>
             </a:r>
           </a:p>
         </p:txBody>
@@ -16752,7 +17336,7 @@
                           </a:solidFill>
                           <a:latin typeface="Calibri"/>
                         </a:rPr>
-                        <a:t>V6a k</a:t>
+                        <a:t>V6 k</a:t>
                       </a:r>
                     </a:p>
                   </a:txBody>
@@ -16775,7 +17359,7 @@
                           </a:solidFill>
                           <a:latin typeface="Calibri"/>
                         </a:rPr>
-                        <a:t>V6a measured</a:t>
+                        <a:t>V6 mean (n=5)</a:t>
                       </a:r>
                     </a:p>
                   </a:txBody>
@@ -16861,7 +17445,7 @@
                           </a:solidFill>
                           <a:latin typeface="Calibri"/>
                         </a:rPr>
-                        <a:t>×1.25</a:t>
+                        <a:t>×1.15</a:t>
                       </a:r>
                     </a:p>
                   </a:txBody>
@@ -16880,7 +17464,7 @@
                           </a:solidFill>
                           <a:latin typeface="Calibri"/>
                         </a:rPr>
-                        <a:t>2.41 GPa</a:t>
+                        <a:t>2.60 GPa</a:t>
                       </a:r>
                     </a:p>
                   </a:txBody>
@@ -16962,7 +17546,7 @@
                           </a:solidFill>
                           <a:latin typeface="Calibri"/>
                         </a:rPr>
-                        <a:t>×0.63</a:t>
+                        <a:t>×0.67</a:t>
                       </a:r>
                     </a:p>
                   </a:txBody>
@@ -16981,7 +17565,7 @@
                           </a:solidFill>
                           <a:latin typeface="Calibri"/>
                         </a:rPr>
-                        <a:t>47.8 MPa</a:t>
+                        <a:t>45.0 MPa</a:t>
                       </a:r>
                     </a:p>
                   </a:txBody>
@@ -17063,7 +17647,7 @@
                           </a:solidFill>
                           <a:latin typeface="Calibri"/>
                         </a:rPr>
-                        <a:t>×0.67</a:t>
+                        <a:t>×0.69</a:t>
                       </a:r>
                     </a:p>
                   </a:txBody>
@@ -17082,7 +17666,7 @@
                           </a:solidFill>
                           <a:latin typeface="Calibri"/>
                         </a:rPr>
-                        <a:t>47.8 MPa</a:t>
+                        <a:t>46.2 MPa</a:t>
                       </a:r>
                     </a:p>
                   </a:txBody>
@@ -17147,7 +17731,7 @@
                 <a:latin typeface="Calibri"/>
               </a:rPr>
               <a:t>Green = measured value lands INSIDE the Chacón range; yellow = just below.
-At 100 % infill the strength values land in literature directly: UTS 47.8 MPa and σ_y 47.8 MPa sit mid-range (k = 0.63–0.67 &lt; 1 ⇒ no knock-down needed). E (2.41 GPa, ×1.25) is just shy of the 3.0 GPa floor — held down by the rig-compliance-limited apparent modulus. Common-factor window ≈ [1.05, 1.25] → k ≈ 1.</a:t>
+At 100 % infill the strength values land in literature directly: UTS 46.2 MPa and σ_y 45.0 MPa sit mid-range (k = 0.67–0.69 &lt; 1 ⇒ no knock-down needed). E (2.60 GPa, ×1.15) is ~13 % below the 3.0 GPa floor — held down by the rig-compliance-limited apparent modulus. Strength common-factor window ≈ [0.69, 1.11] → k ≈ 1 (p. 155).</a:t>
             </a:r>
           </a:p>
         </p:txBody>
@@ -17199,7 +17783,7 @@
                 </a:solidFill>
                 <a:latin typeface="Calibri"/>
               </a:rPr>
-              <a:t>2.17×</a:t>
+              <a:t>2.09×</a:t>
             </a:r>
           </a:p>
           <a:p>
@@ -17263,7 +17847,7 @@
                 </a:solidFill>
                 <a:latin typeface="Calibri"/>
               </a:rPr>
-              <a:t>2.83×</a:t>
+              <a:t>5.0×</a:t>
             </a:r>
           </a:p>
           <a:p>
@@ -17327,7 +17911,7 @@
                 </a:solidFill>
                 <a:latin typeface="Calibri"/>
               </a:rPr>
-              <a:t>99.9 %</a:t>
+              <a:t>≥99 %</a:t>
             </a:r>
           </a:p>
           <a:p>
@@ -17507,7 +18091,7 @@
                 </a:solidFill>
                 <a:latin typeface="Calibri"/>
               </a:rPr>
-              <a:t>DIC validated under LED lighting (99.9 % tracking, clean baseline) — lighting is precision-only, as predicted.</a:t>
+              <a:t>DIC validated under LED lighting (clean ≥99 % tracking across all 5, stable baseline) — lighting is precision-only, as predicted.</a:t>
             </a:r>
           </a:p>
         </p:txBody>
@@ -17542,7 +18126,7 @@
                 </a:solidFill>
                 <a:latin typeface="Calibri"/>
               </a:rPr>
-              <a:t>Pilot V6a values (batch strength/modulus edge). Representative n = 5 validation on pp. 158 &amp; 160. Journal ref Chacón (2017); add:north datasheet on p. 156.</a:t>
+              <a:t>n = 5 mean vs Chacón (2017); per-specimen repeatability on p. 157, add:north datasheet on p. 156. Strength inside range (k ≈ 1); E ~13 % below the journal floor.</a:t>
             </a:r>
           </a:p>
         </p:txBody>

</xml_diff>

<commit_message>
Label stress as "Engineering stress" (nominal area) + stress-convention slide
- Relabel stress axes (True/Cauchy -> "Engineering stress") in the V6 deck plots
  (v6a_plots.py) and the V5 scripts (v5_slide_plots, v5abc_compare,
  tensile_failure_analysis, v5_full_analysis). v6_quintet_plots already correct.
  What we compute is F / nominal 80 mm2 = engineering stress, which matches the
  ISO 527 / Chacon / add:north basis used for validation.
- generate_v6a_slides.py: new slide 163 - engineering vs true (Cauchy) stress,
  and how to measure the CURRENT area for future Cauchy stress (transverse
  markers / Poisson / edge camera / full-field DIC). Deck = 23 slides.
- Regenerated the affected V6a plots + rebuilt the deck.

Co-Authored-By: Claude Opus 4.8 <noreply@anthropic.com>
</commit_message>
<xml_diff>
--- a/V6a_8_6_20_slides.pptx
+++ b/V6a_8_6_20_slides.pptx
@@ -27,6 +27,7 @@
     <p:sldId id="275" r:id="rId26"/>
     <p:sldId id="276" r:id="rId27"/>
     <p:sldId id="277" r:id="rId28"/>
+    <p:sldId id="278" r:id="rId29"/>
   </p:sldIdLst>
   <p:sldSz cx="12191695" cy="6858000" type="screen4x3"/>
   <p:notesSz cx="6858000" cy="9144000"/>
@@ -15956,6 +15957,749 @@
                 <a:latin typeface="Calibri"/>
               </a:rPr>
               <a:t>162</a:t>
+            </a:r>
+          </a:p>
+        </p:txBody>
+      </p:sp>
+    </p:spTree>
+  </p:cSld>
+  <p:clrMapOvr>
+    <a:masterClrMapping/>
+  </p:clrMapOvr>
+</p:sld>
+</file>
+
+<file path=ppt/slides/slide23.xml><?xml version="1.0" encoding="utf-8"?>
+<p:sld xmlns:a="http://schemas.openxmlformats.org/drawingml/2006/main" xmlns:p="http://schemas.openxmlformats.org/presentationml/2006/main" xmlns:r="http://schemas.openxmlformats.org/officeDocument/2006/relationships">
+  <p:cSld>
+    <p:spTree>
+      <p:nvGrpSpPr>
+        <p:cNvPr id="1" name=""/>
+        <p:cNvGrpSpPr/>
+        <p:nvPr/>
+      </p:nvGrpSpPr>
+      <p:grpSpPr/>
+      <p:sp>
+        <p:nvSpPr>
+          <p:cNvPr id="2" name="TextBox 1"/>
+          <p:cNvSpPr txBox="1"/>
+          <p:nvPr/>
+        </p:nvSpPr>
+        <p:spPr>
+          <a:xfrm>
+            <a:off x="11155680" y="274320"/>
+            <a:ext cx="914400" cy="274320"/>
+          </a:xfrm>
+          <a:prstGeom prst="rect">
+            <a:avLst/>
+          </a:prstGeom>
+          <a:noFill/>
+        </p:spPr>
+        <p:txBody>
+          <a:bodyPr wrap="square" lIns="45720" rIns="45720" tIns="18288" bIns="18288" anchor="t">
+            <a:spAutoFit/>
+          </a:bodyPr>
+          <a:lstStyle/>
+          <a:p>
+            <a:pPr algn="r"/>
+            <a:r>
+              <a:rPr sz="800" b="1" i="0">
+                <a:solidFill>
+                  <a:srgbClr val="707070"/>
+                </a:solidFill>
+                <a:latin typeface="Calibri"/>
+              </a:rPr>
+              <a:t>JÖNKÖPING UNIVERSITY</a:t>
+            </a:r>
+          </a:p>
+        </p:txBody>
+      </p:sp>
+      <p:sp>
+        <p:nvSpPr>
+          <p:cNvPr id="3" name="Rectangle 2"/>
+          <p:cNvSpPr/>
+          <p:nvPr/>
+        </p:nvSpPr>
+        <p:spPr>
+          <a:xfrm>
+            <a:off x="457200" y="411480"/>
+            <a:ext cx="457200" cy="73152"/>
+          </a:xfrm>
+          <a:prstGeom prst="rect">
+            <a:avLst/>
+          </a:prstGeom>
+          <a:solidFill>
+            <a:srgbClr val="A9D6EF"/>
+          </a:solidFill>
+          <a:ln>
+            <a:noFill/>
+          </a:ln>
+        </p:spPr>
+        <p:style>
+          <a:lnRef idx="1">
+            <a:schemeClr val="accent1"/>
+          </a:lnRef>
+          <a:fillRef idx="3">
+            <a:schemeClr val="accent1"/>
+          </a:fillRef>
+          <a:effectRef idx="2">
+            <a:schemeClr val="accent1"/>
+          </a:effectRef>
+          <a:fontRef idx="minor">
+            <a:schemeClr val="lt1"/>
+          </a:fontRef>
+        </p:style>
+        <p:txBody>
+          <a:bodyPr rtlCol="0" anchor="ctr"/>
+          <a:lstStyle/>
+          <a:p>
+            <a:pPr algn="ctr"/>
+          </a:p>
+        </p:txBody>
+      </p:sp>
+      <p:sp>
+        <p:nvSpPr>
+          <p:cNvPr id="4" name="TextBox 3"/>
+          <p:cNvSpPr txBox="1"/>
+          <p:nvPr/>
+        </p:nvSpPr>
+        <p:spPr>
+          <a:xfrm>
+            <a:off x="457200" y="502920"/>
+            <a:ext cx="11430000" cy="822960"/>
+          </a:xfrm>
+          <a:prstGeom prst="rect">
+            <a:avLst/>
+          </a:prstGeom>
+          <a:noFill/>
+        </p:spPr>
+        <p:txBody>
+          <a:bodyPr wrap="square" lIns="45720" rIns="45720" tIns="18288" bIns="18288" anchor="t">
+            <a:spAutoFit/>
+          </a:bodyPr>
+          <a:lstStyle/>
+          <a:p>
+            <a:pPr algn="l"/>
+            <a:r>
+              <a:rPr sz="3000" b="0" i="0">
+                <a:solidFill>
+                  <a:srgbClr val="000000"/>
+                </a:solidFill>
+                <a:latin typeface="Calibri Light"/>
+              </a:rPr>
+              <a:t>ENGINEERING vs TRUE (CAUCHY) STRESS — &amp; MEASURING THE AREA</a:t>
+            </a:r>
+          </a:p>
+        </p:txBody>
+      </p:sp>
+      <p:sp>
+        <p:nvSpPr>
+          <p:cNvPr id="5" name="TextBox 4"/>
+          <p:cNvSpPr txBox="1"/>
+          <p:nvPr/>
+        </p:nvSpPr>
+        <p:spPr>
+          <a:xfrm>
+            <a:off x="365760" y="1170432"/>
+            <a:ext cx="5577840" cy="365760"/>
+          </a:xfrm>
+          <a:prstGeom prst="rect">
+            <a:avLst/>
+          </a:prstGeom>
+          <a:noFill/>
+        </p:spPr>
+        <p:txBody>
+          <a:bodyPr wrap="square" lIns="45720" rIns="45720" tIns="18288" bIns="18288" anchor="t">
+            <a:spAutoFit/>
+          </a:bodyPr>
+          <a:lstStyle/>
+          <a:p>
+            <a:pPr algn="l"/>
+            <a:r>
+              <a:rPr sz="1600" b="0" i="0">
+                <a:solidFill>
+                  <a:srgbClr val="707070"/>
+                </a:solidFill>
+                <a:latin typeface="Calibri"/>
+              </a:rPr>
+              <a:t>Why the report &amp; plots use ENGINEERING stress</a:t>
+            </a:r>
+          </a:p>
+        </p:txBody>
+      </p:sp>
+      <p:sp>
+        <p:nvSpPr>
+          <p:cNvPr id="6" name="TextBox 5"/>
+          <p:cNvSpPr txBox="1"/>
+          <p:nvPr/>
+        </p:nvSpPr>
+        <p:spPr>
+          <a:xfrm>
+            <a:off x="365760" y="1554480"/>
+            <a:ext cx="5623560" cy="3383280"/>
+          </a:xfrm>
+          <a:prstGeom prst="rect">
+            <a:avLst/>
+          </a:prstGeom>
+          <a:noFill/>
+        </p:spPr>
+        <p:txBody>
+          <a:bodyPr wrap="square" lIns="45720" rIns="45720" tIns="18288" bIns="18288" anchor="t">
+            <a:spAutoFit/>
+          </a:bodyPr>
+          <a:lstStyle/>
+          <a:p>
+            <a:pPr algn="l"/>
+            <a:r>
+              <a:rPr sz="1150" b="0" i="0">
+                <a:solidFill>
+                  <a:srgbClr val="000000"/>
+                </a:solidFill>
+                <a:latin typeface="Calibri"/>
+              </a:rPr>
+              <a:t>σ_eng = F / A₀   (A₀ = 80 mm², fixed) — what we compute &amp; report.
+σ_true (Cauchy) = F / A_current — the real stress on the shrinking cross-section; NOT measured here (the deforming area is never tracked).
+Link (uniform, pre-neck):   σ_true = σ_eng·(1+ε),    ε_true = ln(1+ε).
+WHY engineering: ISO 527, Chacón (2017) and the add:north datasheet all report ENGINEERING stress — so it is the apples-to-apples basis for our k-factors / PASS–FAIL. True stress reads higher and would break that comparison.
+Gap for our PLA (small strains): ~2–3 % higher at UTS (46.2 → ~47 MPa), ~5 % near fracture; E and σ_y essentially unchanged.</a:t>
+            </a:r>
+          </a:p>
+        </p:txBody>
+      </p:sp>
+      <p:sp>
+        <p:nvSpPr>
+          <p:cNvPr id="7" name="TextBox 6"/>
+          <p:cNvSpPr txBox="1"/>
+          <p:nvPr/>
+        </p:nvSpPr>
+        <p:spPr>
+          <a:xfrm>
+            <a:off x="6172200" y="1170432"/>
+            <a:ext cx="5669280" cy="365760"/>
+          </a:xfrm>
+          <a:prstGeom prst="rect">
+            <a:avLst/>
+          </a:prstGeom>
+          <a:noFill/>
+        </p:spPr>
+        <p:txBody>
+          <a:bodyPr wrap="square" lIns="45720" rIns="45720" tIns="18288" bIns="18288" anchor="t">
+            <a:spAutoFit/>
+          </a:bodyPr>
+          <a:lstStyle/>
+          <a:p>
+            <a:pPr algn="l"/>
+            <a:r>
+              <a:rPr sz="1600" b="0" i="0">
+                <a:solidFill>
+                  <a:srgbClr val="707070"/>
+                </a:solidFill>
+                <a:latin typeface="Calibri"/>
+              </a:rPr>
+              <a:t>Measuring the CURRENT area → true stress (future)</a:t>
+            </a:r>
+          </a:p>
+        </p:txBody>
+      </p:sp>
+      <p:graphicFrame>
+        <p:nvGraphicFramePr>
+          <p:cNvPr id="8" name="Table 7"/>
+          <p:cNvGraphicFramePr>
+            <a:graphicFrameLocks noGrp="1"/>
+          </p:cNvGraphicFramePr>
+          <p:nvPr/>
+        </p:nvGraphicFramePr>
+        <p:xfrm>
+          <a:off x="6172200" y="1554480"/>
+          <a:ext cx="5714998" cy="2286000"/>
+        </p:xfrm>
+        <a:graphic>
+          <a:graphicData uri="http://schemas.openxmlformats.org/drawingml/2006/table">
+            <a:tbl>
+              <a:tblPr firstRow="1" bandRow="1">
+                <a:tableStyleId>{5C22544A-7EE6-4342-B048-85BDC9FD1C3A}</a:tableStyleId>
+              </a:tblPr>
+              <a:tblGrid>
+                <a:gridCol w="1365530"/>
+                <a:gridCol w="2731061"/>
+                <a:gridCol w="1618407"/>
+              </a:tblGrid>
+              <a:tr h="457200">
+                <a:tc>
+                  <a:txBody>
+                    <a:bodyPr lIns="54864" rIns="54864" tIns="18288" bIns="18288" wrap="square" anchor="ctr"/>
+                    <a:lstStyle/>
+                    <a:p>
+                      <a:pPr algn="l"/>
+                      <a:r>
+                        <a:rPr sz="1000" b="1">
+                          <a:solidFill>
+                            <a:srgbClr val="FFFFFF"/>
+                          </a:solidFill>
+                          <a:latin typeface="Calibri"/>
+                        </a:rPr>
+                        <a:t>Method</a:t>
+                      </a:r>
+                    </a:p>
+                  </a:txBody>
+                  <a:tcPr>
+                    <a:solidFill>
+                      <a:srgbClr val="143D2F"/>
+                    </a:solidFill>
+                  </a:tcPr>
+                </a:tc>
+                <a:tc>
+                  <a:txBody>
+                    <a:bodyPr lIns="54864" rIns="54864" tIns="18288" bIns="18288" wrap="square" anchor="ctr"/>
+                    <a:lstStyle/>
+                    <a:p>
+                      <a:pPr algn="l"/>
+                      <a:r>
+                        <a:rPr sz="1000" b="1">
+                          <a:solidFill>
+                            <a:srgbClr val="FFFFFF"/>
+                          </a:solidFill>
+                          <a:latin typeface="Calibri"/>
+                        </a:rPr>
+                        <a:t>How</a:t>
+                      </a:r>
+                    </a:p>
+                  </a:txBody>
+                  <a:tcPr>
+                    <a:solidFill>
+                      <a:srgbClr val="143D2F"/>
+                    </a:solidFill>
+                  </a:tcPr>
+                </a:tc>
+                <a:tc>
+                  <a:txBody>
+                    <a:bodyPr lIns="54864" rIns="54864" tIns="18288" bIns="18288" wrap="square" anchor="ctr"/>
+                    <a:lstStyle/>
+                    <a:p>
+                      <a:pPr algn="l"/>
+                      <a:r>
+                        <a:rPr sz="1000" b="1">
+                          <a:solidFill>
+                            <a:srgbClr val="FFFFFF"/>
+                          </a:solidFill>
+                          <a:latin typeface="Calibri"/>
+                        </a:rPr>
+                        <a:t>Note</a:t>
+                      </a:r>
+                    </a:p>
+                  </a:txBody>
+                  <a:tcPr>
+                    <a:solidFill>
+                      <a:srgbClr val="143D2F"/>
+                    </a:solidFill>
+                  </a:tcPr>
+                </a:tc>
+              </a:tr>
+              <a:tr h="457200">
+                <a:tc>
+                  <a:txBody>
+                    <a:bodyPr lIns="54864" rIns="54864" tIns="18288" bIns="18288" wrap="square" anchor="ctr"/>
+                    <a:lstStyle/>
+                    <a:p>
+                      <a:pPr algn="l"/>
+                      <a:r>
+                        <a:rPr sz="950" b="0">
+                          <a:solidFill>
+                            <a:srgbClr val="000000"/>
+                          </a:solidFill>
+                          <a:latin typeface="Calibri"/>
+                        </a:rPr>
+                        <a:t>Poisson estimate</a:t>
+                      </a:r>
+                    </a:p>
+                  </a:txBody>
+                  <a:tcPr/>
+                </a:tc>
+                <a:tc>
+                  <a:txBody>
+                    <a:bodyPr lIns="54864" rIns="54864" tIns="18288" bIns="18288" wrap="square" anchor="ctr"/>
+                    <a:lstStyle/>
+                    <a:p>
+                      <a:pPr algn="l"/>
+                      <a:r>
+                        <a:rPr sz="950" b="0">
+                          <a:solidFill>
+                            <a:srgbClr val="000000"/>
+                          </a:solidFill>
+                          <a:latin typeface="Calibri"/>
+                        </a:rPr>
+                        <a:t>A = A₀(1−ν·ε)²,  ν ≈ 0.35  (no hardware)</a:t>
+                      </a:r>
+                    </a:p>
+                  </a:txBody>
+                  <a:tcPr/>
+                </a:tc>
+                <a:tc>
+                  <a:txBody>
+                    <a:bodyPr lIns="54864" rIns="54864" tIns="18288" bIns="18288" wrap="square" anchor="ctr"/>
+                    <a:lstStyle/>
+                    <a:p>
+                      <a:pPr algn="l"/>
+                      <a:r>
+                        <a:rPr sz="950" b="0">
+                          <a:solidFill>
+                            <a:srgbClr val="000000"/>
+                          </a:solidFill>
+                          <a:latin typeface="Calibri"/>
+                        </a:rPr>
+                        <a:t>cheap; ν drifts in yield</a:t>
+                      </a:r>
+                    </a:p>
+                  </a:txBody>
+                  <a:tcPr/>
+                </a:tc>
+              </a:tr>
+              <a:tr h="457200">
+                <a:tc>
+                  <a:txBody>
+                    <a:bodyPr lIns="54864" rIns="54864" tIns="18288" bIns="18288" wrap="square" anchor="ctr"/>
+                    <a:lstStyle/>
+                    <a:p>
+                      <a:pPr algn="l"/>
+                      <a:r>
+                        <a:rPr sz="950" b="1">
+                          <a:solidFill>
+                            <a:srgbClr val="000000"/>
+                          </a:solidFill>
+                          <a:latin typeface="Calibri"/>
+                        </a:rPr>
+                        <a:t>Transverse markers</a:t>
+                      </a:r>
+                    </a:p>
+                  </a:txBody>
+                  <a:tcPr>
+                    <a:solidFill>
+                      <a:srgbClr val="C8E6C9"/>
+                    </a:solidFill>
+                  </a:tcPr>
+                </a:tc>
+                <a:tc>
+                  <a:txBody>
+                    <a:bodyPr lIns="54864" rIns="54864" tIns="18288" bIns="18288" wrap="square" anchor="ctr"/>
+                    <a:lstStyle/>
+                    <a:p>
+                      <a:pPr algn="l"/>
+                      <a:r>
+                        <a:rPr sz="950" b="0">
+                          <a:solidFill>
+                            <a:srgbClr val="000000"/>
+                          </a:solidFill>
+                          <a:latin typeface="Calibri"/>
+                        </a:rPr>
+                        <a:t>+2 dots across width → ε_w;  A ≈ A₀(1+ε_w)²</a:t>
+                      </a:r>
+                    </a:p>
+                  </a:txBody>
+                  <a:tcPr>
+                    <a:solidFill>
+                      <a:srgbClr val="C8E6C9"/>
+                    </a:solidFill>
+                  </a:tcPr>
+                </a:tc>
+                <a:tc>
+                  <a:txBody>
+                    <a:bodyPr lIns="54864" rIns="54864" tIns="18288" bIns="18288" wrap="square" anchor="ctr"/>
+                    <a:lstStyle/>
+                    <a:p>
+                      <a:pPr algn="l"/>
+                      <a:r>
+                        <a:rPr sz="950" b="0">
+                          <a:solidFill>
+                            <a:srgbClr val="000000"/>
+                          </a:solidFill>
+                          <a:latin typeface="Calibri"/>
+                        </a:rPr>
+                        <a:t>reuses blob-DIC; gives Poisson</a:t>
+                      </a:r>
+                    </a:p>
+                  </a:txBody>
+                  <a:tcPr>
+                    <a:solidFill>
+                      <a:srgbClr val="C8E6C9"/>
+                    </a:solidFill>
+                  </a:tcPr>
+                </a:tc>
+              </a:tr>
+              <a:tr h="457200">
+                <a:tc>
+                  <a:txBody>
+                    <a:bodyPr lIns="54864" rIns="54864" tIns="18288" bIns="18288" wrap="square" anchor="ctr"/>
+                    <a:lstStyle/>
+                    <a:p>
+                      <a:pPr algn="l"/>
+                      <a:r>
+                        <a:rPr sz="950" b="0">
+                          <a:solidFill>
+                            <a:srgbClr val="000000"/>
+                          </a:solidFill>
+                          <a:latin typeface="Calibri"/>
+                        </a:rPr>
+                        <a:t>+ edge camera</a:t>
+                      </a:r>
+                    </a:p>
+                  </a:txBody>
+                  <a:tcPr/>
+                </a:tc>
+                <a:tc>
+                  <a:txBody>
+                    <a:bodyPr lIns="54864" rIns="54864" tIns="18288" bIns="18288" wrap="square" anchor="ctr"/>
+                    <a:lstStyle/>
+                    <a:p>
+                      <a:pPr algn="l"/>
+                      <a:r>
+                        <a:rPr sz="950" b="0">
+                          <a:solidFill>
+                            <a:srgbClr val="000000"/>
+                          </a:solidFill>
+                          <a:latin typeface="Calibri"/>
+                        </a:rPr>
+                        <a:t>2nd view → thickness strain;  A = w·t</a:t>
+                      </a:r>
+                    </a:p>
+                  </a:txBody>
+                  <a:tcPr/>
+                </a:tc>
+                <a:tc>
+                  <a:txBody>
+                    <a:bodyPr lIns="54864" rIns="54864" tIns="18288" bIns="18288" wrap="square" anchor="ctr"/>
+                    <a:lstStyle/>
+                    <a:p>
+                      <a:pPr algn="l"/>
+                      <a:r>
+                        <a:rPr sz="950" b="0">
+                          <a:solidFill>
+                            <a:srgbClr val="000000"/>
+                          </a:solidFill>
+                          <a:latin typeface="Calibri"/>
+                        </a:rPr>
+                        <a:t>rigorous; FDM is orthotropic</a:t>
+                      </a:r>
+                    </a:p>
+                  </a:txBody>
+                  <a:tcPr/>
+                </a:tc>
+              </a:tr>
+              <a:tr h="457200">
+                <a:tc>
+                  <a:txBody>
+                    <a:bodyPr lIns="54864" rIns="54864" tIns="18288" bIns="18288" wrap="square" anchor="ctr"/>
+                    <a:lstStyle/>
+                    <a:p>
+                      <a:pPr algn="l"/>
+                      <a:r>
+                        <a:rPr sz="950" b="0">
+                          <a:solidFill>
+                            <a:srgbClr val="000000"/>
+                          </a:solidFill>
+                          <a:latin typeface="Calibri"/>
+                        </a:rPr>
+                        <a:t>Full-field speckle</a:t>
+                      </a:r>
+                    </a:p>
+                  </a:txBody>
+                  <a:tcPr/>
+                </a:tc>
+                <a:tc>
+                  <a:txBody>
+                    <a:bodyPr lIns="54864" rIns="54864" tIns="18288" bIns="18288" wrap="square" anchor="ctr"/>
+                    <a:lstStyle/>
+                    <a:p>
+                      <a:pPr algn="l"/>
+                      <a:r>
+                        <a:rPr sz="950" b="0">
+                          <a:solidFill>
+                            <a:srgbClr val="000000"/>
+                          </a:solidFill>
+                          <a:latin typeface="Calibri"/>
+                        </a:rPr>
+                        <a:t>fine random speckle + subset DIC</a:t>
+                      </a:r>
+                    </a:p>
+                  </a:txBody>
+                  <a:tcPr/>
+                </a:tc>
+                <a:tc>
+                  <a:txBody>
+                    <a:bodyPr lIns="54864" rIns="54864" tIns="18288" bIns="18288" wrap="square" anchor="ctr"/>
+                    <a:lstStyle/>
+                    <a:p>
+                      <a:pPr algn="l"/>
+                      <a:r>
+                        <a:rPr sz="950" b="0">
+                          <a:solidFill>
+                            <a:srgbClr val="000000"/>
+                          </a:solidFill>
+                          <a:latin typeface="Calibri"/>
+                        </a:rPr>
+                        <a:t>strain field + necking; new pipeline</a:t>
+                      </a:r>
+                    </a:p>
+                  </a:txBody>
+                  <a:tcPr/>
+                </a:tc>
+              </a:tr>
+            </a:tbl>
+          </a:graphicData>
+        </a:graphic>
+      </p:graphicFrame>
+      <p:sp>
+        <p:nvSpPr>
+          <p:cNvPr id="9" name="TextBox 8"/>
+          <p:cNvSpPr txBox="1"/>
+          <p:nvPr/>
+        </p:nvSpPr>
+        <p:spPr>
+          <a:xfrm>
+            <a:off x="6172200" y="3950208"/>
+            <a:ext cx="5715000" cy="960120"/>
+          </a:xfrm>
+          <a:prstGeom prst="rect">
+            <a:avLst/>
+          </a:prstGeom>
+          <a:noFill/>
+        </p:spPr>
+        <p:txBody>
+          <a:bodyPr wrap="square" lIns="45720" rIns="45720" tIns="18288" bIns="18288" anchor="t">
+            <a:spAutoFit/>
+          </a:bodyPr>
+          <a:lstStyle/>
+          <a:p>
+            <a:pPr algn="l"/>
+            <a:r>
+              <a:rPr sz="1050" b="0" i="1">
+                <a:solidFill>
+                  <a:srgbClr val="707070"/>
+                </a:solidFill>
+                <a:latin typeface="Calibri"/>
+              </a:rPr>
+              <a:t>Same speckle style (spray dots): just add a transverse dot pair — the current 2-marker tracker extends naturally (2 axial + 2 transverse). A finer random speckle enables full-field DIC (transverse field + necking) but needs a new analysis pipeline.</a:t>
+            </a:r>
+          </a:p>
+        </p:txBody>
+      </p:sp>
+      <p:sp>
+        <p:nvSpPr>
+          <p:cNvPr id="10" name="Rectangle 9"/>
+          <p:cNvSpPr/>
+          <p:nvPr/>
+        </p:nvSpPr>
+        <p:spPr>
+          <a:xfrm>
+            <a:off x="365760" y="5074920"/>
+            <a:ext cx="11521440" cy="932688"/>
+          </a:xfrm>
+          <a:prstGeom prst="rect">
+            <a:avLst/>
+          </a:prstGeom>
+          <a:solidFill>
+            <a:srgbClr val="E7F1F8"/>
+          </a:solidFill>
+          <a:ln>
+            <a:noFill/>
+          </a:ln>
+        </p:spPr>
+        <p:style>
+          <a:lnRef idx="1">
+            <a:schemeClr val="accent1"/>
+          </a:lnRef>
+          <a:fillRef idx="3">
+            <a:schemeClr val="accent1"/>
+          </a:fillRef>
+          <a:effectRef idx="2">
+            <a:schemeClr val="accent1"/>
+          </a:effectRef>
+          <a:fontRef idx="minor">
+            <a:schemeClr val="lt1"/>
+          </a:fontRef>
+        </p:style>
+        <p:txBody>
+          <a:bodyPr rtlCol="0" anchor="ctr" wrap="square" lIns="109728" rIns="109728"/>
+          <a:lstStyle/>
+          <a:p>
+            <a:pPr algn="ctr"/>
+            <a:r>
+              <a:rPr sz="1100" b="1">
+                <a:solidFill>
+                  <a:srgbClr val="000000"/>
+                </a:solidFill>
+                <a:latin typeface="Calibri"/>
+              </a:rPr>
+              <a:t>RECOMMENDED — add a TRANSVERSE marker pair (green row): measure width contraction ε_w with the existing DIC (bonus: Poisson's ratio). Then A(t) = A₀(1+ε_w)²,  σ_cauchy = F / A(t),  plotted vs true strain ln(1+ε). Keep ENGINEERING stress as the reported / validated value (datasheet &amp; journal basis); report Cauchy as the physically-accurate supplement. Add an edge camera for through-thickness if FDM orthotropy matters.</a:t>
+            </a:r>
+          </a:p>
+        </p:txBody>
+      </p:sp>
+      <p:sp>
+        <p:nvSpPr>
+          <p:cNvPr id="11" name="TextBox 10"/>
+          <p:cNvSpPr txBox="1"/>
+          <p:nvPr/>
+        </p:nvSpPr>
+        <p:spPr>
+          <a:xfrm>
+            <a:off x="548640" y="6400800"/>
+            <a:ext cx="11064240" cy="365760"/>
+          </a:xfrm>
+          <a:prstGeom prst="rect">
+            <a:avLst/>
+          </a:prstGeom>
+          <a:noFill/>
+        </p:spPr>
+        <p:txBody>
+          <a:bodyPr wrap="square" lIns="45720" rIns="45720" tIns="18288" bIns="18288" anchor="t">
+            <a:spAutoFit/>
+          </a:bodyPr>
+          <a:lstStyle/>
+          <a:p>
+            <a:pPr algn="l"/>
+            <a:r>
+              <a:rPr sz="1200" b="0" i="1">
+                <a:solidFill>
+                  <a:srgbClr val="707070"/>
+                </a:solidFill>
+                <a:latin typeface="Calibri"/>
+              </a:rPr>
+              <a:t>Current V6 report &amp; plots = engineering stress (nominal 80 mm²). True/Cauchy needs the deforming area; post-necking needs full-field DIC or markers at the neck.</a:t>
+            </a:r>
+          </a:p>
+        </p:txBody>
+      </p:sp>
+      <p:sp>
+        <p:nvSpPr>
+          <p:cNvPr id="12" name="TextBox 11"/>
+          <p:cNvSpPr txBox="1"/>
+          <p:nvPr/>
+        </p:nvSpPr>
+        <p:spPr>
+          <a:xfrm>
+            <a:off x="457200" y="6446520"/>
+            <a:ext cx="640080" cy="274320"/>
+          </a:xfrm>
+          <a:prstGeom prst="rect">
+            <a:avLst/>
+          </a:prstGeom>
+          <a:noFill/>
+        </p:spPr>
+        <p:txBody>
+          <a:bodyPr wrap="square" lIns="45720" rIns="45720" tIns="18288" bIns="18288" anchor="t">
+            <a:spAutoFit/>
+          </a:bodyPr>
+          <a:lstStyle/>
+          <a:p>
+            <a:pPr algn="l"/>
+            <a:r>
+              <a:rPr sz="1000" b="0" i="0">
+                <a:solidFill>
+                  <a:srgbClr val="707070"/>
+                </a:solidFill>
+                <a:latin typeface="Calibri"/>
+              </a:rPr>
+              <a:t>163</a:t>
             </a:r>
           </a:p>
         </p:txBody>

</xml_diff>

<commit_message>
V6a deck: add slide 164 — measuring Poisson / true stress without transverse dots
The mini-dogbone gauge is too narrow for a transverse dot pair and at ~20 px/mm the
elastic width change is sub-pixel (supersedes slide 163's transverse-marker idea).
Documents 3 MEASURED routes: (1) edge/silhouette width tracking [recommended — reuses
the camera + a matte-black backdrop], (2) full-field speckle DIC (Ncorr/muDIC, offline),
(3) hardware (side camera / laser micrometer / clip-on transverse extensometer).
Deck now 24 slides (pages 141-164).

Co-Authored-By: Claude Opus 4.8 <noreply@anthropic.com>
</commit_message>
<xml_diff>
--- a/V6a_8_6_20_slides.pptx
+++ b/V6a_8_6_20_slides.pptx
@@ -28,6 +28,7 @@
     <p:sldId id="276" r:id="rId27"/>
     <p:sldId id="277" r:id="rId28"/>
     <p:sldId id="278" r:id="rId29"/>
+    <p:sldId id="279" r:id="rId30"/>
   </p:sldIdLst>
   <p:sldSz cx="12191695" cy="6858000" type="screen4x3"/>
   <p:notesSz cx="6858000" cy="9144000"/>
@@ -16700,6 +16701,694 @@
                 <a:latin typeface="Calibri"/>
               </a:rPr>
               <a:t>163</a:t>
+            </a:r>
+          </a:p>
+        </p:txBody>
+      </p:sp>
+    </p:spTree>
+  </p:cSld>
+  <p:clrMapOvr>
+    <a:masterClrMapping/>
+  </p:clrMapOvr>
+</p:sld>
+</file>
+
+<file path=ppt/slides/slide24.xml><?xml version="1.0" encoding="utf-8"?>
+<p:sld xmlns:a="http://schemas.openxmlformats.org/drawingml/2006/main" xmlns:p="http://schemas.openxmlformats.org/presentationml/2006/main" xmlns:r="http://schemas.openxmlformats.org/officeDocument/2006/relationships">
+  <p:cSld>
+    <p:spTree>
+      <p:nvGrpSpPr>
+        <p:cNvPr id="1" name=""/>
+        <p:cNvGrpSpPr/>
+        <p:nvPr/>
+      </p:nvGrpSpPr>
+      <p:grpSpPr/>
+      <p:sp>
+        <p:nvSpPr>
+          <p:cNvPr id="2" name="TextBox 1"/>
+          <p:cNvSpPr txBox="1"/>
+          <p:nvPr/>
+        </p:nvSpPr>
+        <p:spPr>
+          <a:xfrm>
+            <a:off x="11155680" y="274320"/>
+            <a:ext cx="914400" cy="274320"/>
+          </a:xfrm>
+          <a:prstGeom prst="rect">
+            <a:avLst/>
+          </a:prstGeom>
+          <a:noFill/>
+        </p:spPr>
+        <p:txBody>
+          <a:bodyPr wrap="square" lIns="45720" rIns="45720" tIns="18288" bIns="18288" anchor="t">
+            <a:spAutoFit/>
+          </a:bodyPr>
+          <a:lstStyle/>
+          <a:p>
+            <a:pPr algn="r"/>
+            <a:r>
+              <a:rPr sz="800" b="1" i="0">
+                <a:solidFill>
+                  <a:srgbClr val="707070"/>
+                </a:solidFill>
+                <a:latin typeface="Calibri"/>
+              </a:rPr>
+              <a:t>JÖNKÖPING UNIVERSITY</a:t>
+            </a:r>
+          </a:p>
+        </p:txBody>
+      </p:sp>
+      <p:sp>
+        <p:nvSpPr>
+          <p:cNvPr id="3" name="Rectangle 2"/>
+          <p:cNvSpPr/>
+          <p:nvPr/>
+        </p:nvSpPr>
+        <p:spPr>
+          <a:xfrm>
+            <a:off x="457200" y="411480"/>
+            <a:ext cx="457200" cy="73152"/>
+          </a:xfrm>
+          <a:prstGeom prst="rect">
+            <a:avLst/>
+          </a:prstGeom>
+          <a:solidFill>
+            <a:srgbClr val="A9D6EF"/>
+          </a:solidFill>
+          <a:ln>
+            <a:noFill/>
+          </a:ln>
+        </p:spPr>
+        <p:style>
+          <a:lnRef idx="1">
+            <a:schemeClr val="accent1"/>
+          </a:lnRef>
+          <a:fillRef idx="3">
+            <a:schemeClr val="accent1"/>
+          </a:fillRef>
+          <a:effectRef idx="2">
+            <a:schemeClr val="accent1"/>
+          </a:effectRef>
+          <a:fontRef idx="minor">
+            <a:schemeClr val="lt1"/>
+          </a:fontRef>
+        </p:style>
+        <p:txBody>
+          <a:bodyPr rtlCol="0" anchor="ctr"/>
+          <a:lstStyle/>
+          <a:p>
+            <a:pPr algn="ctr"/>
+          </a:p>
+        </p:txBody>
+      </p:sp>
+      <p:sp>
+        <p:nvSpPr>
+          <p:cNvPr id="4" name="TextBox 3"/>
+          <p:cNvSpPr txBox="1"/>
+          <p:nvPr/>
+        </p:nvSpPr>
+        <p:spPr>
+          <a:xfrm>
+            <a:off x="457200" y="502920"/>
+            <a:ext cx="11430000" cy="822960"/>
+          </a:xfrm>
+          <a:prstGeom prst="rect">
+            <a:avLst/>
+          </a:prstGeom>
+          <a:noFill/>
+        </p:spPr>
+        <p:txBody>
+          <a:bodyPr wrap="square" lIns="45720" rIns="45720" tIns="18288" bIns="18288" anchor="t">
+            <a:spAutoFit/>
+          </a:bodyPr>
+          <a:lstStyle/>
+          <a:p>
+            <a:pPr algn="l"/>
+            <a:r>
+              <a:rPr sz="3000" b="0" i="0">
+                <a:solidFill>
+                  <a:srgbClr val="000000"/>
+                </a:solidFill>
+                <a:latin typeface="Calibri Light"/>
+              </a:rPr>
+              <a:t>MEASURING POISSON'S RATIO &amp; TRUE STRESS — WITHOUT TRANSVERSE DOTS</a:t>
+            </a:r>
+          </a:p>
+        </p:txBody>
+      </p:sp>
+      <p:sp>
+        <p:nvSpPr>
+          <p:cNvPr id="5" name="TextBox 4"/>
+          <p:cNvSpPr txBox="1"/>
+          <p:nvPr/>
+        </p:nvSpPr>
+        <p:spPr>
+          <a:xfrm>
+            <a:off x="365760" y="1170432"/>
+            <a:ext cx="5532120" cy="365760"/>
+          </a:xfrm>
+          <a:prstGeom prst="rect">
+            <a:avLst/>
+          </a:prstGeom>
+          <a:noFill/>
+        </p:spPr>
+        <p:txBody>
+          <a:bodyPr wrap="square" lIns="45720" rIns="45720" tIns="18288" bIns="18288" anchor="t">
+            <a:spAutoFit/>
+          </a:bodyPr>
+          <a:lstStyle/>
+          <a:p>
+            <a:pPr algn="l"/>
+            <a:r>
+              <a:rPr sz="1600" b="0" i="0">
+                <a:solidFill>
+                  <a:srgbClr val="707070"/>
+                </a:solidFill>
+                <a:latin typeface="Calibri"/>
+              </a:rPr>
+              <a:t>Why not transverse dots — and the fix</a:t>
+            </a:r>
+          </a:p>
+        </p:txBody>
+      </p:sp>
+      <p:sp>
+        <p:nvSpPr>
+          <p:cNvPr id="6" name="TextBox 5"/>
+          <p:cNvSpPr txBox="1"/>
+          <p:nvPr/>
+        </p:nvSpPr>
+        <p:spPr>
+          <a:xfrm>
+            <a:off x="365760" y="1554480"/>
+            <a:ext cx="5532120" cy="3657600"/>
+          </a:xfrm>
+          <a:prstGeom prst="rect">
+            <a:avLst/>
+          </a:prstGeom>
+          <a:noFill/>
+        </p:spPr>
+        <p:txBody>
+          <a:bodyPr wrap="square" lIns="45720" rIns="45720" tIns="18288" bIns="18288" anchor="t">
+            <a:spAutoFit/>
+          </a:bodyPr>
+          <a:lstStyle/>
+          <a:p>
+            <a:pPr algn="l"/>
+            <a:r>
+              <a:rPr sz="1150" b="0" i="0">
+                <a:solidFill>
+                  <a:srgbClr val="000000"/>
+                </a:solidFill>
+                <a:latin typeface="Calibri"/>
+              </a:rPr>
+              <a:t>The mini-dogbone GAUGE is too NARROW to fit a transverse dot pair, and at ~20 px/mm the elastic width change is SUB-PIXEL for discrete dots — added markers cannot resolve it.
+The fix: don't add markers — measure the specimen's OWN EDGES. Track the left &amp; right silhouette edges across the gauge and average the width; as it necks, that width shrinks:
+    ε_w = (W₀ - W)/W₀,   ν = -ε_w/ε_axial,   A = W·t
+All three routes below return a MEASURED value (no assumed ν) — written to the CSV as real data, not an estimate.</a:t>
+            </a:r>
+          </a:p>
+        </p:txBody>
+      </p:sp>
+      <p:sp>
+        <p:nvSpPr>
+          <p:cNvPr id="7" name="TextBox 6"/>
+          <p:cNvSpPr txBox="1"/>
+          <p:nvPr/>
+        </p:nvSpPr>
+        <p:spPr>
+          <a:xfrm>
+            <a:off x="6035040" y="1170432"/>
+            <a:ext cx="5852160" cy="365760"/>
+          </a:xfrm>
+          <a:prstGeom prst="rect">
+            <a:avLst/>
+          </a:prstGeom>
+          <a:noFill/>
+        </p:spPr>
+        <p:txBody>
+          <a:bodyPr wrap="square" lIns="45720" rIns="45720" tIns="18288" bIns="18288" anchor="t">
+            <a:spAutoFit/>
+          </a:bodyPr>
+          <a:lstStyle/>
+          <a:p>
+            <a:pPr algn="l"/>
+            <a:r>
+              <a:rPr sz="1600" b="0" i="0">
+                <a:solidFill>
+                  <a:srgbClr val="707070"/>
+                </a:solidFill>
+                <a:latin typeface="Calibri"/>
+              </a:rPr>
+              <a:t>Three ways to MEASURE it (no transverse dots)</a:t>
+            </a:r>
+          </a:p>
+        </p:txBody>
+      </p:sp>
+      <p:graphicFrame>
+        <p:nvGraphicFramePr>
+          <p:cNvPr id="8" name="Table 7"/>
+          <p:cNvGraphicFramePr>
+            <a:graphicFrameLocks noGrp="1"/>
+          </p:cNvGraphicFramePr>
+          <p:nvPr/>
+        </p:nvGraphicFramePr>
+        <p:xfrm>
+          <a:off x="6035040" y="1554480"/>
+          <a:ext cx="5852160" cy="2468880"/>
+        </p:xfrm>
+        <a:graphic>
+          <a:graphicData uri="http://schemas.openxmlformats.org/drawingml/2006/table">
+            <a:tbl>
+              <a:tblPr firstRow="1" bandRow="1">
+                <a:tableStyleId>{5C22544A-7EE6-4342-B048-85BDC9FD1C3A}</a:tableStyleId>
+              </a:tblPr>
+              <a:tblGrid>
+                <a:gridCol w="1554480"/>
+                <a:gridCol w="2743200"/>
+                <a:gridCol w="1554480"/>
+              </a:tblGrid>
+              <a:tr h="617220">
+                <a:tc>
+                  <a:txBody>
+                    <a:bodyPr lIns="54864" rIns="54864" tIns="18288" bIns="18288" wrap="square" anchor="ctr"/>
+                    <a:lstStyle/>
+                    <a:p>
+                      <a:pPr algn="l"/>
+                      <a:r>
+                        <a:rPr sz="1000" b="1">
+                          <a:solidFill>
+                            <a:srgbClr val="FFFFFF"/>
+                          </a:solidFill>
+                          <a:latin typeface="Calibri"/>
+                        </a:rPr>
+                        <a:t>Route</a:t>
+                      </a:r>
+                    </a:p>
+                  </a:txBody>
+                  <a:tcPr>
+                    <a:solidFill>
+                      <a:srgbClr val="143D2F"/>
+                    </a:solidFill>
+                  </a:tcPr>
+                </a:tc>
+                <a:tc>
+                  <a:txBody>
+                    <a:bodyPr lIns="54864" rIns="54864" tIns="18288" bIns="18288" wrap="square" anchor="ctr"/>
+                    <a:lstStyle/>
+                    <a:p>
+                      <a:pPr algn="l"/>
+                      <a:r>
+                        <a:rPr sz="1000" b="1">
+                          <a:solidFill>
+                            <a:srgbClr val="FFFFFF"/>
+                          </a:solidFill>
+                          <a:latin typeface="Calibri"/>
+                        </a:rPr>
+                        <a:t>How it works</a:t>
+                      </a:r>
+                    </a:p>
+                  </a:txBody>
+                  <a:tcPr>
+                    <a:solidFill>
+                      <a:srgbClr val="143D2F"/>
+                    </a:solidFill>
+                  </a:tcPr>
+                </a:tc>
+                <a:tc>
+                  <a:txBody>
+                    <a:bodyPr lIns="54864" rIns="54864" tIns="18288" bIns="18288" wrap="square" anchor="ctr"/>
+                    <a:lstStyle/>
+                    <a:p>
+                      <a:pPr algn="l"/>
+                      <a:r>
+                        <a:rPr sz="1000" b="1">
+                          <a:solidFill>
+                            <a:srgbClr val="FFFFFF"/>
+                          </a:solidFill>
+                          <a:latin typeface="Calibri"/>
+                        </a:rPr>
+                        <a:t>Needs</a:t>
+                      </a:r>
+                    </a:p>
+                  </a:txBody>
+                  <a:tcPr>
+                    <a:solidFill>
+                      <a:srgbClr val="143D2F"/>
+                    </a:solidFill>
+                  </a:tcPr>
+                </a:tc>
+              </a:tr>
+              <a:tr h="617220">
+                <a:tc>
+                  <a:txBody>
+                    <a:bodyPr lIns="54864" rIns="54864" tIns="18288" bIns="18288" wrap="square" anchor="ctr"/>
+                    <a:lstStyle/>
+                    <a:p>
+                      <a:pPr algn="l"/>
+                      <a:r>
+                        <a:rPr sz="900" b="1">
+                          <a:solidFill>
+                            <a:srgbClr val="000000"/>
+                          </a:solidFill>
+                          <a:latin typeface="Calibri"/>
+                        </a:rPr>
+                        <a:t>1  Edge / silhouette
+    width tracking</a:t>
+                      </a:r>
+                    </a:p>
+                  </a:txBody>
+                  <a:tcPr>
+                    <a:solidFill>
+                      <a:srgbClr val="C8E6C9"/>
+                    </a:solidFill>
+                  </a:tcPr>
+                </a:tc>
+                <a:tc>
+                  <a:txBody>
+                    <a:bodyPr lIns="54864" rIns="54864" tIns="18288" bIns="18288" wrap="square" anchor="ctr"/>
+                    <a:lstStyle/>
+                    <a:p>
+                      <a:pPr algn="l"/>
+                      <a:r>
+                        <a:rPr sz="900" b="0">
+                          <a:solidFill>
+                            <a:srgbClr val="000000"/>
+                          </a:solidFill>
+                          <a:latin typeface="Calibri"/>
+                        </a:rPr>
+                        <a:t>find the specimen's L &amp; R edges across the gauge; average width over 100s of rows -&gt; ε_w each frame</a:t>
+                      </a:r>
+                    </a:p>
+                  </a:txBody>
+                  <a:tcPr>
+                    <a:solidFill>
+                      <a:srgbClr val="C8E6C9"/>
+                    </a:solidFill>
+                  </a:tcPr>
+                </a:tc>
+                <a:tc>
+                  <a:txBody>
+                    <a:bodyPr lIns="54864" rIns="54864" tIns="18288" bIns="18288" wrap="square" anchor="ctr"/>
+                    <a:lstStyle/>
+                    <a:p>
+                      <a:pPr algn="l"/>
+                      <a:r>
+                        <a:rPr sz="900" b="0">
+                          <a:solidFill>
+                            <a:srgbClr val="000000"/>
+                          </a:solidFill>
+                          <a:latin typeface="Calibri"/>
+                        </a:rPr>
+                        <a:t>matte-black backdrop;
+reuses THIS camera</a:t>
+                      </a:r>
+                    </a:p>
+                  </a:txBody>
+                  <a:tcPr>
+                    <a:solidFill>
+                      <a:srgbClr val="C8E6C9"/>
+                    </a:solidFill>
+                  </a:tcPr>
+                </a:tc>
+              </a:tr>
+              <a:tr h="617220">
+                <a:tc>
+                  <a:txBody>
+                    <a:bodyPr lIns="54864" rIns="54864" tIns="18288" bIns="18288" wrap="square" anchor="ctr"/>
+                    <a:lstStyle/>
+                    <a:p>
+                      <a:pPr algn="l"/>
+                      <a:r>
+                        <a:rPr sz="900" b="0">
+                          <a:solidFill>
+                            <a:srgbClr val="000000"/>
+                          </a:solidFill>
+                          <a:latin typeface="Calibri"/>
+                        </a:rPr>
+                        <a:t>2  Full-field
+    speckle DIC</a:t>
+                      </a:r>
+                    </a:p>
+                  </a:txBody>
+                  <a:tcPr/>
+                </a:tc>
+                <a:tc>
+                  <a:txBody>
+                    <a:bodyPr lIns="54864" rIns="54864" tIns="18288" bIns="18288" wrap="square" anchor="ctr"/>
+                    <a:lstStyle/>
+                    <a:p>
+                      <a:pPr algn="l"/>
+                      <a:r>
+                        <a:rPr sz="900" b="0">
+                          <a:solidFill>
+                            <a:srgbClr val="000000"/>
+                          </a:solidFill>
+                          <a:latin typeface="Calibri"/>
+                        </a:rPr>
+                        <a:t>fine random speckle + subset correlation (Ncorr / muDIC, offline) -&gt; full axial + transverse strain field</a:t>
+                      </a:r>
+                    </a:p>
+                  </a:txBody>
+                  <a:tcPr/>
+                </a:tc>
+                <a:tc>
+                  <a:txBody>
+                    <a:bodyPr lIns="54864" rIns="54864" tIns="18288" bIns="18288" wrap="square" anchor="ctr"/>
+                    <a:lstStyle/>
+                    <a:p>
+                      <a:pPr algn="l"/>
+                      <a:r>
+                        <a:rPr sz="900" b="0">
+                          <a:solidFill>
+                            <a:srgbClr val="000000"/>
+                          </a:solidFill>
+                          <a:latin typeface="Calibri"/>
+                        </a:rPr>
+                        <a:t>speckle + new
+analysis pipeline</a:t>
+                      </a:r>
+                    </a:p>
+                  </a:txBody>
+                  <a:tcPr/>
+                </a:tc>
+              </a:tr>
+              <a:tr h="617220">
+                <a:tc>
+                  <a:txBody>
+                    <a:bodyPr lIns="54864" rIns="54864" tIns="18288" bIns="18288" wrap="square" anchor="ctr"/>
+                    <a:lstStyle/>
+                    <a:p>
+                      <a:pPr algn="l"/>
+                      <a:r>
+                        <a:rPr sz="900" b="0">
+                          <a:solidFill>
+                            <a:srgbClr val="000000"/>
+                          </a:solidFill>
+                          <a:latin typeface="Calibri"/>
+                        </a:rPr>
+                        <a:t>3  Hardware probe</a:t>
+                      </a:r>
+                    </a:p>
+                  </a:txBody>
+                  <a:tcPr/>
+                </a:tc>
+                <a:tc>
+                  <a:txBody>
+                    <a:bodyPr lIns="54864" rIns="54864" tIns="18288" bIns="18288" wrap="square" anchor="ctr"/>
+                    <a:lstStyle/>
+                    <a:p>
+                      <a:pPr algn="l"/>
+                      <a:r>
+                        <a:rPr sz="900" b="0">
+                          <a:solidFill>
+                            <a:srgbClr val="000000"/>
+                          </a:solidFill>
+                          <a:latin typeface="Calibri"/>
+                        </a:rPr>
+                        <a:t>2nd side camera (thickness), laser micrometer, or clip-on transverse extensometer</a:t>
+                      </a:r>
+                    </a:p>
+                  </a:txBody>
+                  <a:tcPr/>
+                </a:tc>
+                <a:tc>
+                  <a:txBody>
+                    <a:bodyPr lIns="54864" rIns="54864" tIns="18288" bIns="18288" wrap="square" anchor="ctr"/>
+                    <a:lstStyle/>
+                    <a:p>
+                      <a:pPr algn="l"/>
+                      <a:r>
+                        <a:rPr sz="900" b="0">
+                          <a:solidFill>
+                            <a:srgbClr val="000000"/>
+                          </a:solidFill>
+                          <a:latin typeface="Calibri"/>
+                        </a:rPr>
+                        <a:t>extra hardware;
+lab-grade</a:t>
+                      </a:r>
+                    </a:p>
+                  </a:txBody>
+                  <a:tcPr/>
+                </a:tc>
+              </a:tr>
+            </a:tbl>
+          </a:graphicData>
+        </a:graphic>
+      </p:graphicFrame>
+      <p:sp>
+        <p:nvSpPr>
+          <p:cNvPr id="9" name="TextBox 8"/>
+          <p:cNvSpPr txBox="1"/>
+          <p:nvPr/>
+        </p:nvSpPr>
+        <p:spPr>
+          <a:xfrm>
+            <a:off x="6035040" y="4114800"/>
+            <a:ext cx="5852160" cy="914400"/>
+          </a:xfrm>
+          <a:prstGeom prst="rect">
+            <a:avLst/>
+          </a:prstGeom>
+          <a:noFill/>
+        </p:spPr>
+        <p:txBody>
+          <a:bodyPr wrap="square" lIns="45720" rIns="45720" tIns="18288" bIns="18288" anchor="t">
+            <a:spAutoFit/>
+          </a:bodyPr>
+          <a:lstStyle/>
+          <a:p>
+            <a:pPr algn="l"/>
+            <a:r>
+              <a:rPr sz="1050" b="0" i="1">
+                <a:solidFill>
+                  <a:srgbClr val="707070"/>
+                </a:solidFill>
+                <a:latin typeface="Calibri"/>
+              </a:rPr>
+              <a:t>Why #1 works at 20 px/mm: one edge is sub-pixel, but averaging the width along the whole gauge (100s of rows) cuts the noise ~10x to ~0.01 px — the ~0.5 px elastic width change is then well resolved. It only needs CRISP edges = a dark background behind the specimen.</a:t>
+            </a:r>
+          </a:p>
+        </p:txBody>
+      </p:sp>
+      <p:sp>
+        <p:nvSpPr>
+          <p:cNvPr id="10" name="Rectangle 9"/>
+          <p:cNvSpPr/>
+          <p:nvPr/>
+        </p:nvSpPr>
+        <p:spPr>
+          <a:xfrm>
+            <a:off x="365760" y="5120640"/>
+            <a:ext cx="11521440" cy="932688"/>
+          </a:xfrm>
+          <a:prstGeom prst="rect">
+            <a:avLst/>
+          </a:prstGeom>
+          <a:solidFill>
+            <a:srgbClr val="E7F1F8"/>
+          </a:solidFill>
+          <a:ln>
+            <a:noFill/>
+          </a:ln>
+        </p:spPr>
+        <p:style>
+          <a:lnRef idx="1">
+            <a:schemeClr val="accent1"/>
+          </a:lnRef>
+          <a:fillRef idx="3">
+            <a:schemeClr val="accent1"/>
+          </a:fillRef>
+          <a:effectRef idx="2">
+            <a:schemeClr val="accent1"/>
+          </a:effectRef>
+          <a:fontRef idx="minor">
+            <a:schemeClr val="lt1"/>
+          </a:fontRef>
+        </p:style>
+        <p:txBody>
+          <a:bodyPr rtlCol="0" anchor="ctr" wrap="square" lIns="109728" rIns="109728"/>
+          <a:lstStyle/>
+          <a:p>
+            <a:pPr algn="ctr"/>
+            <a:r>
+              <a:rPr sz="1100" b="1">
+                <a:solidFill>
+                  <a:srgbClr val="000000"/>
+                </a:solidFill>
+                <a:latin typeface="Calibri"/>
+              </a:rPr>
+              <a:t>RECOMMENDED — EDGE-WIDTH TRACKING + a matte-black backdrop (e.g. spray-painted MDF a few cm behind the gauge): the only route that MEASURES Poisson's ratio &amp; true Cauchy stress while reusing THIS camera and specimen. Matte finish avoids LED glare; the gap softens cast shadows. Keep ENGINEERING stress as the reported / validated basis — Cauchy as the measured supplement.</a:t>
+            </a:r>
+          </a:p>
+        </p:txBody>
+      </p:sp>
+      <p:sp>
+        <p:nvSpPr>
+          <p:cNvPr id="11" name="TextBox 10"/>
+          <p:cNvSpPr txBox="1"/>
+          <p:nvPr/>
+        </p:nvSpPr>
+        <p:spPr>
+          <a:xfrm>
+            <a:off x="548640" y="6400800"/>
+            <a:ext cx="11064240" cy="365760"/>
+          </a:xfrm>
+          <a:prstGeom prst="rect">
+            <a:avLst/>
+          </a:prstGeom>
+          <a:noFill/>
+        </p:spPr>
+        <p:txBody>
+          <a:bodyPr wrap="square" lIns="45720" rIns="45720" tIns="18288" bIns="18288" anchor="t">
+            <a:spAutoFit/>
+          </a:bodyPr>
+          <a:lstStyle/>
+          <a:p>
+            <a:pPr algn="l"/>
+            <a:r>
+              <a:rPr sz="1200" b="0" i="1">
+                <a:solidFill>
+                  <a:srgbClr val="707070"/>
+                </a:solidFill>
+                <a:latin typeface="Calibri"/>
+              </a:rPr>
+              <a:t>Supersedes the transverse-marker idea on the previous slide: the narrow gauge + camera resolution rule out a transverse dot pair. Measure the specimen's own edges (or full-field speckle) instead.</a:t>
+            </a:r>
+          </a:p>
+        </p:txBody>
+      </p:sp>
+      <p:sp>
+        <p:nvSpPr>
+          <p:cNvPr id="12" name="TextBox 11"/>
+          <p:cNvSpPr txBox="1"/>
+          <p:nvPr/>
+        </p:nvSpPr>
+        <p:spPr>
+          <a:xfrm>
+            <a:off x="457200" y="6446520"/>
+            <a:ext cx="640080" cy="274320"/>
+          </a:xfrm>
+          <a:prstGeom prst="rect">
+            <a:avLst/>
+          </a:prstGeom>
+          <a:noFill/>
+        </p:spPr>
+        <p:txBody>
+          <a:bodyPr wrap="square" lIns="45720" rIns="45720" tIns="18288" bIns="18288" anchor="t">
+            <a:spAutoFit/>
+          </a:bodyPr>
+          <a:lstStyle/>
+          <a:p>
+            <a:pPr algn="l"/>
+            <a:r>
+              <a:rPr sz="1000" b="0" i="0">
+                <a:solidFill>
+                  <a:srgbClr val="707070"/>
+                </a:solidFill>
+                <a:latin typeface="Calibri"/>
+              </a:rPr>
+              <a:t>164</a:t>
             </a:r>
           </a:p>
         </p:txBody>

</xml_diff>

<commit_message>
V6a deck: add roadmap progress section (slides 165-168)
- 165 status dashboard: 5-phase roadmap table (Foundations DONE; one-click workflow
  BUILT/rig-test; closed-loop 1/5 wired; smart-DIC HUD done; UX planned) + KPIs
  (7 modules / 6 app features / 9-9 sim / 6 to rig-test).
- 166 DONE: committed modules (utm_analysis/report/registry/recipes/control_*/dic) +
  in-UI features (report, recipes, prepare, auto-stop, strain-rate, HUD, safety net).
- 167 TO BE TESTED: per-feature rig checklist + the 3 rig facts + safety banner.
- 168 PLANNED: measured-Poisson edge-width pipeline (matte-black MDF backdrop -> detect
  edges -> average width -> nu / true Cauchy) + remaining modes/UX + recommended order.
Deck now 28 slides (pp.141-168).

Co-Authored-By: Claude Opus 4.8 <noreply@anthropic.com>
</commit_message>
<xml_diff>
--- a/V6a_8_6_20_slides.pptx
+++ b/V6a_8_6_20_slides.pptx
@@ -29,6 +29,10 @@
     <p:sldId id="277" r:id="rId28"/>
     <p:sldId id="278" r:id="rId29"/>
     <p:sldId id="279" r:id="rId30"/>
+    <p:sldId id="280" r:id="rId31"/>
+    <p:sldId id="281" r:id="rId32"/>
+    <p:sldId id="282" r:id="rId33"/>
+    <p:sldId id="283" r:id="rId34"/>
   </p:sldIdLst>
   <p:sldSz cx="12191695" cy="6858000" type="screen4x3"/>
   <p:notesSz cx="6858000" cy="9144000"/>
@@ -17389,6 +17393,3034 @@
                 <a:latin typeface="Calibri"/>
               </a:rPr>
               <a:t>164</a:t>
+            </a:r>
+          </a:p>
+        </p:txBody>
+      </p:sp>
+    </p:spTree>
+  </p:cSld>
+  <p:clrMapOvr>
+    <a:masterClrMapping/>
+  </p:clrMapOvr>
+</p:sld>
+</file>
+
+<file path=ppt/slides/slide25.xml><?xml version="1.0" encoding="utf-8"?>
+<p:sld xmlns:a="http://schemas.openxmlformats.org/drawingml/2006/main" xmlns:p="http://schemas.openxmlformats.org/presentationml/2006/main" xmlns:r="http://schemas.openxmlformats.org/officeDocument/2006/relationships">
+  <p:cSld>
+    <p:spTree>
+      <p:nvGrpSpPr>
+        <p:cNvPr id="1" name=""/>
+        <p:cNvGrpSpPr/>
+        <p:nvPr/>
+      </p:nvGrpSpPr>
+      <p:grpSpPr/>
+      <p:sp>
+        <p:nvSpPr>
+          <p:cNvPr id="2" name="TextBox 1"/>
+          <p:cNvSpPr txBox="1"/>
+          <p:nvPr/>
+        </p:nvSpPr>
+        <p:spPr>
+          <a:xfrm>
+            <a:off x="11155680" y="274320"/>
+            <a:ext cx="914400" cy="274320"/>
+          </a:xfrm>
+          <a:prstGeom prst="rect">
+            <a:avLst/>
+          </a:prstGeom>
+          <a:noFill/>
+        </p:spPr>
+        <p:txBody>
+          <a:bodyPr wrap="square" lIns="45720" rIns="45720" tIns="18288" bIns="18288" anchor="t">
+            <a:spAutoFit/>
+          </a:bodyPr>
+          <a:lstStyle/>
+          <a:p>
+            <a:pPr algn="r"/>
+            <a:r>
+              <a:rPr sz="800" b="1" i="0">
+                <a:solidFill>
+                  <a:srgbClr val="707070"/>
+                </a:solidFill>
+                <a:latin typeface="Calibri"/>
+              </a:rPr>
+              <a:t>JÖNKÖPING UNIVERSITY</a:t>
+            </a:r>
+          </a:p>
+        </p:txBody>
+      </p:sp>
+      <p:sp>
+        <p:nvSpPr>
+          <p:cNvPr id="3" name="Rectangle 2"/>
+          <p:cNvSpPr/>
+          <p:nvPr/>
+        </p:nvSpPr>
+        <p:spPr>
+          <a:xfrm>
+            <a:off x="457200" y="411480"/>
+            <a:ext cx="457200" cy="73152"/>
+          </a:xfrm>
+          <a:prstGeom prst="rect">
+            <a:avLst/>
+          </a:prstGeom>
+          <a:solidFill>
+            <a:srgbClr val="A9D6EF"/>
+          </a:solidFill>
+          <a:ln>
+            <a:noFill/>
+          </a:ln>
+        </p:spPr>
+        <p:style>
+          <a:lnRef idx="1">
+            <a:schemeClr val="accent1"/>
+          </a:lnRef>
+          <a:fillRef idx="3">
+            <a:schemeClr val="accent1"/>
+          </a:fillRef>
+          <a:effectRef idx="2">
+            <a:schemeClr val="accent1"/>
+          </a:effectRef>
+          <a:fontRef idx="minor">
+            <a:schemeClr val="lt1"/>
+          </a:fontRef>
+        </p:style>
+        <p:txBody>
+          <a:bodyPr rtlCol="0" anchor="ctr"/>
+          <a:lstStyle/>
+          <a:p>
+            <a:pPr algn="ctr"/>
+          </a:p>
+        </p:txBody>
+      </p:sp>
+      <p:sp>
+        <p:nvSpPr>
+          <p:cNvPr id="4" name="TextBox 3"/>
+          <p:cNvSpPr txBox="1"/>
+          <p:nvPr/>
+        </p:nvSpPr>
+        <p:spPr>
+          <a:xfrm>
+            <a:off x="457200" y="502920"/>
+            <a:ext cx="11430000" cy="822960"/>
+          </a:xfrm>
+          <a:prstGeom prst="rect">
+            <a:avLst/>
+          </a:prstGeom>
+          <a:noFill/>
+        </p:spPr>
+        <p:txBody>
+          <a:bodyPr wrap="square" lIns="45720" rIns="45720" tIns="18288" bIns="18288" anchor="t">
+            <a:spAutoFit/>
+          </a:bodyPr>
+          <a:lstStyle/>
+          <a:p>
+            <a:pPr algn="l"/>
+            <a:r>
+              <a:rPr sz="3000" b="0" i="0">
+                <a:solidFill>
+                  <a:srgbClr val="000000"/>
+                </a:solidFill>
+                <a:latin typeface="Calibri Light"/>
+              </a:rPr>
+              <a:t>SOFTWARE ROADMAP — ADVANCED FEATURES &amp; EASE OF USE: STATUS</a:t>
+            </a:r>
+          </a:p>
+        </p:txBody>
+      </p:sp>
+      <p:sp>
+        <p:nvSpPr>
+          <p:cNvPr id="5" name="TextBox 4"/>
+          <p:cNvSpPr txBox="1"/>
+          <p:nvPr/>
+        </p:nvSpPr>
+        <p:spPr>
+          <a:xfrm>
+            <a:off x="365760" y="1170432"/>
+            <a:ext cx="11475720" cy="566928"/>
+          </a:xfrm>
+          <a:prstGeom prst="rect">
+            <a:avLst/>
+          </a:prstGeom>
+          <a:noFill/>
+        </p:spPr>
+        <p:txBody>
+          <a:bodyPr wrap="square" lIns="45720" rIns="45720" tIns="18288" bIns="18288" anchor="t">
+            <a:spAutoFit/>
+          </a:bodyPr>
+          <a:lstStyle/>
+          <a:p>
+            <a:pPr algn="l"/>
+            <a:r>
+              <a:rPr sz="1200" b="0" i="0">
+                <a:solidFill>
+                  <a:srgbClr val="000000"/>
+                </a:solidFill>
+                <a:latin typeface="Calibri"/>
+              </a:rPr>
+              <a:t>The rig automated only ONE thing (auto-preload). A phased roadmap adds automated test modes, smart DIC and one-click analysis — each piece shippable on its own. Where it stands today:</a:t>
+            </a:r>
+          </a:p>
+        </p:txBody>
+      </p:sp>
+      <p:graphicFrame>
+        <p:nvGraphicFramePr>
+          <p:cNvPr id="6" name="Table 5"/>
+          <p:cNvGraphicFramePr>
+            <a:graphicFrameLocks noGrp="1"/>
+          </p:cNvGraphicFramePr>
+          <p:nvPr/>
+        </p:nvGraphicFramePr>
+        <p:xfrm>
+          <a:off x="365760" y="1847088"/>
+          <a:ext cx="11475720" cy="2514600"/>
+        </p:xfrm>
+        <a:graphic>
+          <a:graphicData uri="http://schemas.openxmlformats.org/drawingml/2006/table">
+            <a:tbl>
+              <a:tblPr firstRow="1" bandRow="1">
+                <a:tableStyleId>{5C22544A-7EE6-4342-B048-85BDC9FD1C3A}</a:tableStyleId>
+              </a:tblPr>
+              <a:tblGrid>
+                <a:gridCol w="2377440"/>
+                <a:gridCol w="6172200"/>
+                <a:gridCol w="2926080"/>
+              </a:tblGrid>
+              <a:tr h="419100">
+                <a:tc>
+                  <a:txBody>
+                    <a:bodyPr lIns="54864" rIns="54864" tIns="18288" bIns="18288" wrap="square" anchor="ctr"/>
+                    <a:lstStyle/>
+                    <a:p>
+                      <a:pPr algn="l"/>
+                      <a:r>
+                        <a:rPr sz="1100" b="1">
+                          <a:solidFill>
+                            <a:srgbClr val="FFFFFF"/>
+                          </a:solidFill>
+                          <a:latin typeface="Calibri"/>
+                        </a:rPr>
+                        <a:t>Phase</a:t>
+                      </a:r>
+                    </a:p>
+                  </a:txBody>
+                  <a:tcPr>
+                    <a:solidFill>
+                      <a:srgbClr val="143D2F"/>
+                    </a:solidFill>
+                  </a:tcPr>
+                </a:tc>
+                <a:tc>
+                  <a:txBody>
+                    <a:bodyPr lIns="54864" rIns="54864" tIns="18288" bIns="18288" wrap="square" anchor="ctr"/>
+                    <a:lstStyle/>
+                    <a:p>
+                      <a:pPr algn="l"/>
+                      <a:r>
+                        <a:rPr sz="1100" b="1">
+                          <a:solidFill>
+                            <a:srgbClr val="FFFFFF"/>
+                          </a:solidFill>
+                          <a:latin typeface="Calibri"/>
+                        </a:rPr>
+                        <a:t>Focus</a:t>
+                      </a:r>
+                    </a:p>
+                  </a:txBody>
+                  <a:tcPr>
+                    <a:solidFill>
+                      <a:srgbClr val="143D2F"/>
+                    </a:solidFill>
+                  </a:tcPr>
+                </a:tc>
+                <a:tc>
+                  <a:txBody>
+                    <a:bodyPr lIns="54864" rIns="54864" tIns="18288" bIns="18288" wrap="square" anchor="ctr"/>
+                    <a:lstStyle/>
+                    <a:p>
+                      <a:pPr algn="l"/>
+                      <a:r>
+                        <a:rPr sz="1100" b="1">
+                          <a:solidFill>
+                            <a:srgbClr val="FFFFFF"/>
+                          </a:solidFill>
+                          <a:latin typeface="Calibri"/>
+                        </a:rPr>
+                        <a:t>Status</a:t>
+                      </a:r>
+                    </a:p>
+                  </a:txBody>
+                  <a:tcPr>
+                    <a:solidFill>
+                      <a:srgbClr val="143D2F"/>
+                    </a:solidFill>
+                  </a:tcPr>
+                </a:tc>
+              </a:tr>
+              <a:tr h="419100">
+                <a:tc>
+                  <a:txBody>
+                    <a:bodyPr lIns="54864" rIns="54864" tIns="18288" bIns="18288" wrap="square" anchor="ctr"/>
+                    <a:lstStyle/>
+                    <a:p>
+                      <a:pPr algn="l"/>
+                      <a:r>
+                        <a:rPr sz="1050" b="0">
+                          <a:solidFill>
+                            <a:srgbClr val="000000"/>
+                          </a:solidFill>
+                          <a:latin typeface="Calibri"/>
+                        </a:rPr>
+                        <a:t>0 · Foundations</a:t>
+                      </a:r>
+                    </a:p>
+                  </a:txBody>
+                  <a:tcPr/>
+                </a:tc>
+                <a:tc>
+                  <a:txBody>
+                    <a:bodyPr lIns="54864" rIns="54864" tIns="18288" bIns="18288" wrap="square" anchor="ctr"/>
+                    <a:lstStyle/>
+                    <a:p>
+                      <a:pPr algn="l"/>
+                      <a:r>
+                        <a:rPr sz="1050" b="0">
+                          <a:solidFill>
+                            <a:srgbClr val="000000"/>
+                          </a:solidFill>
+                          <a:latin typeface="Calibri"/>
+                        </a:rPr>
+                        <a:t>shared analysis library · control engine · recipes</a:t>
+                      </a:r>
+                    </a:p>
+                  </a:txBody>
+                  <a:tcPr/>
+                </a:tc>
+                <a:tc>
+                  <a:txBody>
+                    <a:bodyPr lIns="54864" rIns="54864" tIns="18288" bIns="18288" wrap="square" anchor="ctr"/>
+                    <a:lstStyle/>
+                    <a:p>
+                      <a:pPr algn="l"/>
+                      <a:r>
+                        <a:rPr sz="1050" b="1">
+                          <a:solidFill>
+                            <a:srgbClr val="000000"/>
+                          </a:solidFill>
+                          <a:latin typeface="Calibri"/>
+                        </a:rPr>
+                        <a:t>DONE</a:t>
+                      </a:r>
+                    </a:p>
+                  </a:txBody>
+                  <a:tcPr>
+                    <a:solidFill>
+                      <a:srgbClr val="C8E6C9"/>
+                    </a:solidFill>
+                  </a:tcPr>
+                </a:tc>
+              </a:tr>
+              <a:tr h="419100">
+                <a:tc>
+                  <a:txBody>
+                    <a:bodyPr lIns="54864" rIns="54864" tIns="18288" bIns="18288" wrap="square" anchor="ctr"/>
+                    <a:lstStyle/>
+                    <a:p>
+                      <a:pPr algn="l"/>
+                      <a:r>
+                        <a:rPr sz="1050" b="0">
+                          <a:solidFill>
+                            <a:srgbClr val="000000"/>
+                          </a:solidFill>
+                          <a:latin typeface="Calibri"/>
+                        </a:rPr>
+                        <a:t>A · One-click workflow</a:t>
+                      </a:r>
+                    </a:p>
+                  </a:txBody>
+                  <a:tcPr/>
+                </a:tc>
+                <a:tc>
+                  <a:txBody>
+                    <a:bodyPr lIns="54864" rIns="54864" tIns="18288" bIns="18288" wrap="square" anchor="ctr"/>
+                    <a:lstStyle/>
+                    <a:p>
+                      <a:pPr algn="l"/>
+                      <a:r>
+                        <a:rPr sz="1050" b="0">
+                          <a:solidFill>
+                            <a:srgbClr val="000000"/>
+                          </a:solidFill>
+                          <a:latin typeface="Calibri"/>
+                        </a:rPr>
+                        <a:t>per-test report · test registry · prepare-specimen · auto-stop</a:t>
+                      </a:r>
+                    </a:p>
+                  </a:txBody>
+                  <a:tcPr/>
+                </a:tc>
+                <a:tc>
+                  <a:txBody>
+                    <a:bodyPr lIns="54864" rIns="54864" tIns="18288" bIns="18288" wrap="square" anchor="ctr"/>
+                    <a:lstStyle/>
+                    <a:p>
+                      <a:pPr algn="l"/>
+                      <a:r>
+                        <a:rPr sz="1050" b="1">
+                          <a:solidFill>
+                            <a:srgbClr val="000000"/>
+                          </a:solidFill>
+                          <a:latin typeface="Calibri"/>
+                        </a:rPr>
+                        <a:t>BUILT — rig-test</a:t>
+                      </a:r>
+                    </a:p>
+                  </a:txBody>
+                  <a:tcPr>
+                    <a:solidFill>
+                      <a:srgbClr val="FFF3CD"/>
+                    </a:solidFill>
+                  </a:tcPr>
+                </a:tc>
+              </a:tr>
+              <a:tr h="419100">
+                <a:tc>
+                  <a:txBody>
+                    <a:bodyPr lIns="54864" rIns="54864" tIns="18288" bIns="18288" wrap="square" anchor="ctr"/>
+                    <a:lstStyle/>
+                    <a:p>
+                      <a:pPr algn="l"/>
+                      <a:r>
+                        <a:rPr sz="1050" b="0">
+                          <a:solidFill>
+                            <a:srgbClr val="000000"/>
+                          </a:solidFill>
+                          <a:latin typeface="Calibri"/>
+                        </a:rPr>
+                        <a:t>B · Closed-loop modes</a:t>
+                      </a:r>
+                    </a:p>
+                  </a:txBody>
+                  <a:tcPr/>
+                </a:tc>
+                <a:tc>
+                  <a:txBody>
+                    <a:bodyPr lIns="54864" rIns="54864" tIns="18288" bIns="18288" wrap="square" anchor="ctr"/>
+                    <a:lstStyle/>
+                    <a:p>
+                      <a:pPr algn="l"/>
+                      <a:r>
+                        <a:rPr sz="1050" b="0">
+                          <a:solidFill>
+                            <a:srgbClr val="000000"/>
+                          </a:solidFill>
+                          <a:latin typeface="Calibri"/>
+                        </a:rPr>
+                        <a:t>strain-rate + cyclic / staircase / relaxation / creep</a:t>
+                      </a:r>
+                    </a:p>
+                  </a:txBody>
+                  <a:tcPr/>
+                </a:tc>
+                <a:tc>
+                  <a:txBody>
+                    <a:bodyPr lIns="54864" rIns="54864" tIns="18288" bIns="18288" wrap="square" anchor="ctr"/>
+                    <a:lstStyle/>
+                    <a:p>
+                      <a:pPr algn="l"/>
+                      <a:r>
+                        <a:rPr sz="1050" b="1">
+                          <a:solidFill>
+                            <a:srgbClr val="000000"/>
+                          </a:solidFill>
+                          <a:latin typeface="Calibri"/>
+                        </a:rPr>
+                        <a:t>1 of 5 wired</a:t>
+                      </a:r>
+                    </a:p>
+                  </a:txBody>
+                  <a:tcPr>
+                    <a:solidFill>
+                      <a:srgbClr val="FFF3CD"/>
+                    </a:solidFill>
+                  </a:tcPr>
+                </a:tc>
+              </a:tr>
+              <a:tr h="419100">
+                <a:tc>
+                  <a:txBody>
+                    <a:bodyPr lIns="54864" rIns="54864" tIns="18288" bIns="18288" wrap="square" anchor="ctr"/>
+                    <a:lstStyle/>
+                    <a:p>
+                      <a:pPr algn="l"/>
+                      <a:r>
+                        <a:rPr sz="1050" b="0">
+                          <a:solidFill>
+                            <a:srgbClr val="000000"/>
+                          </a:solidFill>
+                          <a:latin typeface="Calibri"/>
+                        </a:rPr>
+                        <a:t>C · Smart DIC</a:t>
+                      </a:r>
+                    </a:p>
+                  </a:txBody>
+                  <a:tcPr/>
+                </a:tc>
+                <a:tc>
+                  <a:txBody>
+                    <a:bodyPr lIns="54864" rIns="54864" tIns="18288" bIns="18288" wrap="square" anchor="ctr"/>
+                    <a:lstStyle/>
+                    <a:p>
+                      <a:pPr algn="l"/>
+                      <a:r>
+                        <a:rPr sz="1050" b="0">
+                          <a:solidFill>
+                            <a:srgbClr val="000000"/>
+                          </a:solidFill>
+                          <a:latin typeface="Calibri"/>
+                        </a:rPr>
+                        <a:t>live health HUD + measured Poisson / true Cauchy</a:t>
+                      </a:r>
+                    </a:p>
+                  </a:txBody>
+                  <a:tcPr/>
+                </a:tc>
+                <a:tc>
+                  <a:txBody>
+                    <a:bodyPr lIns="54864" rIns="54864" tIns="18288" bIns="18288" wrap="square" anchor="ctr"/>
+                    <a:lstStyle/>
+                    <a:p>
+                      <a:pPr algn="l"/>
+                      <a:r>
+                        <a:rPr sz="1050" b="1">
+                          <a:solidFill>
+                            <a:srgbClr val="000000"/>
+                          </a:solidFill>
+                          <a:latin typeface="Calibri"/>
+                        </a:rPr>
+                        <a:t>HUD done</a:t>
+                      </a:r>
+                    </a:p>
+                  </a:txBody>
+                  <a:tcPr>
+                    <a:solidFill>
+                      <a:srgbClr val="FFF3CD"/>
+                    </a:solidFill>
+                  </a:tcPr>
+                </a:tc>
+              </a:tr>
+              <a:tr h="419100">
+                <a:tc>
+                  <a:txBody>
+                    <a:bodyPr lIns="54864" rIns="54864" tIns="18288" bIns="18288" wrap="square" anchor="ctr"/>
+                    <a:lstStyle/>
+                    <a:p>
+                      <a:pPr algn="l"/>
+                      <a:r>
+                        <a:rPr sz="1050" b="0">
+                          <a:solidFill>
+                            <a:srgbClr val="000000"/>
+                          </a:solidFill>
+                          <a:latin typeface="Calibri"/>
+                        </a:rPr>
+                        <a:t>D · UX layer</a:t>
+                      </a:r>
+                    </a:p>
+                  </a:txBody>
+                  <a:tcPr/>
+                </a:tc>
+                <a:tc>
+                  <a:txBody>
+                    <a:bodyPr lIns="54864" rIns="54864" tIns="18288" bIns="18288" wrap="square" anchor="ctr"/>
+                    <a:lstStyle/>
+                    <a:p>
+                      <a:pPr algn="l"/>
+                      <a:r>
+                        <a:rPr sz="1050" b="0">
+                          <a:solidFill>
+                            <a:srgbClr val="000000"/>
+                          </a:solidFill>
+                          <a:latin typeface="Calibri"/>
+                        </a:rPr>
+                        <a:t>guided wizard · live overlay · dashboard</a:t>
+                      </a:r>
+                    </a:p>
+                  </a:txBody>
+                  <a:tcPr/>
+                </a:tc>
+                <a:tc>
+                  <a:txBody>
+                    <a:bodyPr lIns="54864" rIns="54864" tIns="18288" bIns="18288" wrap="square" anchor="ctr"/>
+                    <a:lstStyle/>
+                    <a:p>
+                      <a:pPr algn="l"/>
+                      <a:r>
+                        <a:rPr sz="1050" b="1">
+                          <a:solidFill>
+                            <a:srgbClr val="000000"/>
+                          </a:solidFill>
+                          <a:latin typeface="Calibri"/>
+                        </a:rPr>
+                        <a:t>PLANNED</a:t>
+                      </a:r>
+                    </a:p>
+                  </a:txBody>
+                  <a:tcPr>
+                    <a:solidFill>
+                      <a:srgbClr val="E8E8E8"/>
+                    </a:solidFill>
+                  </a:tcPr>
+                </a:tc>
+              </a:tr>
+            </a:tbl>
+          </a:graphicData>
+        </a:graphic>
+      </p:graphicFrame>
+      <p:sp>
+        <p:nvSpPr>
+          <p:cNvPr id="7" name="Rounded Rectangle 6"/>
+          <p:cNvSpPr/>
+          <p:nvPr/>
+        </p:nvSpPr>
+        <p:spPr>
+          <a:xfrm>
+            <a:off x="365760" y="4590288"/>
+            <a:ext cx="2697480" cy="896112"/>
+          </a:xfrm>
+          <a:prstGeom prst="roundRect">
+            <a:avLst/>
+          </a:prstGeom>
+          <a:solidFill>
+            <a:srgbClr val="E7F1F8"/>
+          </a:solidFill>
+          <a:ln>
+            <a:noFill/>
+          </a:ln>
+        </p:spPr>
+        <p:style>
+          <a:lnRef idx="1">
+            <a:schemeClr val="accent1"/>
+          </a:lnRef>
+          <a:fillRef idx="3">
+            <a:schemeClr val="accent1"/>
+          </a:fillRef>
+          <a:effectRef idx="2">
+            <a:schemeClr val="accent1"/>
+          </a:effectRef>
+          <a:fontRef idx="minor">
+            <a:schemeClr val="lt1"/>
+          </a:fontRef>
+        </p:style>
+        <p:txBody>
+          <a:bodyPr rtlCol="0" anchor="ctr" lIns="54864" rIns="54864" bIns="27432" wrap="square"/>
+          <a:lstStyle/>
+          <a:p>
+            <a:pPr algn="ctr"/>
+            <a:r>
+              <a:rPr sz="1800" b="1">
+                <a:solidFill>
+                  <a:srgbClr val="1F3F2F"/>
+                </a:solidFill>
+                <a:latin typeface="Calibri"/>
+              </a:rPr>
+              <a:t>7</a:t>
+            </a:r>
+          </a:p>
+          <a:p>
+            <a:pPr algn="ctr"/>
+            <a:r>
+              <a:rPr sz="950">
+                <a:solidFill>
+                  <a:srgbClr val="000000"/>
+                </a:solidFill>
+                <a:latin typeface="Calibri"/>
+              </a:rPr>
+              <a:t>MODULES (in git)</a:t>
+            </a:r>
+          </a:p>
+        </p:txBody>
+      </p:sp>
+      <p:sp>
+        <p:nvSpPr>
+          <p:cNvPr id="8" name="Rounded Rectangle 7"/>
+          <p:cNvSpPr/>
+          <p:nvPr/>
+        </p:nvSpPr>
+        <p:spPr>
+          <a:xfrm>
+            <a:off x="3310128" y="4590288"/>
+            <a:ext cx="2697480" cy="896112"/>
+          </a:xfrm>
+          <a:prstGeom prst="roundRect">
+            <a:avLst/>
+          </a:prstGeom>
+          <a:solidFill>
+            <a:srgbClr val="E7F1F8"/>
+          </a:solidFill>
+          <a:ln>
+            <a:noFill/>
+          </a:ln>
+        </p:spPr>
+        <p:style>
+          <a:lnRef idx="1">
+            <a:schemeClr val="accent1"/>
+          </a:lnRef>
+          <a:fillRef idx="3">
+            <a:schemeClr val="accent1"/>
+          </a:fillRef>
+          <a:effectRef idx="2">
+            <a:schemeClr val="accent1"/>
+          </a:effectRef>
+          <a:fontRef idx="minor">
+            <a:schemeClr val="lt1"/>
+          </a:fontRef>
+        </p:style>
+        <p:txBody>
+          <a:bodyPr rtlCol="0" anchor="ctr" lIns="54864" rIns="54864" bIns="27432" wrap="square"/>
+          <a:lstStyle/>
+          <a:p>
+            <a:pPr algn="ctr"/>
+            <a:r>
+              <a:rPr sz="1800" b="1">
+                <a:solidFill>
+                  <a:srgbClr val="1F3F2F"/>
+                </a:solidFill>
+                <a:latin typeface="Calibri"/>
+              </a:rPr>
+              <a:t>6</a:t>
+            </a:r>
+          </a:p>
+          <a:p>
+            <a:pPr algn="ctr"/>
+            <a:r>
+              <a:rPr sz="950">
+                <a:solidFill>
+                  <a:srgbClr val="000000"/>
+                </a:solidFill>
+                <a:latin typeface="Calibri"/>
+              </a:rPr>
+              <a:t>APP FEATURES</a:t>
+            </a:r>
+          </a:p>
+        </p:txBody>
+      </p:sp>
+      <p:sp>
+        <p:nvSpPr>
+          <p:cNvPr id="9" name="Rounded Rectangle 8"/>
+          <p:cNvSpPr/>
+          <p:nvPr/>
+        </p:nvSpPr>
+        <p:spPr>
+          <a:xfrm>
+            <a:off x="6254496" y="4590288"/>
+            <a:ext cx="2697480" cy="896112"/>
+          </a:xfrm>
+          <a:prstGeom prst="roundRect">
+            <a:avLst/>
+          </a:prstGeom>
+          <a:solidFill>
+            <a:srgbClr val="E7F1F8"/>
+          </a:solidFill>
+          <a:ln>
+            <a:noFill/>
+          </a:ln>
+        </p:spPr>
+        <p:style>
+          <a:lnRef idx="1">
+            <a:schemeClr val="accent1"/>
+          </a:lnRef>
+          <a:fillRef idx="3">
+            <a:schemeClr val="accent1"/>
+          </a:fillRef>
+          <a:effectRef idx="2">
+            <a:schemeClr val="accent1"/>
+          </a:effectRef>
+          <a:fontRef idx="minor">
+            <a:schemeClr val="lt1"/>
+          </a:fontRef>
+        </p:style>
+        <p:txBody>
+          <a:bodyPr rtlCol="0" anchor="ctr" lIns="54864" rIns="54864" bIns="27432" wrap="square"/>
+          <a:lstStyle/>
+          <a:p>
+            <a:pPr algn="ctr"/>
+            <a:r>
+              <a:rPr sz="1800" b="1">
+                <a:solidFill>
+                  <a:srgbClr val="1F3F2F"/>
+                </a:solidFill>
+                <a:latin typeface="Calibri"/>
+              </a:rPr>
+              <a:t>9 / 9</a:t>
+            </a:r>
+          </a:p>
+          <a:p>
+            <a:pPr algn="ctr"/>
+            <a:r>
+              <a:rPr sz="950">
+                <a:solidFill>
+                  <a:srgbClr val="000000"/>
+                </a:solidFill>
+                <a:latin typeface="Calibri"/>
+              </a:rPr>
+              <a:t>SIM CHECKS PASSED</a:t>
+            </a:r>
+          </a:p>
+        </p:txBody>
+      </p:sp>
+      <p:sp>
+        <p:nvSpPr>
+          <p:cNvPr id="10" name="Rounded Rectangle 9"/>
+          <p:cNvSpPr/>
+          <p:nvPr/>
+        </p:nvSpPr>
+        <p:spPr>
+          <a:xfrm>
+            <a:off x="9198864" y="4590288"/>
+            <a:ext cx="2642616" cy="896112"/>
+          </a:xfrm>
+          <a:prstGeom prst="roundRect">
+            <a:avLst/>
+          </a:prstGeom>
+          <a:solidFill>
+            <a:srgbClr val="E7F1F8"/>
+          </a:solidFill>
+          <a:ln>
+            <a:noFill/>
+          </a:ln>
+        </p:spPr>
+        <p:style>
+          <a:lnRef idx="1">
+            <a:schemeClr val="accent1"/>
+          </a:lnRef>
+          <a:fillRef idx="3">
+            <a:schemeClr val="accent1"/>
+          </a:fillRef>
+          <a:effectRef idx="2">
+            <a:schemeClr val="accent1"/>
+          </a:effectRef>
+          <a:fontRef idx="minor">
+            <a:schemeClr val="lt1"/>
+          </a:fontRef>
+        </p:style>
+        <p:txBody>
+          <a:bodyPr rtlCol="0" anchor="ctr" lIns="54864" rIns="54864" bIns="27432" wrap="square"/>
+          <a:lstStyle/>
+          <a:p>
+            <a:pPr algn="ctr"/>
+            <a:r>
+              <a:rPr sz="1800" b="1">
+                <a:solidFill>
+                  <a:srgbClr val="1F3F2F"/>
+                </a:solidFill>
+                <a:latin typeface="Calibri"/>
+              </a:rPr>
+              <a:t>6</a:t>
+            </a:r>
+          </a:p>
+          <a:p>
+            <a:pPr algn="ctr"/>
+            <a:r>
+              <a:rPr sz="950">
+                <a:solidFill>
+                  <a:srgbClr val="000000"/>
+                </a:solidFill>
+                <a:latin typeface="Calibri"/>
+              </a:rPr>
+              <a:t>TO RIG-TEST</a:t>
+            </a:r>
+          </a:p>
+        </p:txBody>
+      </p:sp>
+      <p:sp>
+        <p:nvSpPr>
+          <p:cNvPr id="11" name="Rectangle 10"/>
+          <p:cNvSpPr/>
+          <p:nvPr/>
+        </p:nvSpPr>
+        <p:spPr>
+          <a:xfrm>
+            <a:off x="365760" y="5650992"/>
+            <a:ext cx="11475720" cy="841248"/>
+          </a:xfrm>
+          <a:prstGeom prst="rect">
+            <a:avLst/>
+          </a:prstGeom>
+          <a:solidFill>
+            <a:srgbClr val="E7F1F8"/>
+          </a:solidFill>
+          <a:ln>
+            <a:noFill/>
+          </a:ln>
+        </p:spPr>
+        <p:style>
+          <a:lnRef idx="1">
+            <a:schemeClr val="accent1"/>
+          </a:lnRef>
+          <a:fillRef idx="3">
+            <a:schemeClr val="accent1"/>
+          </a:fillRef>
+          <a:effectRef idx="2">
+            <a:schemeClr val="accent1"/>
+          </a:effectRef>
+          <a:fontRef idx="minor">
+            <a:schemeClr val="lt1"/>
+          </a:fontRef>
+        </p:style>
+        <p:txBody>
+          <a:bodyPr rtlCol="0" anchor="ctr" wrap="square" lIns="109728" rIns="109728"/>
+          <a:lstStyle/>
+          <a:p>
+            <a:pPr algn="ctr"/>
+            <a:r>
+              <a:rPr sz="1100" b="1">
+                <a:solidFill>
+                  <a:srgbClr val="000000"/>
+                </a:solidFill>
+                <a:latin typeface="Calibri"/>
+              </a:rPr>
+              <a:t>LEGEND — DONE (green) · BUILT, awaiting rig test (amber) · PLANNED (grey).  Foundations + the one-click workflow have shipped; closed-loop modes and smart-DIC are partly in; the UX layer is next.</a:t>
+            </a:r>
+          </a:p>
+        </p:txBody>
+      </p:sp>
+      <p:sp>
+        <p:nvSpPr>
+          <p:cNvPr id="12" name="TextBox 11"/>
+          <p:cNvSpPr txBox="1"/>
+          <p:nvPr/>
+        </p:nvSpPr>
+        <p:spPr>
+          <a:xfrm>
+            <a:off x="548640" y="6400800"/>
+            <a:ext cx="11064240" cy="365760"/>
+          </a:xfrm>
+          <a:prstGeom prst="rect">
+            <a:avLst/>
+          </a:prstGeom>
+          <a:noFill/>
+        </p:spPr>
+        <p:txBody>
+          <a:bodyPr wrap="square" lIns="45720" rIns="45720" tIns="18288" bIns="18288" anchor="t">
+            <a:spAutoFit/>
+          </a:bodyPr>
+          <a:lstStyle/>
+          <a:p>
+            <a:pPr algn="l"/>
+            <a:r>
+              <a:rPr sz="1200" b="0" i="1">
+                <a:solidFill>
+                  <a:srgbClr val="707070"/>
+                </a:solidFill>
+                <a:latin typeface="Calibri"/>
+              </a:rPr>
+              <a:t>All analysis logic is unit-tested / sim-validated offline; app features live in the (unversioned) main.py and follow the proven auto-preload safety discipline.</a:t>
+            </a:r>
+          </a:p>
+        </p:txBody>
+      </p:sp>
+      <p:sp>
+        <p:nvSpPr>
+          <p:cNvPr id="13" name="TextBox 12"/>
+          <p:cNvSpPr txBox="1"/>
+          <p:nvPr/>
+        </p:nvSpPr>
+        <p:spPr>
+          <a:xfrm>
+            <a:off x="457200" y="6446520"/>
+            <a:ext cx="640080" cy="274320"/>
+          </a:xfrm>
+          <a:prstGeom prst="rect">
+            <a:avLst/>
+          </a:prstGeom>
+          <a:noFill/>
+        </p:spPr>
+        <p:txBody>
+          <a:bodyPr wrap="square" lIns="45720" rIns="45720" tIns="18288" bIns="18288" anchor="t">
+            <a:spAutoFit/>
+          </a:bodyPr>
+          <a:lstStyle/>
+          <a:p>
+            <a:pPr algn="l"/>
+            <a:r>
+              <a:rPr sz="1000" b="0" i="0">
+                <a:solidFill>
+                  <a:srgbClr val="707070"/>
+                </a:solidFill>
+                <a:latin typeface="Calibri"/>
+              </a:rPr>
+              <a:t>165</a:t>
+            </a:r>
+          </a:p>
+        </p:txBody>
+      </p:sp>
+    </p:spTree>
+  </p:cSld>
+  <p:clrMapOvr>
+    <a:masterClrMapping/>
+  </p:clrMapOvr>
+</p:sld>
+</file>
+
+<file path=ppt/slides/slide26.xml><?xml version="1.0" encoding="utf-8"?>
+<p:sld xmlns:a="http://schemas.openxmlformats.org/drawingml/2006/main" xmlns:p="http://schemas.openxmlformats.org/presentationml/2006/main" xmlns:r="http://schemas.openxmlformats.org/officeDocument/2006/relationships">
+  <p:cSld>
+    <p:spTree>
+      <p:nvGrpSpPr>
+        <p:cNvPr id="1" name=""/>
+        <p:cNvGrpSpPr/>
+        <p:nvPr/>
+      </p:nvGrpSpPr>
+      <p:grpSpPr/>
+      <p:sp>
+        <p:nvSpPr>
+          <p:cNvPr id="2" name="TextBox 1"/>
+          <p:cNvSpPr txBox="1"/>
+          <p:nvPr/>
+        </p:nvSpPr>
+        <p:spPr>
+          <a:xfrm>
+            <a:off x="11155680" y="274320"/>
+            <a:ext cx="914400" cy="274320"/>
+          </a:xfrm>
+          <a:prstGeom prst="rect">
+            <a:avLst/>
+          </a:prstGeom>
+          <a:noFill/>
+        </p:spPr>
+        <p:txBody>
+          <a:bodyPr wrap="square" lIns="45720" rIns="45720" tIns="18288" bIns="18288" anchor="t">
+            <a:spAutoFit/>
+          </a:bodyPr>
+          <a:lstStyle/>
+          <a:p>
+            <a:pPr algn="r"/>
+            <a:r>
+              <a:rPr sz="800" b="1" i="0">
+                <a:solidFill>
+                  <a:srgbClr val="707070"/>
+                </a:solidFill>
+                <a:latin typeface="Calibri"/>
+              </a:rPr>
+              <a:t>JÖNKÖPING UNIVERSITY</a:t>
+            </a:r>
+          </a:p>
+        </p:txBody>
+      </p:sp>
+      <p:sp>
+        <p:nvSpPr>
+          <p:cNvPr id="3" name="Rectangle 2"/>
+          <p:cNvSpPr/>
+          <p:nvPr/>
+        </p:nvSpPr>
+        <p:spPr>
+          <a:xfrm>
+            <a:off x="457200" y="411480"/>
+            <a:ext cx="457200" cy="73152"/>
+          </a:xfrm>
+          <a:prstGeom prst="rect">
+            <a:avLst/>
+          </a:prstGeom>
+          <a:solidFill>
+            <a:srgbClr val="A9D6EF"/>
+          </a:solidFill>
+          <a:ln>
+            <a:noFill/>
+          </a:ln>
+        </p:spPr>
+        <p:style>
+          <a:lnRef idx="1">
+            <a:schemeClr val="accent1"/>
+          </a:lnRef>
+          <a:fillRef idx="3">
+            <a:schemeClr val="accent1"/>
+          </a:fillRef>
+          <a:effectRef idx="2">
+            <a:schemeClr val="accent1"/>
+          </a:effectRef>
+          <a:fontRef idx="minor">
+            <a:schemeClr val="lt1"/>
+          </a:fontRef>
+        </p:style>
+        <p:txBody>
+          <a:bodyPr rtlCol="0" anchor="ctr"/>
+          <a:lstStyle/>
+          <a:p>
+            <a:pPr algn="ctr"/>
+          </a:p>
+        </p:txBody>
+      </p:sp>
+      <p:sp>
+        <p:nvSpPr>
+          <p:cNvPr id="4" name="TextBox 3"/>
+          <p:cNvSpPr txBox="1"/>
+          <p:nvPr/>
+        </p:nvSpPr>
+        <p:spPr>
+          <a:xfrm>
+            <a:off x="457200" y="502920"/>
+            <a:ext cx="11430000" cy="822960"/>
+          </a:xfrm>
+          <a:prstGeom prst="rect">
+            <a:avLst/>
+          </a:prstGeom>
+          <a:noFill/>
+        </p:spPr>
+        <p:txBody>
+          <a:bodyPr wrap="square" lIns="45720" rIns="45720" tIns="18288" bIns="18288" anchor="t">
+            <a:spAutoFit/>
+          </a:bodyPr>
+          <a:lstStyle/>
+          <a:p>
+            <a:pPr algn="l"/>
+            <a:r>
+              <a:rPr sz="3000" b="0" i="0">
+                <a:solidFill>
+                  <a:srgbClr val="000000"/>
+                </a:solidFill>
+                <a:latin typeface="Calibri Light"/>
+              </a:rPr>
+              <a:t>DONE — BUILT, VERIFIED &amp; COMMITTED</a:t>
+            </a:r>
+          </a:p>
+        </p:txBody>
+      </p:sp>
+      <p:sp>
+        <p:nvSpPr>
+          <p:cNvPr id="5" name="TextBox 4"/>
+          <p:cNvSpPr txBox="1"/>
+          <p:nvPr/>
+        </p:nvSpPr>
+        <p:spPr>
+          <a:xfrm>
+            <a:off x="365760" y="1170432"/>
+            <a:ext cx="5623560" cy="365760"/>
+          </a:xfrm>
+          <a:prstGeom prst="rect">
+            <a:avLst/>
+          </a:prstGeom>
+          <a:noFill/>
+        </p:spPr>
+        <p:txBody>
+          <a:bodyPr wrap="square" lIns="45720" rIns="45720" tIns="18288" bIns="18288" anchor="t">
+            <a:spAutoFit/>
+          </a:bodyPr>
+          <a:lstStyle/>
+          <a:p>
+            <a:pPr algn="l"/>
+            <a:r>
+              <a:rPr sz="1600" b="0" i="0">
+                <a:solidFill>
+                  <a:srgbClr val="707070"/>
+                </a:solidFill>
+                <a:latin typeface="Calibri"/>
+              </a:rPr>
+              <a:t>Analysis &amp; workflow tooling (offline-verified, in git)</a:t>
+            </a:r>
+          </a:p>
+        </p:txBody>
+      </p:sp>
+      <p:graphicFrame>
+        <p:nvGraphicFramePr>
+          <p:cNvPr id="6" name="Table 5"/>
+          <p:cNvGraphicFramePr>
+            <a:graphicFrameLocks noGrp="1"/>
+          </p:cNvGraphicFramePr>
+          <p:nvPr/>
+        </p:nvGraphicFramePr>
+        <p:xfrm>
+          <a:off x="365760" y="1554480"/>
+          <a:ext cx="5623559" cy="2834640"/>
+        </p:xfrm>
+        <a:graphic>
+          <a:graphicData uri="http://schemas.openxmlformats.org/drawingml/2006/table">
+            <a:tbl>
+              <a:tblPr firstRow="1" bandRow="1">
+                <a:tableStyleId>{5C22544A-7EE6-4342-B048-85BDC9FD1C3A}</a:tableStyleId>
+              </a:tblPr>
+              <a:tblGrid>
+                <a:gridCol w="2057400"/>
+                <a:gridCol w="3566159"/>
+              </a:tblGrid>
+              <a:tr h="404948">
+                <a:tc>
+                  <a:txBody>
+                    <a:bodyPr lIns="54864" rIns="54864" tIns="18288" bIns="18288" wrap="square" anchor="ctr"/>
+                    <a:lstStyle/>
+                    <a:p>
+                      <a:pPr algn="l"/>
+                      <a:r>
+                        <a:rPr sz="1000" b="1">
+                          <a:solidFill>
+                            <a:srgbClr val="FFFFFF"/>
+                          </a:solidFill>
+                          <a:latin typeface="Calibri"/>
+                        </a:rPr>
+                        <a:t>Module</a:t>
+                      </a:r>
+                    </a:p>
+                  </a:txBody>
+                  <a:tcPr>
+                    <a:solidFill>
+                      <a:srgbClr val="143D2F"/>
+                    </a:solidFill>
+                  </a:tcPr>
+                </a:tc>
+                <a:tc>
+                  <a:txBody>
+                    <a:bodyPr lIns="54864" rIns="54864" tIns="18288" bIns="18288" wrap="square" anchor="ctr"/>
+                    <a:lstStyle/>
+                    <a:p>
+                      <a:pPr algn="l"/>
+                      <a:r>
+                        <a:rPr sz="1000" b="1">
+                          <a:solidFill>
+                            <a:srgbClr val="FFFFFF"/>
+                          </a:solidFill>
+                          <a:latin typeface="Calibri"/>
+                        </a:rPr>
+                        <a:t>What it gives you</a:t>
+                      </a:r>
+                    </a:p>
+                  </a:txBody>
+                  <a:tcPr>
+                    <a:solidFill>
+                      <a:srgbClr val="143D2F"/>
+                    </a:solidFill>
+                  </a:tcPr>
+                </a:tc>
+              </a:tr>
+              <a:tr h="404948">
+                <a:tc>
+                  <a:txBody>
+                    <a:bodyPr lIns="54864" rIns="54864" tIns="18288" bIns="18288" wrap="square" anchor="ctr"/>
+                    <a:lstStyle/>
+                    <a:p>
+                      <a:pPr algn="l"/>
+                      <a:r>
+                        <a:rPr sz="950" b="0">
+                          <a:solidFill>
+                            <a:srgbClr val="000000"/>
+                          </a:solidFill>
+                          <a:latin typeface="Calibri"/>
+                        </a:rPr>
+                        <a:t>utm_analysis.py</a:t>
+                      </a:r>
+                    </a:p>
+                  </a:txBody>
+                  <a:tcPr/>
+                </a:tc>
+                <a:tc>
+                  <a:txBody>
+                    <a:bodyPr lIns="54864" rIns="54864" tIns="18288" bIns="18288" wrap="square" anchor="ctr"/>
+                    <a:lstStyle/>
+                    <a:p>
+                      <a:pPr algn="l"/>
+                      <a:r>
+                        <a:rPr sz="950" b="0">
+                          <a:solidFill>
+                            <a:srgbClr val="000000"/>
+                          </a:solidFill>
+                          <a:latin typeface="Calibri"/>
+                        </a:rPr>
+                        <a:t>ONE fracture detector + E / σy / UTS / εf / anchor</a:t>
+                      </a:r>
+                    </a:p>
+                  </a:txBody>
+                  <a:tcPr/>
+                </a:tc>
+              </a:tr>
+              <a:tr h="404948">
+                <a:tc>
+                  <a:txBody>
+                    <a:bodyPr lIns="54864" rIns="54864" tIns="18288" bIns="18288" wrap="square" anchor="ctr"/>
+                    <a:lstStyle/>
+                    <a:p>
+                      <a:pPr algn="l"/>
+                      <a:r>
+                        <a:rPr sz="950" b="0">
+                          <a:solidFill>
+                            <a:srgbClr val="000000"/>
+                          </a:solidFill>
+                          <a:latin typeface="Calibri"/>
+                        </a:rPr>
+                        <a:t>utm_report.py</a:t>
+                      </a:r>
+                    </a:p>
+                  </a:txBody>
+                  <a:tcPr/>
+                </a:tc>
+                <a:tc>
+                  <a:txBody>
+                    <a:bodyPr lIns="54864" rIns="54864" tIns="18288" bIns="18288" wrap="square" anchor="ctr"/>
+                    <a:lstStyle/>
+                    <a:p>
+                      <a:pPr algn="l"/>
+                      <a:r>
+                        <a:rPr sz="950" b="0">
+                          <a:solidFill>
+                            <a:srgbClr val="000000"/>
+                          </a:solidFill>
+                          <a:latin typeface="Calibri"/>
+                        </a:rPr>
+                        <a:t>one-click per-test PDF + PNG report</a:t>
+                      </a:r>
+                    </a:p>
+                  </a:txBody>
+                  <a:tcPr/>
+                </a:tc>
+              </a:tr>
+              <a:tr h="404948">
+                <a:tc>
+                  <a:txBody>
+                    <a:bodyPr lIns="54864" rIns="54864" tIns="18288" bIns="18288" wrap="square" anchor="ctr"/>
+                    <a:lstStyle/>
+                    <a:p>
+                      <a:pPr algn="l"/>
+                      <a:r>
+                        <a:rPr sz="950" b="0">
+                          <a:solidFill>
+                            <a:srgbClr val="000000"/>
+                          </a:solidFill>
+                          <a:latin typeface="Calibri"/>
+                        </a:rPr>
+                        <a:t>utm_registry.py</a:t>
+                      </a:r>
+                    </a:p>
+                  </a:txBody>
+                  <a:tcPr/>
+                </a:tc>
+                <a:tc>
+                  <a:txBody>
+                    <a:bodyPr lIns="54864" rIns="54864" tIns="18288" bIns="18288" wrap="square" anchor="ctr"/>
+                    <a:lstStyle/>
+                    <a:p>
+                      <a:pPr algn="l"/>
+                      <a:r>
+                        <a:rPr sz="950" b="0">
+                          <a:solidFill>
+                            <a:srgbClr val="000000"/>
+                          </a:solidFill>
+                          <a:latin typeface="Calibri"/>
+                        </a:rPr>
+                        <a:t>one table of EVERY test (props + anchor)</a:t>
+                      </a:r>
+                    </a:p>
+                  </a:txBody>
+                  <a:tcPr/>
+                </a:tc>
+              </a:tr>
+              <a:tr h="404948">
+                <a:tc>
+                  <a:txBody>
+                    <a:bodyPr lIns="54864" rIns="54864" tIns="18288" bIns="18288" wrap="square" anchor="ctr"/>
+                    <a:lstStyle/>
+                    <a:p>
+                      <a:pPr algn="l"/>
+                      <a:r>
+                        <a:rPr sz="950" b="0">
+                          <a:solidFill>
+                            <a:srgbClr val="000000"/>
+                          </a:solidFill>
+                          <a:latin typeface="Calibri"/>
+                        </a:rPr>
+                        <a:t>utm_recipes.py</a:t>
+                      </a:r>
+                    </a:p>
+                  </a:txBody>
+                  <a:tcPr/>
+                </a:tc>
+                <a:tc>
+                  <a:txBody>
+                    <a:bodyPr lIns="54864" rIns="54864" tIns="18288" bIns="18288" wrap="square" anchor="ctr"/>
+                    <a:lstStyle/>
+                    <a:p>
+                      <a:pPr algn="l"/>
+                      <a:r>
+                        <a:rPr sz="950" b="0">
+                          <a:solidFill>
+                            <a:srgbClr val="000000"/>
+                          </a:solidFill>
+                          <a:latin typeface="Calibri"/>
+                        </a:rPr>
+                        <a:t>save / load a full test setup</a:t>
+                      </a:r>
+                    </a:p>
+                  </a:txBody>
+                  <a:tcPr/>
+                </a:tc>
+              </a:tr>
+              <a:tr h="404948">
+                <a:tc>
+                  <a:txBody>
+                    <a:bodyPr lIns="54864" rIns="54864" tIns="18288" bIns="18288" wrap="square" anchor="ctr"/>
+                    <a:lstStyle/>
+                    <a:p>
+                      <a:pPr algn="l"/>
+                      <a:r>
+                        <a:rPr sz="950" b="0">
+                          <a:solidFill>
+                            <a:srgbClr val="000000"/>
+                          </a:solidFill>
+                          <a:latin typeface="Calibri"/>
+                        </a:rPr>
+                        <a:t>control_policies + _sim</a:t>
+                      </a:r>
+                    </a:p>
+                  </a:txBody>
+                  <a:tcPr/>
+                </a:tc>
+                <a:tc>
+                  <a:txBody>
+                    <a:bodyPr lIns="54864" rIns="54864" tIns="18288" bIns="18288" wrap="square" anchor="ctr"/>
+                    <a:lstStyle/>
+                    <a:p>
+                      <a:pPr algn="l"/>
+                      <a:r>
+                        <a:rPr sz="950" b="0">
+                          <a:solidFill>
+                            <a:srgbClr val="000000"/>
+                          </a:solidFill>
+                          <a:latin typeface="Calibri"/>
+                        </a:rPr>
+                        <a:t>closed-loop test-mode engine — 9/9 sim</a:t>
+                      </a:r>
+                    </a:p>
+                  </a:txBody>
+                  <a:tcPr/>
+                </a:tc>
+              </a:tr>
+              <a:tr h="404952">
+                <a:tc>
+                  <a:txBody>
+                    <a:bodyPr lIns="54864" rIns="54864" tIns="18288" bIns="18288" wrap="square" anchor="ctr"/>
+                    <a:lstStyle/>
+                    <a:p>
+                      <a:pPr algn="l"/>
+                      <a:r>
+                        <a:rPr sz="950" b="0">
+                          <a:solidFill>
+                            <a:srgbClr val="000000"/>
+                          </a:solidFill>
+                          <a:latin typeface="Calibri"/>
+                        </a:rPr>
+                        <a:t>utm_dic.py</a:t>
+                      </a:r>
+                    </a:p>
+                  </a:txBody>
+                  <a:tcPr/>
+                </a:tc>
+                <a:tc>
+                  <a:txBody>
+                    <a:bodyPr lIns="54864" rIns="54864" tIns="18288" bIns="18288" wrap="square" anchor="ctr"/>
+                    <a:lstStyle/>
+                    <a:p>
+                      <a:pPr algn="l"/>
+                      <a:r>
+                        <a:rPr sz="950" b="0">
+                          <a:solidFill>
+                            <a:srgbClr val="000000"/>
+                          </a:solidFill>
+                          <a:latin typeface="Calibri"/>
+                        </a:rPr>
+                        <a:t>live DIC health + Poisson / Cauchy maths</a:t>
+                      </a:r>
+                    </a:p>
+                  </a:txBody>
+                  <a:tcPr/>
+                </a:tc>
+              </a:tr>
+            </a:tbl>
+          </a:graphicData>
+        </a:graphic>
+      </p:graphicFrame>
+      <p:sp>
+        <p:nvSpPr>
+          <p:cNvPr id="7" name="TextBox 6"/>
+          <p:cNvSpPr txBox="1"/>
+          <p:nvPr/>
+        </p:nvSpPr>
+        <p:spPr>
+          <a:xfrm>
+            <a:off x="365760" y="4526280"/>
+            <a:ext cx="5623560" cy="1280160"/>
+          </a:xfrm>
+          <a:prstGeom prst="rect">
+            <a:avLst/>
+          </a:prstGeom>
+          <a:noFill/>
+        </p:spPr>
+        <p:txBody>
+          <a:bodyPr wrap="square" lIns="45720" rIns="45720" tIns="18288" bIns="18288" anchor="t">
+            <a:spAutoFit/>
+          </a:bodyPr>
+          <a:lstStyle/>
+          <a:p>
+            <a:pPr algn="l"/>
+            <a:r>
+              <a:rPr sz="1050" b="0" i="1">
+                <a:solidFill>
+                  <a:srgbClr val="707070"/>
+                </a:solidFill>
+                <a:latin typeface="Calibri"/>
+              </a:rPr>
+              <a:t>Kills the copy-paste-per-specimen analysis burden (the cause of the V6c / V5-S4 detector bugs): one tested analyser, reused everywhere. Reproduces the known V5 / V6 numbers exactly.</a:t>
+            </a:r>
+          </a:p>
+        </p:txBody>
+      </p:sp>
+      <p:sp>
+        <p:nvSpPr>
+          <p:cNvPr id="8" name="TextBox 7"/>
+          <p:cNvSpPr txBox="1"/>
+          <p:nvPr/>
+        </p:nvSpPr>
+        <p:spPr>
+          <a:xfrm>
+            <a:off x="6172200" y="1170432"/>
+            <a:ext cx="5669280" cy="365760"/>
+          </a:xfrm>
+          <a:prstGeom prst="rect">
+            <a:avLst/>
+          </a:prstGeom>
+          <a:noFill/>
+        </p:spPr>
+        <p:txBody>
+          <a:bodyPr wrap="square" lIns="45720" rIns="45720" tIns="18288" bIns="18288" anchor="t">
+            <a:spAutoFit/>
+          </a:bodyPr>
+          <a:lstStyle/>
+          <a:p>
+            <a:pPr algn="l"/>
+            <a:r>
+              <a:rPr sz="1600" b="0" i="0">
+                <a:solidFill>
+                  <a:srgbClr val="707070"/>
+                </a:solidFill>
+                <a:latin typeface="Calibri"/>
+              </a:rPr>
+              <a:t>In the UI (main.py — awaiting rig test)</a:t>
+            </a:r>
+          </a:p>
+        </p:txBody>
+      </p:sp>
+      <p:sp>
+        <p:nvSpPr>
+          <p:cNvPr id="9" name="TextBox 8"/>
+          <p:cNvSpPr txBox="1"/>
+          <p:nvPr/>
+        </p:nvSpPr>
+        <p:spPr>
+          <a:xfrm>
+            <a:off x="6172200" y="1572768"/>
+            <a:ext cx="5669280" cy="3566160"/>
+          </a:xfrm>
+          <a:prstGeom prst="rect">
+            <a:avLst/>
+          </a:prstGeom>
+          <a:noFill/>
+        </p:spPr>
+        <p:txBody>
+          <a:bodyPr wrap="square" lIns="45720" rIns="45720" tIns="18288" bIns="18288" anchor="t">
+            <a:spAutoFit/>
+          </a:bodyPr>
+          <a:lstStyle/>
+          <a:p>
+            <a:pPr algn="l"/>
+            <a:r>
+              <a:rPr sz="1200" b="0" i="0">
+                <a:solidFill>
+                  <a:srgbClr val="000000"/>
+                </a:solidFill>
+                <a:latin typeface="Calibri"/>
+              </a:rPr>
+              <a:t>•  Generate report  — one button → PDF + images
+•  Recipe dropdown  — Load / Save a test setup
+•  Prepare specimen  — 1-click tare (position + force + DIC)
+•  Auto-stop at fracture  — halts on load collapse
+•  Strain-rate mode (BETA)  — closed-loop dε/dt
+•  DIC health HUD  — live OK / WARN / BAD badge
+•  Safety net  — 10 kN force / 45 mm travel / 900 s cap</a:t>
+            </a:r>
+          </a:p>
+        </p:txBody>
+      </p:sp>
+      <p:sp>
+        <p:nvSpPr>
+          <p:cNvPr id="10" name="TextBox 9"/>
+          <p:cNvSpPr txBox="1"/>
+          <p:nvPr/>
+        </p:nvSpPr>
+        <p:spPr>
+          <a:xfrm>
+            <a:off x="548640" y="6400800"/>
+            <a:ext cx="11064240" cy="365760"/>
+          </a:xfrm>
+          <a:prstGeom prst="rect">
+            <a:avLst/>
+          </a:prstGeom>
+          <a:noFill/>
+        </p:spPr>
+        <p:txBody>
+          <a:bodyPr wrap="square" lIns="45720" rIns="45720" tIns="18288" bIns="18288" anchor="t">
+            <a:spAutoFit/>
+          </a:bodyPr>
+          <a:lstStyle/>
+          <a:p>
+            <a:pPr algn="l"/>
+            <a:r>
+              <a:rPr sz="1200" b="0" i="1">
+                <a:solidFill>
+                  <a:srgbClr val="707070"/>
+                </a:solidFill>
+                <a:latin typeface="Calibri"/>
+              </a:rPr>
+              <a:t>Modules committed &amp; regression-checked against the deck numbers; the UI wiring stays in the unversioned main.py and will be snapshot-committed once validated on the rig.</a:t>
+            </a:r>
+          </a:p>
+        </p:txBody>
+      </p:sp>
+      <p:sp>
+        <p:nvSpPr>
+          <p:cNvPr id="11" name="TextBox 10"/>
+          <p:cNvSpPr txBox="1"/>
+          <p:nvPr/>
+        </p:nvSpPr>
+        <p:spPr>
+          <a:xfrm>
+            <a:off x="457200" y="6446520"/>
+            <a:ext cx="640080" cy="274320"/>
+          </a:xfrm>
+          <a:prstGeom prst="rect">
+            <a:avLst/>
+          </a:prstGeom>
+          <a:noFill/>
+        </p:spPr>
+        <p:txBody>
+          <a:bodyPr wrap="square" lIns="45720" rIns="45720" tIns="18288" bIns="18288" anchor="t">
+            <a:spAutoFit/>
+          </a:bodyPr>
+          <a:lstStyle/>
+          <a:p>
+            <a:pPr algn="l"/>
+            <a:r>
+              <a:rPr sz="1000" b="0" i="0">
+                <a:solidFill>
+                  <a:srgbClr val="707070"/>
+                </a:solidFill>
+                <a:latin typeface="Calibri"/>
+              </a:rPr>
+              <a:t>166</a:t>
+            </a:r>
+          </a:p>
+        </p:txBody>
+      </p:sp>
+    </p:spTree>
+  </p:cSld>
+  <p:clrMapOvr>
+    <a:masterClrMapping/>
+  </p:clrMapOvr>
+</p:sld>
+</file>
+
+<file path=ppt/slides/slide27.xml><?xml version="1.0" encoding="utf-8"?>
+<p:sld xmlns:a="http://schemas.openxmlformats.org/drawingml/2006/main" xmlns:p="http://schemas.openxmlformats.org/presentationml/2006/main" xmlns:r="http://schemas.openxmlformats.org/officeDocument/2006/relationships">
+  <p:cSld>
+    <p:spTree>
+      <p:nvGrpSpPr>
+        <p:cNvPr id="1" name=""/>
+        <p:cNvGrpSpPr/>
+        <p:nvPr/>
+      </p:nvGrpSpPr>
+      <p:grpSpPr/>
+      <p:sp>
+        <p:nvSpPr>
+          <p:cNvPr id="2" name="TextBox 1"/>
+          <p:cNvSpPr txBox="1"/>
+          <p:nvPr/>
+        </p:nvSpPr>
+        <p:spPr>
+          <a:xfrm>
+            <a:off x="11155680" y="274320"/>
+            <a:ext cx="914400" cy="274320"/>
+          </a:xfrm>
+          <a:prstGeom prst="rect">
+            <a:avLst/>
+          </a:prstGeom>
+          <a:noFill/>
+        </p:spPr>
+        <p:txBody>
+          <a:bodyPr wrap="square" lIns="45720" rIns="45720" tIns="18288" bIns="18288" anchor="t">
+            <a:spAutoFit/>
+          </a:bodyPr>
+          <a:lstStyle/>
+          <a:p>
+            <a:pPr algn="r"/>
+            <a:r>
+              <a:rPr sz="800" b="1" i="0">
+                <a:solidFill>
+                  <a:srgbClr val="707070"/>
+                </a:solidFill>
+                <a:latin typeface="Calibri"/>
+              </a:rPr>
+              <a:t>JÖNKÖPING UNIVERSITY</a:t>
+            </a:r>
+          </a:p>
+        </p:txBody>
+      </p:sp>
+      <p:sp>
+        <p:nvSpPr>
+          <p:cNvPr id="3" name="Rectangle 2"/>
+          <p:cNvSpPr/>
+          <p:nvPr/>
+        </p:nvSpPr>
+        <p:spPr>
+          <a:xfrm>
+            <a:off x="457200" y="411480"/>
+            <a:ext cx="457200" cy="73152"/>
+          </a:xfrm>
+          <a:prstGeom prst="rect">
+            <a:avLst/>
+          </a:prstGeom>
+          <a:solidFill>
+            <a:srgbClr val="A9D6EF"/>
+          </a:solidFill>
+          <a:ln>
+            <a:noFill/>
+          </a:ln>
+        </p:spPr>
+        <p:style>
+          <a:lnRef idx="1">
+            <a:schemeClr val="accent1"/>
+          </a:lnRef>
+          <a:fillRef idx="3">
+            <a:schemeClr val="accent1"/>
+          </a:fillRef>
+          <a:effectRef idx="2">
+            <a:schemeClr val="accent1"/>
+          </a:effectRef>
+          <a:fontRef idx="minor">
+            <a:schemeClr val="lt1"/>
+          </a:fontRef>
+        </p:style>
+        <p:txBody>
+          <a:bodyPr rtlCol="0" anchor="ctr"/>
+          <a:lstStyle/>
+          <a:p>
+            <a:pPr algn="ctr"/>
+          </a:p>
+        </p:txBody>
+      </p:sp>
+      <p:sp>
+        <p:nvSpPr>
+          <p:cNvPr id="4" name="TextBox 3"/>
+          <p:cNvSpPr txBox="1"/>
+          <p:nvPr/>
+        </p:nvSpPr>
+        <p:spPr>
+          <a:xfrm>
+            <a:off x="457200" y="502920"/>
+            <a:ext cx="11430000" cy="822960"/>
+          </a:xfrm>
+          <a:prstGeom prst="rect">
+            <a:avLst/>
+          </a:prstGeom>
+          <a:noFill/>
+        </p:spPr>
+        <p:txBody>
+          <a:bodyPr wrap="square" lIns="45720" rIns="45720" tIns="18288" bIns="18288" anchor="t">
+            <a:spAutoFit/>
+          </a:bodyPr>
+          <a:lstStyle/>
+          <a:p>
+            <a:pPr algn="l"/>
+            <a:r>
+              <a:rPr sz="3000" b="0" i="0">
+                <a:solidFill>
+                  <a:srgbClr val="000000"/>
+                </a:solidFill>
+                <a:latin typeface="Calibri Light"/>
+              </a:rPr>
+              <a:t>TO BE TESTED — ON THE RIG / CAMERA</a:t>
+            </a:r>
+          </a:p>
+        </p:txBody>
+      </p:sp>
+      <p:sp>
+        <p:nvSpPr>
+          <p:cNvPr id="5" name="TextBox 4"/>
+          <p:cNvSpPr txBox="1"/>
+          <p:nvPr/>
+        </p:nvSpPr>
+        <p:spPr>
+          <a:xfrm>
+            <a:off x="365760" y="1170432"/>
+            <a:ext cx="6720840" cy="365760"/>
+          </a:xfrm>
+          <a:prstGeom prst="rect">
+            <a:avLst/>
+          </a:prstGeom>
+          <a:noFill/>
+        </p:spPr>
+        <p:txBody>
+          <a:bodyPr wrap="square" lIns="45720" rIns="45720" tIns="18288" bIns="18288" anchor="t">
+            <a:spAutoFit/>
+          </a:bodyPr>
+          <a:lstStyle/>
+          <a:p>
+            <a:pPr algn="l"/>
+            <a:r>
+              <a:rPr sz="1600" b="0" i="0">
+                <a:solidFill>
+                  <a:srgbClr val="707070"/>
+                </a:solidFill>
+                <a:latin typeface="Calibri"/>
+              </a:rPr>
+              <a:t>Feature checks (needs motor + camera)</a:t>
+            </a:r>
+          </a:p>
+        </p:txBody>
+      </p:sp>
+      <p:graphicFrame>
+        <p:nvGraphicFramePr>
+          <p:cNvPr id="6" name="Table 5"/>
+          <p:cNvGraphicFramePr>
+            <a:graphicFrameLocks noGrp="1"/>
+          </p:cNvGraphicFramePr>
+          <p:nvPr/>
+        </p:nvGraphicFramePr>
+        <p:xfrm>
+          <a:off x="365760" y="1554480"/>
+          <a:ext cx="6720840" cy="2788920"/>
+        </p:xfrm>
+        <a:graphic>
+          <a:graphicData uri="http://schemas.openxmlformats.org/drawingml/2006/table">
+            <a:tbl>
+              <a:tblPr firstRow="1" bandRow="1">
+                <a:tableStyleId>{5C22544A-7EE6-4342-B048-85BDC9FD1C3A}</a:tableStyleId>
+              </a:tblPr>
+              <a:tblGrid>
+                <a:gridCol w="2148840"/>
+                <a:gridCol w="4572000"/>
+              </a:tblGrid>
+              <a:tr h="398417">
+                <a:tc>
+                  <a:txBody>
+                    <a:bodyPr lIns="54864" rIns="54864" tIns="18288" bIns="18288" wrap="square" anchor="ctr"/>
+                    <a:lstStyle/>
+                    <a:p>
+                      <a:pPr algn="l"/>
+                      <a:r>
+                        <a:rPr sz="1000" b="1">
+                          <a:solidFill>
+                            <a:srgbClr val="FFFFFF"/>
+                          </a:solidFill>
+                          <a:latin typeface="Calibri"/>
+                        </a:rPr>
+                        <a:t>Feature</a:t>
+                      </a:r>
+                    </a:p>
+                  </a:txBody>
+                  <a:tcPr>
+                    <a:solidFill>
+                      <a:srgbClr val="143D2F"/>
+                    </a:solidFill>
+                  </a:tcPr>
+                </a:tc>
+                <a:tc>
+                  <a:txBody>
+                    <a:bodyPr lIns="54864" rIns="54864" tIns="18288" bIns="18288" wrap="square" anchor="ctr"/>
+                    <a:lstStyle/>
+                    <a:p>
+                      <a:pPr algn="l"/>
+                      <a:r>
+                        <a:rPr sz="1000" b="1">
+                          <a:solidFill>
+                            <a:srgbClr val="FFFFFF"/>
+                          </a:solidFill>
+                          <a:latin typeface="Calibri"/>
+                        </a:rPr>
+                        <a:t>Pass =</a:t>
+                      </a:r>
+                    </a:p>
+                  </a:txBody>
+                  <a:tcPr>
+                    <a:solidFill>
+                      <a:srgbClr val="143D2F"/>
+                    </a:solidFill>
+                  </a:tcPr>
+                </a:tc>
+              </a:tr>
+              <a:tr h="398417">
+                <a:tc>
+                  <a:txBody>
+                    <a:bodyPr lIns="54864" rIns="54864" tIns="18288" bIns="18288" wrap="square" anchor="ctr"/>
+                    <a:lstStyle/>
+                    <a:p>
+                      <a:pPr algn="l"/>
+                      <a:r>
+                        <a:rPr sz="950" b="0">
+                          <a:solidFill>
+                            <a:srgbClr val="000000"/>
+                          </a:solidFill>
+                          <a:latin typeface="Calibri"/>
+                        </a:rPr>
+                        <a:t>DIC health HUD</a:t>
+                      </a:r>
+                    </a:p>
+                  </a:txBody>
+                  <a:tcPr/>
+                </a:tc>
+                <a:tc>
+                  <a:txBody>
+                    <a:bodyPr lIns="54864" rIns="54864" tIns="18288" bIns="18288" wrap="square" anchor="ctr"/>
+                    <a:lstStyle/>
+                    <a:p>
+                      <a:pPr algn="l"/>
+                      <a:r>
+                        <a:rPr sz="950" b="0">
+                          <a:solidFill>
+                            <a:srgbClr val="000000"/>
+                          </a:solidFill>
+                          <a:latin typeface="Calibri"/>
+                        </a:rPr>
+                        <a:t>camera on → green 2/2; cover a dot → red BAD</a:t>
+                      </a:r>
+                    </a:p>
+                  </a:txBody>
+                  <a:tcPr/>
+                </a:tc>
+              </a:tr>
+              <a:tr h="398417">
+                <a:tc>
+                  <a:txBody>
+                    <a:bodyPr lIns="54864" rIns="54864" tIns="18288" bIns="18288" wrap="square" anchor="ctr"/>
+                    <a:lstStyle/>
+                    <a:p>
+                      <a:pPr algn="l"/>
+                      <a:r>
+                        <a:rPr sz="950" b="0">
+                          <a:solidFill>
+                            <a:srgbClr val="000000"/>
+                          </a:solidFill>
+                          <a:latin typeface="Calibri"/>
+                        </a:rPr>
+                        <a:t>Prepare specimen</a:t>
+                      </a:r>
+                    </a:p>
+                  </a:txBody>
+                  <a:tcPr/>
+                </a:tc>
+                <a:tc>
+                  <a:txBody>
+                    <a:bodyPr lIns="54864" rIns="54864" tIns="18288" bIns="18288" wrap="square" anchor="ctr"/>
+                    <a:lstStyle/>
+                    <a:p>
+                      <a:pPr algn="l"/>
+                      <a:r>
+                        <a:rPr sz="950" b="0">
+                          <a:solidFill>
+                            <a:srgbClr val="000000"/>
+                          </a:solidFill>
+                          <a:latin typeface="Calibri"/>
+                        </a:rPr>
+                        <a:t>one click → position + force + DIC all tared</a:t>
+                      </a:r>
+                    </a:p>
+                  </a:txBody>
+                  <a:tcPr/>
+                </a:tc>
+              </a:tr>
+              <a:tr h="398417">
+                <a:tc>
+                  <a:txBody>
+                    <a:bodyPr lIns="54864" rIns="54864" tIns="18288" bIns="18288" wrap="square" anchor="ctr"/>
+                    <a:lstStyle/>
+                    <a:p>
+                      <a:pPr algn="l"/>
+                      <a:r>
+                        <a:rPr sz="950" b="0">
+                          <a:solidFill>
+                            <a:srgbClr val="000000"/>
+                          </a:solidFill>
+                          <a:latin typeface="Calibri"/>
+                        </a:rPr>
+                        <a:t>Auto-stop at fracture</a:t>
+                      </a:r>
+                    </a:p>
+                  </a:txBody>
+                  <a:tcPr/>
+                </a:tc>
+                <a:tc>
+                  <a:txBody>
+                    <a:bodyPr lIns="54864" rIns="54864" tIns="18288" bIns="18288" wrap="square" anchor="ctr"/>
+                    <a:lstStyle/>
+                    <a:p>
+                      <a:pPr algn="l"/>
+                      <a:r>
+                        <a:rPr sz="950" b="0">
+                          <a:solidFill>
+                            <a:srgbClr val="000000"/>
+                          </a:solidFill>
+                          <a:latin typeface="Calibri"/>
+                        </a:rPr>
+                        <a:t>scrap pull → Stop right at the load collapse</a:t>
+                      </a:r>
+                    </a:p>
+                  </a:txBody>
+                  <a:tcPr/>
+                </a:tc>
+              </a:tr>
+              <a:tr h="398417">
+                <a:tc>
+                  <a:txBody>
+                    <a:bodyPr lIns="54864" rIns="54864" tIns="18288" bIns="18288" wrap="square" anchor="ctr"/>
+                    <a:lstStyle/>
+                    <a:p>
+                      <a:pPr algn="l"/>
+                      <a:r>
+                        <a:rPr sz="950" b="0">
+                          <a:solidFill>
+                            <a:srgbClr val="000000"/>
+                          </a:solidFill>
+                          <a:latin typeface="Calibri"/>
+                        </a:rPr>
+                        <a:t>Recipes</a:t>
+                      </a:r>
+                    </a:p>
+                  </a:txBody>
+                  <a:tcPr/>
+                </a:tc>
+                <a:tc>
+                  <a:txBody>
+                    <a:bodyPr lIns="54864" rIns="54864" tIns="18288" bIns="18288" wrap="square" anchor="ctr"/>
+                    <a:lstStyle/>
+                    <a:p>
+                      <a:pPr algn="l"/>
+                      <a:r>
+                        <a:rPr sz="950" b="0">
+                          <a:solidFill>
+                            <a:srgbClr val="000000"/>
+                          </a:solidFill>
+                          <a:latin typeface="Calibri"/>
+                        </a:rPr>
+                        <a:t>load a starter → inputs change; Save → in list</a:t>
+                      </a:r>
+                    </a:p>
+                  </a:txBody>
+                  <a:tcPr/>
+                </a:tc>
+              </a:tr>
+              <a:tr h="398417">
+                <a:tc>
+                  <a:txBody>
+                    <a:bodyPr lIns="54864" rIns="54864" tIns="18288" bIns="18288" wrap="square" anchor="ctr"/>
+                    <a:lstStyle/>
+                    <a:p>
+                      <a:pPr algn="l"/>
+                      <a:r>
+                        <a:rPr sz="950" b="0">
+                          <a:solidFill>
+                            <a:srgbClr val="000000"/>
+                          </a:solidFill>
+                          <a:latin typeface="Calibri"/>
+                        </a:rPr>
+                        <a:t>Generate report</a:t>
+                      </a:r>
+                    </a:p>
+                  </a:txBody>
+                  <a:tcPr/>
+                </a:tc>
+                <a:tc>
+                  <a:txBody>
+                    <a:bodyPr lIns="54864" rIns="54864" tIns="18288" bIns="18288" wrap="square" anchor="ctr"/>
+                    <a:lstStyle/>
+                    <a:p>
+                      <a:pPr algn="l"/>
+                      <a:r>
+                        <a:rPr sz="950" b="0">
+                          <a:solidFill>
+                            <a:srgbClr val="000000"/>
+                          </a:solidFill>
+                          <a:latin typeface="Calibri"/>
+                        </a:rPr>
+                        <a:t>after a test → PDF + PNG land in /reports</a:t>
+                      </a:r>
+                    </a:p>
+                  </a:txBody>
+                  <a:tcPr/>
+                </a:tc>
+              </a:tr>
+              <a:tr h="398418">
+                <a:tc>
+                  <a:txBody>
+                    <a:bodyPr lIns="54864" rIns="54864" tIns="18288" bIns="18288" wrap="square" anchor="ctr"/>
+                    <a:lstStyle/>
+                    <a:p>
+                      <a:pPr algn="l"/>
+                      <a:r>
+                        <a:rPr sz="950" b="0">
+                          <a:solidFill>
+                            <a:srgbClr val="000000"/>
+                          </a:solidFill>
+                          <a:latin typeface="Calibri"/>
+                        </a:rPr>
+                        <a:t>Strain-rate (BETA)</a:t>
+                      </a:r>
+                    </a:p>
+                  </a:txBody>
+                  <a:tcPr/>
+                </a:tc>
+                <a:tc>
+                  <a:txBody>
+                    <a:bodyPr lIns="54864" rIns="54864" tIns="18288" bIns="18288" wrap="square" anchor="ctr"/>
+                    <a:lstStyle/>
+                    <a:p>
+                      <a:pPr algn="l"/>
+                      <a:r>
+                        <a:rPr sz="950" b="0">
+                          <a:solidFill>
+                            <a:srgbClr val="000000"/>
+                          </a:solidFill>
+                          <a:latin typeface="Calibri"/>
+                        </a:rPr>
+                        <a:t>scrap pull → holds dε/dt; stops at target / break</a:t>
+                      </a:r>
+                    </a:p>
+                  </a:txBody>
+                  <a:tcPr/>
+                </a:tc>
+              </a:tr>
+            </a:tbl>
+          </a:graphicData>
+        </a:graphic>
+      </p:graphicFrame>
+      <p:sp>
+        <p:nvSpPr>
+          <p:cNvPr id="7" name="TextBox 6"/>
+          <p:cNvSpPr txBox="1"/>
+          <p:nvPr/>
+        </p:nvSpPr>
+        <p:spPr>
+          <a:xfrm>
+            <a:off x="7269480" y="1170432"/>
+            <a:ext cx="4572000" cy="365760"/>
+          </a:xfrm>
+          <a:prstGeom prst="rect">
+            <a:avLst/>
+          </a:prstGeom>
+          <a:noFill/>
+        </p:spPr>
+        <p:txBody>
+          <a:bodyPr wrap="square" lIns="45720" rIns="45720" tIns="18288" bIns="18288" anchor="t">
+            <a:spAutoFit/>
+          </a:bodyPr>
+          <a:lstStyle/>
+          <a:p>
+            <a:pPr algn="l"/>
+            <a:r>
+              <a:rPr sz="1600" b="0" i="0">
+                <a:solidFill>
+                  <a:srgbClr val="707070"/>
+                </a:solidFill>
+                <a:latin typeface="Calibri"/>
+              </a:rPr>
+              <a:t>Rig facts to report back</a:t>
+            </a:r>
+          </a:p>
+        </p:txBody>
+      </p:sp>
+      <p:sp>
+        <p:nvSpPr>
+          <p:cNvPr id="8" name="TextBox 7"/>
+          <p:cNvSpPr txBox="1"/>
+          <p:nvPr/>
+        </p:nvSpPr>
+        <p:spPr>
+          <a:xfrm>
+            <a:off x="7269480" y="1572768"/>
+            <a:ext cx="4572000" cy="2743200"/>
+          </a:xfrm>
+          <a:prstGeom prst="rect">
+            <a:avLst/>
+          </a:prstGeom>
+          <a:noFill/>
+        </p:spPr>
+        <p:txBody>
+          <a:bodyPr wrap="square" lIns="45720" rIns="45720" tIns="18288" bIns="18288" anchor="t">
+            <a:spAutoFit/>
+          </a:bodyPr>
+          <a:lstStyle/>
+          <a:p>
+            <a:pPr algn="l"/>
+            <a:r>
+              <a:rPr sz="1150" b="0" i="0">
+                <a:solidFill>
+                  <a:srgbClr val="000000"/>
+                </a:solidFill>
+                <a:latin typeface="Calibri"/>
+              </a:rPr>
+              <a:t>These unblock the other 4 test modes:
+1.  Does SetSpeed 0 HOLD the motor still?
+     (dwell — staircase / relaxation)
+2.  Clean reversal sequence — Stop → SetSpeed
+     → direction?  (cyclic / creep)
+3.  Usable crosshead stroke (mm)?
+     (finalise the 45 mm travel cap)</a:t>
+            </a:r>
+          </a:p>
+        </p:txBody>
+      </p:sp>
+      <p:sp>
+        <p:nvSpPr>
+          <p:cNvPr id="9" name="Rectangle 8"/>
+          <p:cNvSpPr/>
+          <p:nvPr/>
+        </p:nvSpPr>
+        <p:spPr>
+          <a:xfrm>
+            <a:off x="365760" y="5029200"/>
+            <a:ext cx="11475720" cy="960120"/>
+          </a:xfrm>
+          <a:prstGeom prst="rect">
+            <a:avLst/>
+          </a:prstGeom>
+          <a:solidFill>
+            <a:srgbClr val="FFF3CD"/>
+          </a:solidFill>
+          <a:ln>
+            <a:noFill/>
+          </a:ln>
+        </p:spPr>
+        <p:style>
+          <a:lnRef idx="1">
+            <a:schemeClr val="accent1"/>
+          </a:lnRef>
+          <a:fillRef idx="3">
+            <a:schemeClr val="accent1"/>
+          </a:fillRef>
+          <a:effectRef idx="2">
+            <a:schemeClr val="accent1"/>
+          </a:effectRef>
+          <a:fontRef idx="minor">
+            <a:schemeClr val="lt1"/>
+          </a:fontRef>
+        </p:style>
+        <p:txBody>
+          <a:bodyPr rtlCol="0" anchor="ctr" wrap="square" lIns="109728" rIns="109728"/>
+          <a:lstStyle/>
+          <a:p>
+            <a:pPr algn="ctr"/>
+            <a:r>
+              <a:rPr sz="1150" b="1">
+                <a:solidFill>
+                  <a:srgbClr val="000000"/>
+                </a:solidFill>
+                <a:latin typeface="Calibri"/>
+              </a:rPr>
+              <a:t>SAFETY — Auto-stop and Strain-rate drive the motor: run them first on a SCRAP specimen with a hand near E-Stop. Everything else is read-only. Full step-by-step list: Software/UTM_PyQt6/TESTING_TODO.md</a:t>
+            </a:r>
+          </a:p>
+        </p:txBody>
+      </p:sp>
+      <p:sp>
+        <p:nvSpPr>
+          <p:cNvPr id="10" name="TextBox 9"/>
+          <p:cNvSpPr txBox="1"/>
+          <p:nvPr/>
+        </p:nvSpPr>
+        <p:spPr>
+          <a:xfrm>
+            <a:off x="548640" y="6400800"/>
+            <a:ext cx="11064240" cy="365760"/>
+          </a:xfrm>
+          <a:prstGeom prst="rect">
+            <a:avLst/>
+          </a:prstGeom>
+          <a:noFill/>
+        </p:spPr>
+        <p:txBody>
+          <a:bodyPr wrap="square" lIns="45720" rIns="45720" tIns="18288" bIns="18288" anchor="t">
+            <a:spAutoFit/>
+          </a:bodyPr>
+          <a:lstStyle/>
+          <a:p>
+            <a:pPr algn="l"/>
+            <a:r>
+              <a:rPr sz="1200" b="0" i="1">
+                <a:solidFill>
+                  <a:srgbClr val="707070"/>
+                </a:solidFill>
+                <a:latin typeface="Calibri"/>
+              </a:rPr>
+              <a:t>Logic is already sim/offline-validated — these runs confirm behaviour on real hardware and set the tunable thresholds (fracture arm 30% / collapse 50%, travel cap).</a:t>
+            </a:r>
+          </a:p>
+        </p:txBody>
+      </p:sp>
+      <p:sp>
+        <p:nvSpPr>
+          <p:cNvPr id="11" name="TextBox 10"/>
+          <p:cNvSpPr txBox="1"/>
+          <p:nvPr/>
+        </p:nvSpPr>
+        <p:spPr>
+          <a:xfrm>
+            <a:off x="457200" y="6446520"/>
+            <a:ext cx="640080" cy="274320"/>
+          </a:xfrm>
+          <a:prstGeom prst="rect">
+            <a:avLst/>
+          </a:prstGeom>
+          <a:noFill/>
+        </p:spPr>
+        <p:txBody>
+          <a:bodyPr wrap="square" lIns="45720" rIns="45720" tIns="18288" bIns="18288" anchor="t">
+            <a:spAutoFit/>
+          </a:bodyPr>
+          <a:lstStyle/>
+          <a:p>
+            <a:pPr algn="l"/>
+            <a:r>
+              <a:rPr sz="1000" b="0" i="0">
+                <a:solidFill>
+                  <a:srgbClr val="707070"/>
+                </a:solidFill>
+                <a:latin typeface="Calibri"/>
+              </a:rPr>
+              <a:t>167</a:t>
+            </a:r>
+          </a:p>
+        </p:txBody>
+      </p:sp>
+    </p:spTree>
+  </p:cSld>
+  <p:clrMapOvr>
+    <a:masterClrMapping/>
+  </p:clrMapOvr>
+</p:sld>
+</file>
+
+<file path=ppt/slides/slide28.xml><?xml version="1.0" encoding="utf-8"?>
+<p:sld xmlns:a="http://schemas.openxmlformats.org/drawingml/2006/main" xmlns:p="http://schemas.openxmlformats.org/presentationml/2006/main" xmlns:r="http://schemas.openxmlformats.org/officeDocument/2006/relationships">
+  <p:cSld>
+    <p:spTree>
+      <p:nvGrpSpPr>
+        <p:cNvPr id="1" name=""/>
+        <p:cNvGrpSpPr/>
+        <p:nvPr/>
+      </p:nvGrpSpPr>
+      <p:grpSpPr/>
+      <p:sp>
+        <p:nvSpPr>
+          <p:cNvPr id="2" name="TextBox 1"/>
+          <p:cNvSpPr txBox="1"/>
+          <p:nvPr/>
+        </p:nvSpPr>
+        <p:spPr>
+          <a:xfrm>
+            <a:off x="11155680" y="274320"/>
+            <a:ext cx="914400" cy="274320"/>
+          </a:xfrm>
+          <a:prstGeom prst="rect">
+            <a:avLst/>
+          </a:prstGeom>
+          <a:noFill/>
+        </p:spPr>
+        <p:txBody>
+          <a:bodyPr wrap="square" lIns="45720" rIns="45720" tIns="18288" bIns="18288" anchor="t">
+            <a:spAutoFit/>
+          </a:bodyPr>
+          <a:lstStyle/>
+          <a:p>
+            <a:pPr algn="r"/>
+            <a:r>
+              <a:rPr sz="800" b="1" i="0">
+                <a:solidFill>
+                  <a:srgbClr val="707070"/>
+                </a:solidFill>
+                <a:latin typeface="Calibri"/>
+              </a:rPr>
+              <a:t>JÖNKÖPING UNIVERSITY</a:t>
+            </a:r>
+          </a:p>
+        </p:txBody>
+      </p:sp>
+      <p:sp>
+        <p:nvSpPr>
+          <p:cNvPr id="3" name="Rectangle 2"/>
+          <p:cNvSpPr/>
+          <p:nvPr/>
+        </p:nvSpPr>
+        <p:spPr>
+          <a:xfrm>
+            <a:off x="457200" y="411480"/>
+            <a:ext cx="457200" cy="73152"/>
+          </a:xfrm>
+          <a:prstGeom prst="rect">
+            <a:avLst/>
+          </a:prstGeom>
+          <a:solidFill>
+            <a:srgbClr val="A9D6EF"/>
+          </a:solidFill>
+          <a:ln>
+            <a:noFill/>
+          </a:ln>
+        </p:spPr>
+        <p:style>
+          <a:lnRef idx="1">
+            <a:schemeClr val="accent1"/>
+          </a:lnRef>
+          <a:fillRef idx="3">
+            <a:schemeClr val="accent1"/>
+          </a:fillRef>
+          <a:effectRef idx="2">
+            <a:schemeClr val="accent1"/>
+          </a:effectRef>
+          <a:fontRef idx="minor">
+            <a:schemeClr val="lt1"/>
+          </a:fontRef>
+        </p:style>
+        <p:txBody>
+          <a:bodyPr rtlCol="0" anchor="ctr"/>
+          <a:lstStyle/>
+          <a:p>
+            <a:pPr algn="ctr"/>
+          </a:p>
+        </p:txBody>
+      </p:sp>
+      <p:sp>
+        <p:nvSpPr>
+          <p:cNvPr id="4" name="TextBox 3"/>
+          <p:cNvSpPr txBox="1"/>
+          <p:nvPr/>
+        </p:nvSpPr>
+        <p:spPr>
+          <a:xfrm>
+            <a:off x="457200" y="502920"/>
+            <a:ext cx="11430000" cy="822960"/>
+          </a:xfrm>
+          <a:prstGeom prst="rect">
+            <a:avLst/>
+          </a:prstGeom>
+          <a:noFill/>
+        </p:spPr>
+        <p:txBody>
+          <a:bodyPr wrap="square" lIns="45720" rIns="45720" tIns="18288" bIns="18288" anchor="t">
+            <a:spAutoFit/>
+          </a:bodyPr>
+          <a:lstStyle/>
+          <a:p>
+            <a:pPr algn="l"/>
+            <a:r>
+              <a:rPr sz="3000" b="0" i="0">
+                <a:solidFill>
+                  <a:srgbClr val="000000"/>
+                </a:solidFill>
+                <a:latin typeface="Calibri Light"/>
+              </a:rPr>
+              <a:t>PLANNED NEXT — MEASURED POISSON (EDGE-WIDTH) + REMAINING AUTOMATION</a:t>
+            </a:r>
+          </a:p>
+        </p:txBody>
+      </p:sp>
+      <p:sp>
+        <p:nvSpPr>
+          <p:cNvPr id="5" name="TextBox 4"/>
+          <p:cNvSpPr txBox="1"/>
+          <p:nvPr/>
+        </p:nvSpPr>
+        <p:spPr>
+          <a:xfrm>
+            <a:off x="365760" y="1170432"/>
+            <a:ext cx="11475720" cy="365760"/>
+          </a:xfrm>
+          <a:prstGeom prst="rect">
+            <a:avLst/>
+          </a:prstGeom>
+          <a:noFill/>
+        </p:spPr>
+        <p:txBody>
+          <a:bodyPr wrap="square" lIns="45720" rIns="45720" tIns="18288" bIns="18288" anchor="t">
+            <a:spAutoFit/>
+          </a:bodyPr>
+          <a:lstStyle/>
+          <a:p>
+            <a:pPr algn="l"/>
+            <a:r>
+              <a:rPr sz="1600" b="0" i="0">
+                <a:solidFill>
+                  <a:srgbClr val="707070"/>
+                </a:solidFill>
+                <a:latin typeface="Calibri"/>
+              </a:rPr>
+              <a:t>Measured Poisson / true Cauchy — edge-width tracking  (next build, reuses THIS camera)</a:t>
+            </a:r>
+          </a:p>
+        </p:txBody>
+      </p:sp>
+      <p:sp>
+        <p:nvSpPr>
+          <p:cNvPr id="6" name="Rounded Rectangle 5"/>
+          <p:cNvSpPr/>
+          <p:nvPr/>
+        </p:nvSpPr>
+        <p:spPr>
+          <a:xfrm>
+            <a:off x="365760" y="1600200"/>
+            <a:ext cx="2514600" cy="868680"/>
+          </a:xfrm>
+          <a:prstGeom prst="roundRect">
+            <a:avLst/>
+          </a:prstGeom>
+          <a:solidFill>
+            <a:srgbClr val="333333"/>
+          </a:solidFill>
+          <a:ln w="15240">
+            <a:solidFill>
+              <a:srgbClr val="000000"/>
+            </a:solidFill>
+          </a:ln>
+        </p:spPr>
+        <p:style>
+          <a:lnRef idx="1">
+            <a:schemeClr val="accent1"/>
+          </a:lnRef>
+          <a:fillRef idx="3">
+            <a:schemeClr val="accent1"/>
+          </a:fillRef>
+          <a:effectRef idx="2">
+            <a:schemeClr val="accent1"/>
+          </a:effectRef>
+          <a:fontRef idx="minor">
+            <a:schemeClr val="lt1"/>
+          </a:fontRef>
+        </p:style>
+        <p:txBody>
+          <a:bodyPr rtlCol="0" anchor="ctr" lIns="54864" rIns="54864" tIns="27432" bIns="27432" wrap="square"/>
+          <a:lstStyle/>
+          <a:p>
+            <a:pPr algn="ctr"/>
+            <a:r>
+              <a:rPr sz="1050" b="1">
+                <a:solidFill>
+                  <a:srgbClr val="FFFFFF"/>
+                </a:solidFill>
+                <a:latin typeface="Calibri"/>
+              </a:rPr>
+              <a:t>Matte-black MDF
+backdrop
+(behind gauge)</a:t>
+            </a:r>
+          </a:p>
+        </p:txBody>
+      </p:sp>
+      <p:sp>
+        <p:nvSpPr>
+          <p:cNvPr id="7" name="Rounded Rectangle 6"/>
+          <p:cNvSpPr/>
+          <p:nvPr/>
+        </p:nvSpPr>
+        <p:spPr>
+          <a:xfrm>
+            <a:off x="3310128" y="1600200"/>
+            <a:ext cx="2514600" cy="868680"/>
+          </a:xfrm>
+          <a:prstGeom prst="roundRect">
+            <a:avLst/>
+          </a:prstGeom>
+          <a:solidFill>
+            <a:srgbClr val="FFFFFF"/>
+          </a:solidFill>
+          <a:ln w="15240">
+            <a:solidFill>
+              <a:srgbClr val="1F77B4"/>
+            </a:solidFill>
+          </a:ln>
+        </p:spPr>
+        <p:style>
+          <a:lnRef idx="1">
+            <a:schemeClr val="accent1"/>
+          </a:lnRef>
+          <a:fillRef idx="3">
+            <a:schemeClr val="accent1"/>
+          </a:fillRef>
+          <a:effectRef idx="2">
+            <a:schemeClr val="accent1"/>
+          </a:effectRef>
+          <a:fontRef idx="minor">
+            <a:schemeClr val="lt1"/>
+          </a:fontRef>
+        </p:style>
+        <p:txBody>
+          <a:bodyPr rtlCol="0" anchor="ctr" lIns="54864" rIns="54864" tIns="27432" bIns="27432" wrap="square"/>
+          <a:lstStyle/>
+          <a:p>
+            <a:pPr algn="ctr"/>
+            <a:r>
+              <a:rPr sz="1050" b="0">
+                <a:solidFill>
+                  <a:srgbClr val="000000"/>
+                </a:solidFill>
+                <a:latin typeface="Calibri"/>
+              </a:rPr>
+              <a:t>Camera detects
+L &amp; R specimen
+edges</a:t>
+            </a:r>
+          </a:p>
+        </p:txBody>
+      </p:sp>
+      <p:sp>
+        <p:nvSpPr>
+          <p:cNvPr id="8" name="Rounded Rectangle 7"/>
+          <p:cNvSpPr/>
+          <p:nvPr/>
+        </p:nvSpPr>
+        <p:spPr>
+          <a:xfrm>
+            <a:off x="6254496" y="1600200"/>
+            <a:ext cx="2514600" cy="868680"/>
+          </a:xfrm>
+          <a:prstGeom prst="roundRect">
+            <a:avLst/>
+          </a:prstGeom>
+          <a:solidFill>
+            <a:srgbClr val="FFFFFF"/>
+          </a:solidFill>
+          <a:ln w="15240">
+            <a:solidFill>
+              <a:srgbClr val="1F77B4"/>
+            </a:solidFill>
+          </a:ln>
+        </p:spPr>
+        <p:style>
+          <a:lnRef idx="1">
+            <a:schemeClr val="accent1"/>
+          </a:lnRef>
+          <a:fillRef idx="3">
+            <a:schemeClr val="accent1"/>
+          </a:fillRef>
+          <a:effectRef idx="2">
+            <a:schemeClr val="accent1"/>
+          </a:effectRef>
+          <a:fontRef idx="minor">
+            <a:schemeClr val="lt1"/>
+          </a:fontRef>
+        </p:style>
+        <p:txBody>
+          <a:bodyPr rtlCol="0" anchor="ctr" lIns="54864" rIns="54864" tIns="27432" bIns="27432" wrap="square"/>
+          <a:lstStyle/>
+          <a:p>
+            <a:pPr algn="ctr"/>
+            <a:r>
+              <a:rPr sz="1050" b="0">
+                <a:solidFill>
+                  <a:srgbClr val="000000"/>
+                </a:solidFill>
+                <a:latin typeface="Calibri"/>
+              </a:rPr>
+              <a:t>Average width
+over the gauge
+(100s of rows)</a:t>
+            </a:r>
+          </a:p>
+        </p:txBody>
+      </p:sp>
+      <p:sp>
+        <p:nvSpPr>
+          <p:cNvPr id="9" name="Rounded Rectangle 8"/>
+          <p:cNvSpPr/>
+          <p:nvPr/>
+        </p:nvSpPr>
+        <p:spPr>
+          <a:xfrm>
+            <a:off x="9198864" y="1600200"/>
+            <a:ext cx="2642616" cy="868680"/>
+          </a:xfrm>
+          <a:prstGeom prst="roundRect">
+            <a:avLst/>
+          </a:prstGeom>
+          <a:solidFill>
+            <a:srgbClr val="C8E6C9"/>
+          </a:solidFill>
+          <a:ln w="15240">
+            <a:solidFill>
+              <a:srgbClr val="1F3F2F"/>
+            </a:solidFill>
+          </a:ln>
+        </p:spPr>
+        <p:style>
+          <a:lnRef idx="1">
+            <a:schemeClr val="accent1"/>
+          </a:lnRef>
+          <a:fillRef idx="3">
+            <a:schemeClr val="accent1"/>
+          </a:fillRef>
+          <a:effectRef idx="2">
+            <a:schemeClr val="accent1"/>
+          </a:effectRef>
+          <a:fontRef idx="minor">
+            <a:schemeClr val="lt1"/>
+          </a:fontRef>
+        </p:style>
+        <p:txBody>
+          <a:bodyPr rtlCol="0" anchor="ctr" lIns="54864" rIns="54864" tIns="27432" bIns="27432" wrap="square"/>
+          <a:lstStyle/>
+          <a:p>
+            <a:pPr algn="ctr"/>
+            <a:r>
+              <a:rPr sz="1050" b="1">
+                <a:solidFill>
+                  <a:srgbClr val="1F3F2F"/>
+                </a:solidFill>
+                <a:latin typeface="Calibri"/>
+              </a:rPr>
+              <a:t>εw → ν  and
+true area →
+Cauchy stress</a:t>
+            </a:r>
+          </a:p>
+        </p:txBody>
+      </p:sp>
+      <p:cxnSp>
+        <p:nvCxnSpPr>
+          <p:cNvPr id="10" name="Connector 9"/>
+          <p:cNvCxnSpPr/>
+          <p:nvPr/>
+        </p:nvCxnSpPr>
+        <p:spPr>
+          <a:xfrm>
+            <a:off x="2898648" y="2039112"/>
+            <a:ext cx="393192" cy="0"/>
+          </a:xfrm>
+          <a:prstGeom prst="line">
+            <a:avLst/>
+          </a:prstGeom>
+          <a:ln w="19050">
+            <a:solidFill>
+              <a:srgbClr val="555555"/>
+            </a:solidFill>
+            <a:tailEnd type="triangle" w="med" len="med"/>
+          </a:ln>
+        </p:spPr>
+        <p:style>
+          <a:lnRef idx="2">
+            <a:schemeClr val="accent1"/>
+          </a:lnRef>
+          <a:fillRef idx="0">
+            <a:schemeClr val="accent1"/>
+          </a:fillRef>
+          <a:effectRef idx="1">
+            <a:schemeClr val="accent1"/>
+          </a:effectRef>
+          <a:fontRef idx="minor">
+            <a:schemeClr val="tx1"/>
+          </a:fontRef>
+        </p:style>
+      </p:cxnSp>
+      <p:cxnSp>
+        <p:nvCxnSpPr>
+          <p:cNvPr id="11" name="Connector 10"/>
+          <p:cNvCxnSpPr/>
+          <p:nvPr/>
+        </p:nvCxnSpPr>
+        <p:spPr>
+          <a:xfrm>
+            <a:off x="5843016" y="2039112"/>
+            <a:ext cx="393192" cy="0"/>
+          </a:xfrm>
+          <a:prstGeom prst="line">
+            <a:avLst/>
+          </a:prstGeom>
+          <a:ln w="19050">
+            <a:solidFill>
+              <a:srgbClr val="555555"/>
+            </a:solidFill>
+            <a:tailEnd type="triangle" w="med" len="med"/>
+          </a:ln>
+        </p:spPr>
+        <p:style>
+          <a:lnRef idx="2">
+            <a:schemeClr val="accent1"/>
+          </a:lnRef>
+          <a:fillRef idx="0">
+            <a:schemeClr val="accent1"/>
+          </a:fillRef>
+          <a:effectRef idx="1">
+            <a:schemeClr val="accent1"/>
+          </a:effectRef>
+          <a:fontRef idx="minor">
+            <a:schemeClr val="tx1"/>
+          </a:fontRef>
+        </p:style>
+      </p:cxnSp>
+      <p:cxnSp>
+        <p:nvCxnSpPr>
+          <p:cNvPr id="12" name="Connector 11"/>
+          <p:cNvCxnSpPr/>
+          <p:nvPr/>
+        </p:nvCxnSpPr>
+        <p:spPr>
+          <a:xfrm>
+            <a:off x="8787384" y="2039112"/>
+            <a:ext cx="393192" cy="0"/>
+          </a:xfrm>
+          <a:prstGeom prst="line">
+            <a:avLst/>
+          </a:prstGeom>
+          <a:ln w="19050">
+            <a:solidFill>
+              <a:srgbClr val="555555"/>
+            </a:solidFill>
+            <a:tailEnd type="triangle" w="med" len="med"/>
+          </a:ln>
+        </p:spPr>
+        <p:style>
+          <a:lnRef idx="2">
+            <a:schemeClr val="accent1"/>
+          </a:lnRef>
+          <a:fillRef idx="0">
+            <a:schemeClr val="accent1"/>
+          </a:fillRef>
+          <a:effectRef idx="1">
+            <a:schemeClr val="accent1"/>
+          </a:effectRef>
+          <a:fontRef idx="minor">
+            <a:schemeClr val="tx1"/>
+          </a:fontRef>
+        </p:style>
+      </p:cxnSp>
+      <p:sp>
+        <p:nvSpPr>
+          <p:cNvPr id="13" name="TextBox 12"/>
+          <p:cNvSpPr txBox="1"/>
+          <p:nvPr/>
+        </p:nvSpPr>
+        <p:spPr>
+          <a:xfrm>
+            <a:off x="365760" y="2606040"/>
+            <a:ext cx="11475720" cy="868680"/>
+          </a:xfrm>
+          <a:prstGeom prst="rect">
+            <a:avLst/>
+          </a:prstGeom>
+          <a:noFill/>
+        </p:spPr>
+        <p:txBody>
+          <a:bodyPr wrap="square" lIns="45720" rIns="45720" tIns="18288" bIns="18288" anchor="t">
+            <a:spAutoFit/>
+          </a:bodyPr>
+          <a:lstStyle/>
+          <a:p>
+            <a:pPr algn="l"/>
+            <a:r>
+              <a:rPr sz="1100" b="0" i="0">
+                <a:solidFill>
+                  <a:srgbClr val="000000"/>
+                </a:solidFill>
+                <a:latin typeface="Calibri"/>
+              </a:rPr>
+              <a:t>MEASURED (no assumed ν), reusing the current camera + specimen — matte finish avoids LED glare, a few-cm gap softens shadows. FIRST STEP: mount the board, grab ONE still frame → prototype the edge-detection to confirm contrast BEFORE building the live feature. (Transverse dots stay ruled out — see slide 164.)</a:t>
+            </a:r>
+          </a:p>
+        </p:txBody>
+      </p:sp>
+      <p:sp>
+        <p:nvSpPr>
+          <p:cNvPr id="14" name="TextBox 13"/>
+          <p:cNvSpPr txBox="1"/>
+          <p:nvPr/>
+        </p:nvSpPr>
+        <p:spPr>
+          <a:xfrm>
+            <a:off x="365760" y="3611880"/>
+            <a:ext cx="11475720" cy="365760"/>
+          </a:xfrm>
+          <a:prstGeom prst="rect">
+            <a:avLst/>
+          </a:prstGeom>
+          <a:noFill/>
+        </p:spPr>
+        <p:txBody>
+          <a:bodyPr wrap="square" lIns="45720" rIns="45720" tIns="18288" bIns="18288" anchor="t">
+            <a:spAutoFit/>
+          </a:bodyPr>
+          <a:lstStyle/>
+          <a:p>
+            <a:pPr algn="l"/>
+            <a:r>
+              <a:rPr sz="1600" b="0" i="0">
+                <a:solidFill>
+                  <a:srgbClr val="707070"/>
+                </a:solidFill>
+                <a:latin typeface="Calibri"/>
+              </a:rPr>
+              <a:t>Remaining automation &amp; ease-of-use</a:t>
+            </a:r>
+          </a:p>
+        </p:txBody>
+      </p:sp>
+      <p:sp>
+        <p:nvSpPr>
+          <p:cNvPr id="15" name="TextBox 14"/>
+          <p:cNvSpPr txBox="1"/>
+          <p:nvPr/>
+        </p:nvSpPr>
+        <p:spPr>
+          <a:xfrm>
+            <a:off x="365760" y="4005072"/>
+            <a:ext cx="5669280" cy="1828800"/>
+          </a:xfrm>
+          <a:prstGeom prst="rect">
+            <a:avLst/>
+          </a:prstGeom>
+          <a:noFill/>
+        </p:spPr>
+        <p:txBody>
+          <a:bodyPr wrap="square" lIns="45720" rIns="45720" tIns="18288" bIns="18288" anchor="t">
+            <a:spAutoFit/>
+          </a:bodyPr>
+          <a:lstStyle/>
+          <a:p>
+            <a:pPr algn="l"/>
+            <a:r>
+              <a:rPr sz="1150" b="0" i="0">
+                <a:solidFill>
+                  <a:srgbClr val="000000"/>
+                </a:solidFill>
+                <a:latin typeface="Calibri"/>
+              </a:rPr>
+              <a:t>•  Cyclic / staircase / relaxation / creep modes
+    (engine ready — needs the 3 rig facts)
+•  Full 'Run to fracture' — one button:
+    preload → pull → auto-halt → anchor → save
+•  Auto specimen metadata + folder from recipe</a:t>
+            </a:r>
+          </a:p>
+        </p:txBody>
+      </p:sp>
+      <p:sp>
+        <p:nvSpPr>
+          <p:cNvPr id="16" name="TextBox 15"/>
+          <p:cNvSpPr txBox="1"/>
+          <p:nvPr/>
+        </p:nvSpPr>
+        <p:spPr>
+          <a:xfrm>
+            <a:off x="6172200" y="4005072"/>
+            <a:ext cx="5669280" cy="1828800"/>
+          </a:xfrm>
+          <a:prstGeom prst="rect">
+            <a:avLst/>
+          </a:prstGeom>
+          <a:noFill/>
+        </p:spPr>
+        <p:txBody>
+          <a:bodyPr wrap="square" lIns="45720" rIns="45720" tIns="18288" bIns="18288" anchor="t">
+            <a:spAutoFit/>
+          </a:bodyPr>
+          <a:lstStyle/>
+          <a:p>
+            <a:pPr algn="l"/>
+            <a:r>
+              <a:rPr sz="1150" b="0" i="0">
+                <a:solidFill>
+                  <a:srgbClr val="000000"/>
+                </a:solidFill>
+                <a:latin typeface="Calibri"/>
+              </a:rPr>
+              <a:t>•  Guided wizard / checklist
+    (Connect → … → Prepare → Run → Save)
+•  Live stress-strain + elastic-modulus overlay
+•  Glanceable dashboard + fracture beep / banner</a:t>
+            </a:r>
+          </a:p>
+        </p:txBody>
+      </p:sp>
+      <p:sp>
+        <p:nvSpPr>
+          <p:cNvPr id="17" name="Rectangle 16"/>
+          <p:cNvSpPr/>
+          <p:nvPr/>
+        </p:nvSpPr>
+        <p:spPr>
+          <a:xfrm>
+            <a:off x="365760" y="5943600"/>
+            <a:ext cx="11475720" cy="658368"/>
+          </a:xfrm>
+          <a:prstGeom prst="rect">
+            <a:avLst/>
+          </a:prstGeom>
+          <a:solidFill>
+            <a:srgbClr val="E7F1F8"/>
+          </a:solidFill>
+          <a:ln>
+            <a:noFill/>
+          </a:ln>
+        </p:spPr>
+        <p:style>
+          <a:lnRef idx="1">
+            <a:schemeClr val="accent1"/>
+          </a:lnRef>
+          <a:fillRef idx="3">
+            <a:schemeClr val="accent1"/>
+          </a:fillRef>
+          <a:effectRef idx="2">
+            <a:schemeClr val="accent1"/>
+          </a:effectRef>
+          <a:fontRef idx="minor">
+            <a:schemeClr val="lt1"/>
+          </a:fontRef>
+        </p:style>
+        <p:txBody>
+          <a:bodyPr rtlCol="0" anchor="ctr" wrap="square" lIns="109728" rIns="109728"/>
+          <a:lstStyle/>
+          <a:p>
+            <a:pPr algn="ctr"/>
+            <a:r>
+              <a:rPr sz="1100" b="1">
+                <a:solidFill>
+                  <a:srgbClr val="000000"/>
+                </a:solidFill>
+                <a:latin typeface="Calibri"/>
+              </a:rPr>
+              <a:t>ORDER — rig-test what's built → confirm the 3 facts → wire the remaining modes → edge-width Poisson (after the backdrop) → UX layer.</a:t>
+            </a:r>
+          </a:p>
+        </p:txBody>
+      </p:sp>
+      <p:sp>
+        <p:nvSpPr>
+          <p:cNvPr id="18" name="TextBox 17"/>
+          <p:cNvSpPr txBox="1"/>
+          <p:nvPr/>
+        </p:nvSpPr>
+        <p:spPr>
+          <a:xfrm>
+            <a:off x="457200" y="6446520"/>
+            <a:ext cx="640080" cy="274320"/>
+          </a:xfrm>
+          <a:prstGeom prst="rect">
+            <a:avLst/>
+          </a:prstGeom>
+          <a:noFill/>
+        </p:spPr>
+        <p:txBody>
+          <a:bodyPr wrap="square" lIns="45720" rIns="45720" tIns="18288" bIns="18288" anchor="t">
+            <a:spAutoFit/>
+          </a:bodyPr>
+          <a:lstStyle/>
+          <a:p>
+            <a:pPr algn="l"/>
+            <a:r>
+              <a:rPr sz="1000" b="0" i="0">
+                <a:solidFill>
+                  <a:srgbClr val="707070"/>
+                </a:solidFill>
+                <a:latin typeface="Calibri"/>
+              </a:rPr>
+              <a:t>168</a:t>
             </a:r>
           </a:p>
         </p:txBody>

</xml_diff>

<commit_message>
Document innovation roadmap — ROADMAP.md + refreshed V6a deck slides 165-168
Testing phase complete, so the roadmap is updated from "built, awaiting rig test"
to the validated state:
- NEW Software/UTM_PyQt6/ROADMAP.md — living source of truth (done / partial /
  planned / hardware-blocked) with per-feature validation evidence.
- V6a deck slides 165-168 regenerated: Phase A + strain-rate now DONE+VALIDATED,
  slide 167 flipped to "VALIDATED ON THE RIG" with pass results, 3 rig facts
  resolved, motor ~2.6 kN torque-ceiling hardware limit called out.

Co-Authored-By: Claude Opus 4.8 <noreply@anthropic.com>
</commit_message>
<xml_diff>
--- a/V6a_8_6_20_slides.pptx
+++ b/V6a_8_6_20_slides.pptx
@@ -17558,7 +17558,7 @@
                 </a:solidFill>
                 <a:latin typeface="Calibri"/>
               </a:rPr>
-              <a:t>The rig automated only ONE thing (auto-preload). A phased roadmap adds automated test modes, smart DIC and one-click analysis — each piece shippable on its own. Where it stands today:</a:t>
+              <a:t>The rig automated only ONE thing (auto-preload). A phased roadmap adds automated test modes, smart DIC and one-click analysis — each piece shippable on its own. After the full rig-test campaign:</a:t>
             </a:r>
           </a:p>
         </p:txBody>
@@ -17772,7 +17772,70 @@
                           </a:solidFill>
                           <a:latin typeface="Calibri"/>
                         </a:rPr>
-                        <a:t>BUILT — rig-test</a:t>
+                        <a:t>DONE — VALIDATED</a:t>
+                      </a:r>
+                    </a:p>
+                  </a:txBody>
+                  <a:tcPr>
+                    <a:solidFill>
+                      <a:srgbClr val="C8E6C9"/>
+                    </a:solidFill>
+                  </a:tcPr>
+                </a:tc>
+              </a:tr>
+              <a:tr h="419100">
+                <a:tc>
+                  <a:txBody>
+                    <a:bodyPr lIns="54864" rIns="54864" tIns="18288" bIns="18288" wrap="square" anchor="ctr"/>
+                    <a:lstStyle/>
+                    <a:p>
+                      <a:pPr algn="l"/>
+                      <a:r>
+                        <a:rPr sz="1050" b="0">
+                          <a:solidFill>
+                            <a:srgbClr val="000000"/>
+                          </a:solidFill>
+                          <a:latin typeface="Calibri"/>
+                        </a:rPr>
+                        <a:t>B · Closed-loop modes</a:t>
+                      </a:r>
+                    </a:p>
+                  </a:txBody>
+                  <a:tcPr/>
+                </a:tc>
+                <a:tc>
+                  <a:txBody>
+                    <a:bodyPr lIns="54864" rIns="54864" tIns="18288" bIns="18288" wrap="square" anchor="ctr"/>
+                    <a:lstStyle/>
+                    <a:p>
+                      <a:pPr algn="l"/>
+                      <a:r>
+                        <a:rPr sz="1050" b="0">
+                          <a:solidFill>
+                            <a:srgbClr val="000000"/>
+                          </a:solidFill>
+                          <a:latin typeface="Calibri"/>
+                        </a:rPr>
+                        <a:t>strain-rate + cyclic / staircase / relaxation / creep</a:t>
+                      </a:r>
+                    </a:p>
+                  </a:txBody>
+                  <a:tcPr/>
+                </a:tc>
+                <a:tc>
+                  <a:txBody>
+                    <a:bodyPr lIns="54864" rIns="54864" tIns="18288" bIns="18288" wrap="square" anchor="ctr"/>
+                    <a:lstStyle/>
+                    <a:p>
+                      <a:pPr algn="l"/>
+                      <a:r>
+                        <a:rPr sz="1050" b="1">
+                          <a:solidFill>
+                            <a:srgbClr val="000000"/>
+                          </a:solidFill>
+                          <a:latin typeface="Calibri"/>
+                        </a:rPr>
+                        <a:t>strain-rate DONE · 4 to wire</a:t>
                       </a:r>
                     </a:p>
                   </a:txBody>
@@ -17797,7 +17860,7 @@
                           </a:solidFill>
                           <a:latin typeface="Calibri"/>
                         </a:rPr>
-                        <a:t>B · Closed-loop modes</a:t>
+                        <a:t>C · Smart DIC</a:t>
                       </a:r>
                     </a:p>
                   </a:txBody>
@@ -17816,7 +17879,7 @@
                           </a:solidFill>
                           <a:latin typeface="Calibri"/>
                         </a:rPr>
-                        <a:t>strain-rate + cyclic / staircase / relaxation / creep</a:t>
+                        <a:t>live health HUD + measured Poisson / true Cauchy</a:t>
                       </a:r>
                     </a:p>
                   </a:txBody>
@@ -17835,70 +17898,7 @@
                           </a:solidFill>
                           <a:latin typeface="Calibri"/>
                         </a:rPr>
-                        <a:t>1 of 5 wired</a:t>
-                      </a:r>
-                    </a:p>
-                  </a:txBody>
-                  <a:tcPr>
-                    <a:solidFill>
-                      <a:srgbClr val="FFF3CD"/>
-                    </a:solidFill>
-                  </a:tcPr>
-                </a:tc>
-              </a:tr>
-              <a:tr h="419100">
-                <a:tc>
-                  <a:txBody>
-                    <a:bodyPr lIns="54864" rIns="54864" tIns="18288" bIns="18288" wrap="square" anchor="ctr"/>
-                    <a:lstStyle/>
-                    <a:p>
-                      <a:pPr algn="l"/>
-                      <a:r>
-                        <a:rPr sz="1050" b="0">
-                          <a:solidFill>
-                            <a:srgbClr val="000000"/>
-                          </a:solidFill>
-                          <a:latin typeface="Calibri"/>
-                        </a:rPr>
-                        <a:t>C · Smart DIC</a:t>
-                      </a:r>
-                    </a:p>
-                  </a:txBody>
-                  <a:tcPr/>
-                </a:tc>
-                <a:tc>
-                  <a:txBody>
-                    <a:bodyPr lIns="54864" rIns="54864" tIns="18288" bIns="18288" wrap="square" anchor="ctr"/>
-                    <a:lstStyle/>
-                    <a:p>
-                      <a:pPr algn="l"/>
-                      <a:r>
-                        <a:rPr sz="1050" b="0">
-                          <a:solidFill>
-                            <a:srgbClr val="000000"/>
-                          </a:solidFill>
-                          <a:latin typeface="Calibri"/>
-                        </a:rPr>
-                        <a:t>live health HUD + measured Poisson / true Cauchy</a:t>
-                      </a:r>
-                    </a:p>
-                  </a:txBody>
-                  <a:tcPr/>
-                </a:tc>
-                <a:tc>
-                  <a:txBody>
-                    <a:bodyPr lIns="54864" rIns="54864" tIns="18288" bIns="18288" wrap="square" anchor="ctr"/>
-                    <a:lstStyle/>
-                    <a:p>
-                      <a:pPr algn="l"/>
-                      <a:r>
-                        <a:rPr sz="1050" b="1">
-                          <a:solidFill>
-                            <a:srgbClr val="000000"/>
-                          </a:solidFill>
-                          <a:latin typeface="Calibri"/>
-                        </a:rPr>
-                        <a:t>HUD done</a:t>
+                        <a:t>HUD DONE · Poisson next</a:t>
                       </a:r>
                     </a:p>
                   </a:txBody>
@@ -18087,7 +18087,7 @@
                 </a:solidFill>
                 <a:latin typeface="Calibri"/>
               </a:rPr>
-              <a:t>6</a:t>
+              <a:t>9</a:t>
             </a:r>
           </a:p>
           <a:p>
@@ -18215,7 +18215,7 @@
                 </a:solidFill>
                 <a:latin typeface="Calibri"/>
               </a:rPr>
-              <a:t>6</a:t>
+              <a:t>6 / 6</a:t>
             </a:r>
           </a:p>
           <a:p>
@@ -18227,7 +18227,7 @@
                 </a:solidFill>
                 <a:latin typeface="Calibri"/>
               </a:rPr>
-              <a:t>TO RIG-TEST</a:t>
+              <a:t>RIG TESTS PASSED</a:t>
             </a:r>
           </a:p>
         </p:txBody>
@@ -18279,7 +18279,7 @@
                 </a:solidFill>
                 <a:latin typeface="Calibri"/>
               </a:rPr>
-              <a:t>LEGEND — DONE (green) · BUILT, awaiting rig test (amber) · PLANNED (grey).  Foundations + the one-click workflow have shipped; closed-loop modes and smart-DIC are partly in; the UX layer is next.</a:t>
+              <a:t>LEGEND — DONE + rig-validated (green) · partial, more to wire (amber) · PLANNED (grey).  Foundations, the one-click workflow and the strain-rate fracture test are validated on the rig; the remaining modes, measured Poisson and the UX layer are next.</a:t>
             </a:r>
           </a:p>
         </p:txBody>
@@ -18314,7 +18314,7 @@
                 </a:solidFill>
                 <a:latin typeface="Calibri"/>
               </a:rPr>
-              <a:t>All analysis logic is unit-tested / sim-validated offline; app features live in the (unversioned) main.py and follow the proven auto-preload safety discipline.</a:t>
+              <a:t>All analysis logic is unit-tested / sim-validated offline; the app feature set is now snapshot-committed (main.py a3b187f) after the full rig-test campaign — see ROADMAP.md / TESTING_TODO.md.</a:t>
             </a:r>
           </a:p>
         </p:txBody>
@@ -18899,7 +18899,7 @@
                 </a:solidFill>
                 <a:latin typeface="Calibri"/>
               </a:rPr>
-              <a:t>In the UI (main.py — awaiting rig test)</a:t>
+              <a:t>In the UI (main.py — RIG-VALIDATED · snapshot a3b187f)</a:t>
             </a:r>
           </a:p>
         </p:txBody>
@@ -18935,12 +18935,12 @@
                 <a:latin typeface="Calibri"/>
               </a:rPr>
               <a:t>•  Generate report  — one button → PDF + images
-•  Recipe dropdown  — Load / Save a test setup
+•  Settings  — Load / Save a setup (+ Default)
 •  Prepare specimen  — 1-click tare (position + force + DIC)
-•  Auto-stop at fracture  — halts on load collapse
-•  Strain-rate mode (BETA)  — closed-loop dε/dt
+•  Fracture test / Auto-stop  — halts on load collapse
+•  Strain-rate fracture test  — closed-loop dε/dt
 •  DIC health HUD  — live OK / WARN / BAD badge
-•  Safety net  — 10 kN force / 45 mm travel / 900 s cap</a:t>
+•  Safety net  — 10 kN / 30 mm / stall guard / dead-DIC</a:t>
             </a:r>
           </a:p>
         </p:txBody>
@@ -18975,7 +18975,7 @@
                 </a:solidFill>
                 <a:latin typeface="Calibri"/>
               </a:rPr>
-              <a:t>Modules committed &amp; regression-checked against the deck numbers; the UI wiring stays in the unversioned main.py and will be snapshot-committed once validated on the rig.</a:t>
+              <a:t>Modules committed &amp; regression-checked against the deck numbers; the UI feature set is now snapshot-committed (main.py a3b187f) after full rig validation.</a:t>
             </a:r>
           </a:p>
         </p:txBody>
@@ -19141,7 +19141,7 @@
                 </a:solidFill>
                 <a:latin typeface="Calibri Light"/>
               </a:rPr>
-              <a:t>TO BE TESTED — ON THE RIG / CAMERA</a:t>
+              <a:t>VALIDATED ON THE RIG  (2026-07-28 / 29)</a:t>
             </a:r>
           </a:p>
         </p:txBody>
@@ -19176,7 +19176,7 @@
                 </a:solidFill>
                 <a:latin typeface="Calibri"/>
               </a:rPr>
-              <a:t>Feature checks (needs motor + camera)</a:t>
+              <a:t>Feature checks — ALL PASSED</a:t>
             </a:r>
           </a:p>
         </p:txBody>
@@ -19240,7 +19240,7 @@
                           </a:solidFill>
                           <a:latin typeface="Calibri"/>
                         </a:rPr>
-                        <a:t>Pass =</a:t>
+                        <a:t>Result</a:t>
                       </a:r>
                     </a:p>
                   </a:txBody>
@@ -19284,7 +19284,7 @@
                           </a:solidFill>
                           <a:latin typeface="Calibri"/>
                         </a:rPr>
-                        <a:t>camera on → green 2/2; cover a dot → red BAD</a:t>
+                        <a:t>green 2/2 live; red BAD on dot cover  ✓</a:t>
                       </a:r>
                     </a:p>
                   </a:txBody>
@@ -19324,7 +19324,7 @@
                           </a:solidFill>
                           <a:latin typeface="Calibri"/>
                         </a:rPr>
-                        <a:t>one click → position + force + DIC all tared</a:t>
+                        <a:t>1 click → position + force + DIC tared  ✓</a:t>
                       </a:r>
                     </a:p>
                   </a:txBody>
@@ -19364,7 +19364,7 @@
                           </a:solidFill>
                           <a:latin typeface="Calibri"/>
                         </a:rPr>
-                        <a:t>scrap pull → Stop right at the load collapse</a:t>
+                        <a:t>caught S16 collapse 2992 → −417 N  ✓</a:t>
                       </a:r>
                     </a:p>
                   </a:txBody>
@@ -19385,7 +19385,7 @@
                           </a:solidFill>
                           <a:latin typeface="Calibri"/>
                         </a:rPr>
-                        <a:t>Recipes</a:t>
+                        <a:t>Settings</a:t>
                       </a:r>
                     </a:p>
                   </a:txBody>
@@ -19404,7 +19404,7 @@
                           </a:solidFill>
                           <a:latin typeface="Calibri"/>
                         </a:rPr>
-                        <a:t>load a starter → inputs change; Save → in list</a:t>
+                        <a:t>Default + Load / Save round-trip  ✓</a:t>
                       </a:r>
                     </a:p>
                   </a:txBody>
@@ -19444,7 +19444,7 @@
                           </a:solidFill>
                           <a:latin typeface="Calibri"/>
                         </a:rPr>
-                        <a:t>after a test → PDF + PNG land in /reports</a:t>
+                        <a:t>S16 report = CSV, every KPI  ✓</a:t>
                       </a:r>
                     </a:p>
                   </a:txBody>
@@ -19465,7 +19465,7 @@
                           </a:solidFill>
                           <a:latin typeface="Calibri"/>
                         </a:rPr>
-                        <a:t>Strain-rate (BETA)</a:t>
+                        <a:t>Strain-rate fracture</a:t>
                       </a:r>
                     </a:p>
                   </a:txBody>
@@ -19484,7 +19484,7 @@
                           </a:solidFill>
                           <a:latin typeface="Calibri"/>
                         </a:rPr>
-                        <a:t>scrap pull → holds dε/dt; stops at target / break</a:t>
+                        <a:t>held 0.0005/s → fracture, auto-stop  ✓</a:t>
                       </a:r>
                     </a:p>
                   </a:txBody>
@@ -19525,7 +19525,7 @@
                 </a:solidFill>
                 <a:latin typeface="Calibri"/>
               </a:rPr>
-              <a:t>Rig facts to report back</a:t>
+              <a:t>Rig facts — ALL RESOLVED</a:t>
             </a:r>
           </a:p>
         </p:txBody>
@@ -19561,12 +19561,13 @@
                 <a:latin typeface="Calibri"/>
               </a:rPr>
               <a:t>These unblock the other 4 test modes:
-1.  Does SetSpeed 0 HOLD the motor still?
-     (dwell — staircase / relaxation)
-2.  Clean reversal sequence — Stop → SetSpeed
-     → direction?  (cyclic / creep)
-3.  Usable crosshead stroke (mm)?
-     (finalise the 45 mm travel cap)</a:t>
+1.  Stop HOLDS position ✓
+     (zero drift over 5 / 10 / 15 s)
+2.  Direct reversal auto-decels ~1 s ✓
+     (no manual Stop needed)
+3.  Travel cap set to 30 mm ✓
+→  cyclic / staircase / relaxation / creep
+     are now UNBLOCKED to wire.</a:t>
             </a:r>
           </a:p>
         </p:txBody>
@@ -19586,7 +19587,7 @@
             <a:avLst/>
           </a:prstGeom>
           <a:solidFill>
-            <a:srgbClr val="FFF3CD"/>
+            <a:srgbClr val="C8E6C9"/>
           </a:solidFill>
           <a:ln>
             <a:noFill/>
@@ -19618,7 +19619,7 @@
                 </a:solidFill>
                 <a:latin typeface="Calibri"/>
               </a:rPr>
-              <a:t>SAFETY — Auto-stop and Strain-rate drive the motor: run them first on a SCRAP specimen with a hand near E-Stop. Everything else is read-only. Full step-by-step list: Software/UTM_PyQt6/TESTING_TODO.md</a:t>
+              <a:t>RESULT — every built feature passed on the rig; S16 = first 100% infill fracture (UTS 47.4 MPa, anchor-corrected). Strain-rate 6.2 held the target rate by adapting crosshead speed 0.10 → 0.05 mm/s. ONE hardware limit found — motor torque ceiling ~2.6 kN (next slide).</a:t>
             </a:r>
           </a:p>
         </p:txBody>
@@ -19653,7 +19654,7 @@
                 </a:solidFill>
                 <a:latin typeface="Calibri"/>
               </a:rPr>
-              <a:t>Logic is already sim/offline-validated — these runs confirm behaviour on real hardware and set the tunable thresholds (fracture arm 30% / collapse 50%, travel cap).</a:t>
+              <a:t>Full step-by-step results: Software/UTM_PyQt6/TESTING_TODO.md; thresholds confirmed (fracture arm 30% / collapse 50%, travel cap 30 mm, stall guard 0.05 mm / 6 s).</a:t>
             </a:r>
           </a:p>
         </p:txBody>
@@ -20292,10 +20293,10 @@
                 <a:latin typeface="Calibri"/>
               </a:rPr>
               <a:t>•  Cyclic / staircase / relaxation / creep modes
-    (engine ready — needs the 3 rig facts)
-•  Full 'Run to fracture' — one button:
-    preload → pull → auto-halt → anchor → save
-•  Auto specimen metadata + folder from recipe</a:t>
+    (engine ready — rig facts RESOLVED, ready to wire)
+•  Measured Poisson — 4-marker / edge-width
+    + auto specimen metadata + folder from recipe
+•  One-click per-specimen report deck</a:t>
             </a:r>
           </a:p>
         </p:txBody>
@@ -20353,7 +20354,7 @@
             <a:avLst/>
           </a:prstGeom>
           <a:solidFill>
-            <a:srgbClr val="E7F1F8"/>
+            <a:srgbClr val="FFF3CD"/>
           </a:solidFill>
           <a:ln>
             <a:noFill/>
@@ -20379,13 +20380,13 @@
           <a:p>
             <a:pPr algn="ctr"/>
             <a:r>
-              <a:rPr sz="1100" b="1">
+              <a:rPr sz="1050" b="1">
                 <a:solidFill>
                   <a:srgbClr val="000000"/>
                 </a:solidFill>
                 <a:latin typeface="Calibri"/>
               </a:rPr>
-              <a:t>ORDER — rig-test what's built → confirm the 3 facts → wire the remaining modes → edge-width Poisson (after the backdrop) → UX layer.</a:t>
+              <a:t>HARDWARE LIMIT — motor torque ceiling ~2.6 kN (variable; driver Vref / thermal / PSU) blocks 100% full-area fracture; use 50% / smaller specimens until resolved.   ORDER — wire remaining modes → edge-width Poisson → UX layer.</a:t>
             </a:r>
           </a:p>
         </p:txBody>

</xml_diff>